<commit_message>
Redesign slide 4 — LLM-themed event calendar (Qwen, GPT-5, Claude, Gemini, Llama, Multi-Model)
</commit_message>
<xml_diff>
--- a/public/AI-Salon-TelAviv-AliExpress-Sponsorship-Proposal.pptx
+++ b/public/AI-Salon-TelAviv-AliExpress-Sponsorship-Proposal.pptx
@@ -882,11 +882,11 @@
             <a:r>
               <a:rPr lang="en-US" dirty="0"/>
               <a:t>Speaker notes:
-- The timeline shows the rhythm: 6 flagship events anchor the year, with always-on digital channels in between.
-- Cadence is bi-monthly — M2, M4, M6, M8, M10, M12 — so AliExpress is continuously visible to the community, not just at events.
-- Each event has a distinct theme (Opening Keynote, AI Insight Forum, Community Connect, Builder Showcase, Global Bridge, Year-Cap Summit) to keep the audience engaged.
-- Always-on digital layer = 12 monthly email blasts + 24 bi-monthly WhatsApp updates.
-- $12K value-equivalent per flagship activation — emphasize the predictability and rhythm of the plan.</a:t>
+- Open with the strategic positioning: every bi-monthly event is themed around a frontier LLM, so each one has a clear hook and a clear reason for the audience to attend.
+- The M2 Qwen flagship is the anchor — AliExpress's in-house LLM is the natural opener, demonstrating retail-commerce at scale and giving the community early API access. This positions AliExpress as a serious AI player, not just a marketplace.
+- Walk through the model lineup: GPT-5 reasoning, Claude's 200K context + agentic dev tools, Gemini multimodal, Llama open-source fine-tuning, and the M12 multi-model year-cap summit.
+- Emphasize the early-access layer: every event pairs the technical deep-dive with concrete perks — API credits, preview access, fine-tuning compute. $32K+ in community value over the year.
+- Close with the rhythm: 6 flagship events + 12 monthly email blasts + 24 WhatsApp community drops = continuous visibility for AliExpress, never just one-off moments.</a:t>
             </a:r>
             <a:endParaRPr lang="en-US" dirty="0"/>
           </a:p>
@@ -2060,7 +2060,7 @@
       </p:sp>
       <p:pic>
         <p:nvPicPr>
-          <p:cNvPr id="11" name="Image 2" descr="/tmp/h2p-fit-1788185035541-wnj5wb.png">    </p:cNvPr>
+          <p:cNvPr id="11" name="Image 2" descr="/tmp/h2p-fit-1788201349274-djtvr4.png">    </p:cNvPr>
           <p:cNvPicPr>
             <a:picLocks noChangeAspect="1"/>
           </p:cNvPicPr>
@@ -5888,27 +5888,29 @@
         </p:nvSpPr>
         <p:spPr>
           <a:xfrm>
-            <a:off x="457200" y="400050"/>
-            <a:ext cx="8636000" cy="164592"/>
-          </a:xfrm>
-          <a:prstGeom prst="rect">
-            <a:avLst/>
-          </a:prstGeom>
-          <a:noFill/>
-          <a:ln/>
-        </p:spPr>
-        <p:txBody>
-          <a:bodyPr wrap="square" lIns="0" tIns="0" rIns="0" bIns="0" rtlCol="0" anchor="t"/>
-          <a:lstStyle/>
-          <a:p>
-            <a:pPr algn="l" indent="0" marL="0">
-              <a:lnSpc>
-                <a:spcPts val="1013"/>
-              </a:lnSpc>
-              <a:buNone/>
-            </a:pPr>
-            <a:r>
-              <a:rPr lang="en-US" sz="800" b="1" spc="203" kern="0" dirty="0">
+            <a:off x="400050" y="257175"/>
+            <a:ext cx="8636000" cy="133302"/>
+          </a:xfrm>
+          <a:prstGeom prst="rect">
+            <a:avLst/>
+          </a:prstGeom>
+          <a:noFill/>
+          <a:ln/>
+        </p:spPr>
+        <p:txBody>
+          <a:bodyPr wrap="square" lIns="0" tIns="0" rIns="0" bIns="0" rtlCol="0" anchor="t">
+            <a:normAutofit/>
+          </a:bodyPr>
+          <a:lstStyle/>
+          <a:p>
+            <a:pPr algn="l" indent="0" marL="0">
+              <a:lnSpc>
+                <a:spcPts val="928"/>
+              </a:lnSpc>
+              <a:buNone/>
+            </a:pPr>
+            <a:r>
+              <a:rPr lang="en-US" sz="800" b="1" spc="186" kern="0" dirty="0">
                 <a:solidFill>
                   <a:srgbClr val="00E6FF"/>
                 </a:solidFill>
@@ -5916,7 +5918,7 @@
                 <a:ea typeface="Liberation Sans Narrow" pitchFamily="34" charset="-122"/>
                 <a:cs typeface="Liberation Sans Narrow" pitchFamily="34" charset="-120"/>
               </a:rPr>
-              <a:t>12-MONTH ACTIVATION CALENDAR</a:t>
+              <a:t>12-MONTH LLM ACTIVATION CALENDAR</a:t>
             </a:r>
             <a:endParaRPr lang="en-US" sz="800" dirty="0"/>
           </a:p>
@@ -5930,8 +5932,8 @@
         </p:nvSpPr>
         <p:spPr>
           <a:xfrm>
-            <a:off x="457200" y="600075"/>
-            <a:ext cx="8636000" cy="324041"/>
+            <a:off x="400050" y="417909"/>
+            <a:ext cx="8636000" cy="275338"/>
           </a:xfrm>
           <a:prstGeom prst="rect">
             <a:avLst/>
@@ -5945,12 +5947,12 @@
           <a:p>
             <a:pPr algn="l" indent="0" marL="0">
               <a:lnSpc>
-                <a:spcPts val="2363"/>
-              </a:lnSpc>
-              <a:buNone/>
-            </a:pPr>
-            <a:r>
-              <a:rPr lang="en-US" sz="2250" b="1" spc="-45" kern="0" dirty="0">
+                <a:spcPts val="2008"/>
+              </a:lnSpc>
+              <a:buNone/>
+            </a:pPr>
+            <a:r>
+              <a:rPr lang="en-US" sz="1913" b="1" spc="-38" kern="0" dirty="0">
                 <a:solidFill>
                   <a:srgbClr val="000000"/>
                 </a:solidFill>
@@ -5958,9 +5960,9 @@
                 <a:ea typeface="Carlito" pitchFamily="34" charset="-122"/>
                 <a:cs typeface="Carlito" pitchFamily="34" charset="-120"/>
               </a:rPr>
-              <a:t>Six flagship events, always-on digital</a:t>
-            </a:r>
-            <a:endParaRPr lang="en-US" sz="2250" dirty="0"/>
+              <a:t>Six flagship events, each anchored by a frontier LLM</a:t>
+            </a:r>
+            <a:endParaRPr lang="en-US" sz="1913" dirty="0"/>
           </a:p>
         </p:txBody>
       </p:sp>
@@ -5972,8 +5974,8 @@
         </p:nvSpPr>
         <p:spPr>
           <a:xfrm>
-            <a:off x="457200" y="985838"/>
-            <a:ext cx="5715000" cy="370332"/>
+            <a:off x="400050" y="730002"/>
+            <a:ext cx="5429250" cy="477159"/>
           </a:xfrm>
           <a:prstGeom prst="rect">
             <a:avLst/>
@@ -5987,12 +5989,12 @@
           <a:p>
             <a:pPr algn="l" indent="0" marL="0">
               <a:lnSpc>
-                <a:spcPts val="1350"/>
-              </a:lnSpc>
-              <a:buNone/>
-            </a:pPr>
-            <a:r>
-              <a:rPr lang="en-US" sz="900" dirty="0">
+                <a:spcPts val="1060"/>
+              </a:lnSpc>
+              <a:buNone/>
+            </a:pPr>
+            <a:r>
+              <a:rPr lang="en-US" sz="800" dirty="0">
                 <a:solidFill>
                   <a:srgbClr val="6B6B6B"/>
                 </a:solidFill>
@@ -6000,9 +6002,9 @@
                 <a:ea typeface="Carlito" pitchFamily="34" charset="-122"/>
                 <a:cs typeface="Carlito" pitchFamily="34" charset="-120"/>
               </a:rPr>
-              <a:t>Bi-monthly flagship events anchor the partnership. Between events: monthly email blasts + bi-monthly WhatsApp updates keep AliExpress continuously visible.</a:t>
-            </a:r>
-            <a:endParaRPr lang="en-US" sz="900" dirty="0"/>
+              <a:t>Bi-monthly flagship events themed around the world's leading AI models. AliExpress opens the Qwen flagship in Month 2 — its in-house retail-commerce LLM — and closes the year hosting a multi-model summit. Every event pairs a technical deep-dive with early-access benefits for the AI Salon TLV community.</a:t>
+            </a:r>
+            <a:endParaRPr lang="en-US" sz="800" dirty="0"/>
           </a:p>
         </p:txBody>
       </p:sp>
@@ -6014,15 +6016,110 @@
         </p:nvSpPr>
         <p:spPr>
           <a:xfrm>
-            <a:off x="460772" y="1432322"/>
-            <a:ext cx="2259992" cy="210741"/>
+            <a:off x="407194" y="1241003"/>
+            <a:ext cx="2709825" cy="1514475"/>
           </a:xfrm>
           <a:prstGeom prst="roundRect">
             <a:avLst>
-              <a:gd name="adj" fmla="val 4515246"/>
+              <a:gd name="adj" fmla="val 3774"/>
             </a:avLst>
           </a:prstGeom>
-          <a:noFill/>
+          <a:solidFill>
+            <a:srgbClr val="FFFFFF"/>
+          </a:solidFill>
+          <a:ln w="14288">
+            <a:solidFill>
+              <a:srgbClr val="FF005A"/>
+            </a:solidFill>
+            <a:prstDash val="solid"/>
+          </a:ln>
+        </p:spPr>
+        <p:txBody>
+          <a:bodyPr wrap="square" rtlCol="0" anchor="ctr"/>
+          <a:lstStyle/>
+          <a:p>
+            <a:pPr indent="0" marL="0">
+              <a:buNone/>
+            </a:pPr>
+            <a:endParaRPr lang="en-US" dirty="0"/>
+          </a:p>
+        </p:txBody>
+      </p:sp>
+      <p:sp>
+        <p:nvSpPr>
+          <p:cNvPr id="6" name="Text 4"/>
+          <p:cNvSpPr/>
+          <p:nvPr/>
+        </p:nvSpPr>
+        <p:spPr>
+          <a:xfrm>
+            <a:off x="414338" y="1248147"/>
+            <a:ext cx="2695538" cy="532433"/>
+          </a:xfrm>
+          <a:prstGeom prst="rect">
+            <a:avLst/>
+          </a:prstGeom>
+          <a:solidFill>
+            <a:srgbClr val="1A1A1A"/>
+          </a:solidFill>
+          <a:ln/>
+        </p:spPr>
+        <p:txBody>
+          <a:bodyPr wrap="square" rtlCol="0" anchor="ctr"/>
+          <a:lstStyle/>
+          <a:p>
+            <a:pPr indent="0" marL="0">
+              <a:buNone/>
+            </a:pPr>
+            <a:endParaRPr lang="en-US" dirty="0"/>
+          </a:p>
+        </p:txBody>
+      </p:sp>
+      <p:pic>
+        <p:nvPicPr>
+          <p:cNvPr id="7" name="Image 0" descr="/tmp/h2p-fit-1788201353088-lt6j5d.png">    </p:cNvPr>
+          <p:cNvPicPr>
+            <a:picLocks noChangeAspect="1"/>
+          </p:cNvPicPr>
+          <p:nvPr/>
+        </p:nvPicPr>
+        <p:blipFill>
+          <a:blip r:embed="rId1"/>
+          <a:stretch>
+            <a:fillRect/>
+          </a:stretch>
+        </p:blipFill>
+        <p:spPr>
+          <a:xfrm>
+            <a:off x="414338" y="1248147"/>
+            <a:ext cx="2695538" cy="532433"/>
+          </a:xfrm>
+          <a:prstGeom prst="rect">
+            <a:avLst/>
+          </a:prstGeom>
+        </p:spPr>
+      </p:pic>
+      <p:sp>
+        <p:nvSpPr>
+          <p:cNvPr id="8" name="Text 5"/>
+          <p:cNvSpPr/>
+          <p:nvPr/>
+        </p:nvSpPr>
+        <p:spPr>
+          <a:xfrm>
+            <a:off x="491490" y="1856446"/>
+            <a:ext cx="970278" cy="184023"/>
+          </a:xfrm>
+          <a:prstGeom prst="roundRect">
+            <a:avLst>
+              <a:gd name="adj" fmla="val 5170807"/>
+            </a:avLst>
+          </a:prstGeom>
+          <a:solidFill>
+            <a:srgbClr val="FF005A">
+              <a:alpha val="8000"/>
+            </a:srgbClr>
+          </a:solidFill>
           <a:ln w="7144">
             <a:solidFill>
               <a:srgbClr val="FF005A"/>
@@ -6043,56 +6140,56 @@
       </p:sp>
       <p:sp>
         <p:nvSpPr>
-          <p:cNvPr id="6" name="Text 4"/>
-          <p:cNvSpPr/>
-          <p:nvPr/>
-        </p:nvSpPr>
-        <p:spPr>
-          <a:xfrm>
-            <a:off x="707231" y="1485900"/>
-            <a:ext cx="1924236" cy="129679"/>
-          </a:xfrm>
-          <a:prstGeom prst="rect">
-            <a:avLst/>
-          </a:prstGeom>
-          <a:noFill/>
-          <a:ln/>
-        </p:spPr>
-        <p:txBody>
-          <a:bodyPr wrap="none" lIns="85725" tIns="42863" rIns="85725" bIns="42863" rtlCol="0" anchor="t"/>
-          <a:lstStyle/>
-          <a:p>
-            <a:pPr algn="l" indent="0" marL="0">
-              <a:lnSpc>
-                <a:spcPts val="928"/>
-              </a:lnSpc>
-              <a:buNone/>
-            </a:pPr>
-            <a:r>
-              <a:rPr lang="en-US" sz="800" b="1" spc="111" kern="0" dirty="0">
+          <p:cNvPr id="9" name="Text 6"/>
+          <p:cNvSpPr/>
+          <p:nvPr/>
+        </p:nvSpPr>
+        <p:spPr>
+          <a:xfrm>
+            <a:off x="692944" y="1909167"/>
+            <a:ext cx="681670" cy="120701"/>
+          </a:xfrm>
+          <a:prstGeom prst="rect">
+            <a:avLst/>
+          </a:prstGeom>
+          <a:noFill/>
+          <a:ln/>
+        </p:spPr>
+        <p:txBody>
+          <a:bodyPr wrap="none" lIns="0" tIns="0" rIns="0" bIns="0" rtlCol="0" anchor="t"/>
+          <a:lstStyle/>
+          <a:p>
+            <a:pPr algn="l" indent="0" marL="0">
+              <a:lnSpc>
+                <a:spcPts val="844"/>
+              </a:lnSpc>
+              <a:buNone/>
+            </a:pPr>
+            <a:r>
+              <a:rPr lang="en-US" sz="600" b="1" spc="68" kern="0" dirty="0">
                 <a:solidFill>
                   <a:srgbClr val="FF005A"/>
                 </a:solidFill>
-                <a:latin typeface="Liberation Sans Narrow" pitchFamily="34" charset="0"/>
-                <a:ea typeface="Liberation Sans Narrow" pitchFamily="34" charset="-122"/>
-                <a:cs typeface="Liberation Sans Narrow" pitchFamily="34" charset="-120"/>
-              </a:rPr>
-              <a:t>BI-MONTHLY CADENCE · M2 → M12</a:t>
-            </a:r>
-            <a:endParaRPr lang="en-US" sz="800" dirty="0"/>
-          </a:p>
-        </p:txBody>
-      </p:sp>
-      <p:sp>
-        <p:nvSpPr>
-          <p:cNvPr id="7" name="Text 5"/>
-          <p:cNvSpPr/>
-          <p:nvPr/>
-        </p:nvSpPr>
-        <p:spPr>
-          <a:xfrm>
-            <a:off x="550069" y="1487686"/>
-            <a:ext cx="100013" cy="100013"/>
+                <a:latin typeface="Carlito" pitchFamily="34" charset="0"/>
+                <a:ea typeface="Carlito" pitchFamily="34" charset="-122"/>
+                <a:cs typeface="Carlito" pitchFamily="34" charset="-120"/>
+              </a:rPr>
+              <a:t>EARLY ACCESS</a:t>
+            </a:r>
+            <a:endParaRPr lang="en-US" sz="600" dirty="0"/>
+          </a:p>
+        </p:txBody>
+      </p:sp>
+      <p:sp>
+        <p:nvSpPr>
+          <p:cNvPr id="10" name="Text 7"/>
+          <p:cNvSpPr/>
+          <p:nvPr/>
+        </p:nvSpPr>
+        <p:spPr>
+          <a:xfrm>
+            <a:off x="578644" y="1909167"/>
+            <a:ext cx="91440" cy="91440"/>
           </a:xfrm>
           <a:prstGeom prst="rect">
             <a:avLst/>
@@ -6108,7 +6205,7 @@
               <a:buNone/>
             </a:pPr>
             <a:r>
-              <a:rPr lang="en-US" sz="984" dirty="0">
+              <a:rPr lang="en-US" sz="800" dirty="0">
                 <a:solidFill>
                   <a:srgbClr val="FF005A"/>
                 </a:solidFill>
@@ -6116,78 +6213,53 @@
                 <a:ea typeface="Segoe UI Symbol" pitchFamily="34" charset="-122"/>
                 <a:cs typeface="Segoe UI Symbol" pitchFamily="34" charset="-120"/>
               </a:rPr>
-              <a:t>◔</a:t>
-            </a:r>
-            <a:endParaRPr lang="en-US" sz="984" dirty="0"/>
-          </a:p>
-        </p:txBody>
-      </p:sp>
-      <p:sp>
-        <p:nvSpPr>
-          <p:cNvPr id="8" name="Text 6"/>
-          <p:cNvSpPr/>
-          <p:nvPr/>
-        </p:nvSpPr>
-        <p:spPr>
-          <a:xfrm>
-            <a:off x="992035" y="2389584"/>
-            <a:ext cx="301931" cy="185166"/>
-          </a:xfrm>
-          <a:prstGeom prst="rect">
-            <a:avLst/>
-          </a:prstGeom>
-          <a:noFill/>
-          <a:ln/>
-        </p:spPr>
-        <p:txBody>
-          <a:bodyPr wrap="none" lIns="0" tIns="0" rIns="0" bIns="0" rtlCol="0" anchor="t"/>
-          <a:lstStyle/>
-          <a:p>
-            <a:pPr algn="ctr" indent="0" marL="0">
-              <a:lnSpc>
-                <a:spcPts val="1350"/>
-              </a:lnSpc>
-              <a:buNone/>
-            </a:pPr>
-            <a:r>
-              <a:rPr lang="en-US" sz="900" b="1" spc="-9" kern="0" dirty="0">
-                <a:solidFill>
-                  <a:srgbClr val="000000"/>
-                </a:solidFill>
-                <a:latin typeface="Liberation Sans Narrow" pitchFamily="34" charset="0"/>
-                <a:ea typeface="Liberation Sans Narrow" pitchFamily="34" charset="-122"/>
-                <a:cs typeface="Liberation Sans Narrow" pitchFamily="34" charset="-120"/>
-              </a:rPr>
-              <a:t>M2</a:t>
-            </a:r>
-            <a:endParaRPr lang="en-US" sz="900" dirty="0"/>
-          </a:p>
-        </p:txBody>
-      </p:sp>
-      <p:sp>
-        <p:nvSpPr>
-          <p:cNvPr id="9" name="Text 7"/>
-          <p:cNvSpPr/>
-          <p:nvPr/>
-        </p:nvSpPr>
-        <p:spPr>
-          <a:xfrm>
-            <a:off x="514350" y="2603897"/>
-            <a:ext cx="1257300" cy="285179"/>
-          </a:xfrm>
-          <a:prstGeom prst="rect">
-            <a:avLst/>
-          </a:prstGeom>
-          <a:noFill/>
-          <a:ln/>
-        </p:spPr>
-        <p:txBody>
-          <a:bodyPr wrap="square" lIns="28575" tIns="0" rIns="28575" bIns="0" rtlCol="0" anchor="t"/>
-          <a:lstStyle/>
-          <a:p>
-            <a:pPr algn="ctr" indent="0" marL="0">
-              <a:lnSpc>
-                <a:spcPts val="877"/>
+              <a:t>⚿</a:t>
+            </a:r>
+            <a:endParaRPr lang="en-US" sz="800" dirty="0"/>
+          </a:p>
+        </p:txBody>
+      </p:sp>
+      <p:sp>
+        <p:nvSpPr>
+          <p:cNvPr id="11" name="Text 8"/>
+          <p:cNvSpPr/>
+          <p:nvPr/>
+        </p:nvSpPr>
+        <p:spPr>
+          <a:xfrm>
+            <a:off x="514350" y="2087761"/>
+            <a:ext cx="2495513" cy="660574"/>
+          </a:xfrm>
+          <a:prstGeom prst="rect">
+            <a:avLst/>
+          </a:prstGeom>
+          <a:noFill/>
+          <a:ln/>
+        </p:spPr>
+        <p:txBody>
+          <a:bodyPr wrap="square" lIns="0" tIns="0" rIns="0" bIns="0" rtlCol="0" anchor="t"/>
+          <a:lstStyle/>
+          <a:p>
+            <a:pPr algn="l" indent="0" marL="0">
+              <a:lnSpc>
+                <a:spcPts val="906"/>
+              </a:lnSpc>
+              <a:buNone/>
+            </a:pPr>
+            <a:r>
+              <a:rPr lang="en-US" sz="800" b="1" dirty="0">
+                <a:solidFill>
+                  <a:srgbClr val="444444"/>
+                </a:solidFill>
+                <a:latin typeface="Carlito" pitchFamily="34" charset="0"/>
+                <a:ea typeface="Carlito" pitchFamily="34" charset="-122"/>
+                <a:cs typeface="Carlito" pitchFamily="34" charset="-120"/>
+              </a:rPr>
+              <a:t>AliExpress's in-house LLM.</a:t>
+            </a:r>
+            <a:pPr algn="l" indent="0" marL="0">
+              <a:lnSpc>
+                <a:spcPts val="906"/>
               </a:lnSpc>
               <a:buNone/>
             </a:pPr>
@@ -6196,11 +6268,45 @@
                 <a:solidFill>
                   <a:srgbClr val="444444"/>
                 </a:solidFill>
-                <a:latin typeface="Liberation Sans Narrow" pitchFamily="34" charset="0"/>
-                <a:ea typeface="Liberation Sans Narrow" pitchFamily="34" charset="-122"/>
-                <a:cs typeface="Liberation Sans Narrow" pitchFamily="34" charset="-120"/>
-              </a:rPr>
-              <a:t>Flagship #1 — Opening Keynote</a:t>
+                <a:latin typeface="Carlito" pitchFamily="34" charset="0"/>
+                <a:ea typeface="Carlito" pitchFamily="34" charset="-122"/>
+                <a:cs typeface="Carlito" pitchFamily="34" charset="-120"/>
+              </a:rPr>
+              <a:t> Live demo of Qwen-Max powering agent-driven product discovery, cross-language search, and global catalog reasoning at marketplace scale. </a:t>
+            </a:r>
+            <a:pPr algn="l" indent="0" marL="0">
+              <a:lnSpc>
+                <a:spcPts val="906"/>
+              </a:lnSpc>
+              <a:buNone/>
+            </a:pPr>
+            <a:r>
+              <a:rPr lang="en-US" sz="800" b="1" dirty="0">
+                <a:solidFill>
+                  <a:srgbClr val="444444"/>
+                </a:solidFill>
+                <a:latin typeface="Carlito" pitchFamily="34" charset="0"/>
+                <a:ea typeface="Carlito" pitchFamily="34" charset="-122"/>
+                <a:cs typeface="Carlito" pitchFamily="34" charset="-120"/>
+              </a:rPr>
+              <a:t>Community gets:</a:t>
+            </a:r>
+            <a:pPr algn="l" indent="0" marL="0">
+              <a:lnSpc>
+                <a:spcPts val="906"/>
+              </a:lnSpc>
+              <a:buNone/>
+            </a:pPr>
+            <a:r>
+              <a:rPr lang="en-US" sz="800" dirty="0">
+                <a:solidFill>
+                  <a:srgbClr val="444444"/>
+                </a:solidFill>
+                <a:latin typeface="Carlito" pitchFamily="34" charset="0"/>
+                <a:ea typeface="Carlito" pitchFamily="34" charset="-122"/>
+                <a:cs typeface="Carlito" pitchFamily="34" charset="-120"/>
+              </a:rPr>
+              <a:t> private Qwen API sandbox + $2K in credits.</a:t>
             </a:r>
             <a:endParaRPr lang="en-US" sz="800" dirty="0"/>
           </a:p>
@@ -6208,444 +6314,122 @@
       </p:sp>
       <p:sp>
         <p:nvSpPr>
-          <p:cNvPr id="10" name="Text 8"/>
-          <p:cNvSpPr/>
-          <p:nvPr/>
-        </p:nvSpPr>
-        <p:spPr>
-          <a:xfrm>
-            <a:off x="2363635" y="2389584"/>
-            <a:ext cx="301931" cy="185166"/>
-          </a:xfrm>
-          <a:prstGeom prst="rect">
-            <a:avLst/>
-          </a:prstGeom>
-          <a:noFill/>
-          <a:ln/>
-        </p:spPr>
-        <p:txBody>
-          <a:bodyPr wrap="none" lIns="0" tIns="0" rIns="0" bIns="0" rtlCol="0" anchor="t"/>
-          <a:lstStyle/>
-          <a:p>
-            <a:pPr algn="ctr" indent="0" marL="0">
-              <a:lnSpc>
-                <a:spcPts val="1350"/>
-              </a:lnSpc>
-              <a:buNone/>
-            </a:pPr>
-            <a:r>
-              <a:rPr lang="en-US" sz="900" b="1" spc="-9" kern="0" dirty="0">
-                <a:solidFill>
-                  <a:srgbClr val="000000"/>
-                </a:solidFill>
-                <a:latin typeface="Liberation Sans Narrow" pitchFamily="34" charset="0"/>
-                <a:ea typeface="Liberation Sans Narrow" pitchFamily="34" charset="-122"/>
-                <a:cs typeface="Liberation Sans Narrow" pitchFamily="34" charset="-120"/>
-              </a:rPr>
-              <a:t>M4</a:t>
-            </a:r>
-            <a:endParaRPr lang="en-US" sz="900" dirty="0"/>
-          </a:p>
-        </p:txBody>
-      </p:sp>
-      <p:sp>
-        <p:nvSpPr>
-          <p:cNvPr id="11" name="Text 9"/>
-          <p:cNvSpPr/>
-          <p:nvPr/>
-        </p:nvSpPr>
-        <p:spPr>
-          <a:xfrm>
-            <a:off x="1885950" y="2603897"/>
-            <a:ext cx="1257300" cy="285179"/>
-          </a:xfrm>
-          <a:prstGeom prst="rect">
-            <a:avLst/>
-          </a:prstGeom>
-          <a:noFill/>
-          <a:ln/>
-        </p:spPr>
-        <p:txBody>
-          <a:bodyPr wrap="square" lIns="28575" tIns="0" rIns="28575" bIns="0" rtlCol="0" anchor="t"/>
-          <a:lstStyle/>
-          <a:p>
-            <a:pPr algn="ctr" indent="0" marL="0">
-              <a:lnSpc>
-                <a:spcPts val="877"/>
-              </a:lnSpc>
-              <a:buNone/>
-            </a:pPr>
-            <a:r>
-              <a:rPr lang="en-US" sz="800" dirty="0">
-                <a:solidFill>
-                  <a:srgbClr val="444444"/>
-                </a:solidFill>
-                <a:latin typeface="Liberation Sans Narrow" pitchFamily="34" charset="0"/>
-                <a:ea typeface="Liberation Sans Narrow" pitchFamily="34" charset="-122"/>
-                <a:cs typeface="Liberation Sans Narrow" pitchFamily="34" charset="-120"/>
-              </a:rPr>
-              <a:t>Flagship #2 — AI Insight Forum</a:t>
-            </a:r>
-            <a:endParaRPr lang="en-US" sz="800" dirty="0"/>
-          </a:p>
-        </p:txBody>
-      </p:sp>
-      <p:sp>
-        <p:nvSpPr>
-          <p:cNvPr id="12" name="Text 10"/>
-          <p:cNvSpPr/>
-          <p:nvPr/>
-        </p:nvSpPr>
-        <p:spPr>
-          <a:xfrm>
-            <a:off x="3735235" y="2389584"/>
-            <a:ext cx="301931" cy="185166"/>
-          </a:xfrm>
-          <a:prstGeom prst="rect">
-            <a:avLst/>
-          </a:prstGeom>
-          <a:noFill/>
-          <a:ln/>
-        </p:spPr>
-        <p:txBody>
-          <a:bodyPr wrap="none" lIns="0" tIns="0" rIns="0" bIns="0" rtlCol="0" anchor="t"/>
-          <a:lstStyle/>
-          <a:p>
-            <a:pPr algn="ctr" indent="0" marL="0">
-              <a:lnSpc>
-                <a:spcPts val="1350"/>
-              </a:lnSpc>
-              <a:buNone/>
-            </a:pPr>
-            <a:r>
-              <a:rPr lang="en-US" sz="900" b="1" spc="-9" kern="0" dirty="0">
-                <a:solidFill>
-                  <a:srgbClr val="000000"/>
-                </a:solidFill>
-                <a:latin typeface="Liberation Sans Narrow" pitchFamily="34" charset="0"/>
-                <a:ea typeface="Liberation Sans Narrow" pitchFamily="34" charset="-122"/>
-                <a:cs typeface="Liberation Sans Narrow" pitchFamily="34" charset="-120"/>
-              </a:rPr>
-              <a:t>M6</a:t>
-            </a:r>
-            <a:endParaRPr lang="en-US" sz="900" dirty="0"/>
-          </a:p>
-        </p:txBody>
-      </p:sp>
-      <p:sp>
-        <p:nvSpPr>
-          <p:cNvPr id="13" name="Text 11"/>
-          <p:cNvSpPr/>
-          <p:nvPr/>
-        </p:nvSpPr>
-        <p:spPr>
-          <a:xfrm>
-            <a:off x="3257550" y="2603897"/>
-            <a:ext cx="1257300" cy="285179"/>
-          </a:xfrm>
-          <a:prstGeom prst="rect">
-            <a:avLst/>
-          </a:prstGeom>
-          <a:noFill/>
-          <a:ln/>
-        </p:spPr>
-        <p:txBody>
-          <a:bodyPr wrap="square" lIns="28575" tIns="0" rIns="28575" bIns="0" rtlCol="0" anchor="t"/>
-          <a:lstStyle/>
-          <a:p>
-            <a:pPr algn="ctr" indent="0" marL="0">
-              <a:lnSpc>
-                <a:spcPts val="877"/>
-              </a:lnSpc>
-              <a:buNone/>
-            </a:pPr>
-            <a:r>
-              <a:rPr lang="en-US" sz="800" dirty="0">
-                <a:solidFill>
-                  <a:srgbClr val="444444"/>
-                </a:solidFill>
-                <a:latin typeface="Liberation Sans Narrow" pitchFamily="34" charset="0"/>
-                <a:ea typeface="Liberation Sans Narrow" pitchFamily="34" charset="-122"/>
-                <a:cs typeface="Liberation Sans Narrow" pitchFamily="34" charset="-120"/>
-              </a:rPr>
-              <a:t>Flagship #3 — Community Connect</a:t>
-            </a:r>
-            <a:endParaRPr lang="en-US" sz="800" dirty="0"/>
-          </a:p>
-        </p:txBody>
-      </p:sp>
-      <p:sp>
-        <p:nvSpPr>
-          <p:cNvPr id="14" name="Text 12"/>
-          <p:cNvSpPr/>
-          <p:nvPr/>
-        </p:nvSpPr>
-        <p:spPr>
-          <a:xfrm>
-            <a:off x="5106835" y="2389584"/>
-            <a:ext cx="301931" cy="185166"/>
-          </a:xfrm>
-          <a:prstGeom prst="rect">
-            <a:avLst/>
-          </a:prstGeom>
-          <a:noFill/>
-          <a:ln/>
-        </p:spPr>
-        <p:txBody>
-          <a:bodyPr wrap="none" lIns="0" tIns="0" rIns="0" bIns="0" rtlCol="0" anchor="t"/>
-          <a:lstStyle/>
-          <a:p>
-            <a:pPr algn="ctr" indent="0" marL="0">
-              <a:lnSpc>
-                <a:spcPts val="1350"/>
-              </a:lnSpc>
-              <a:buNone/>
-            </a:pPr>
-            <a:r>
-              <a:rPr lang="en-US" sz="900" b="1" spc="-9" kern="0" dirty="0">
-                <a:solidFill>
-                  <a:srgbClr val="000000"/>
-                </a:solidFill>
-                <a:latin typeface="Liberation Sans Narrow" pitchFamily="34" charset="0"/>
-                <a:ea typeface="Liberation Sans Narrow" pitchFamily="34" charset="-122"/>
-                <a:cs typeface="Liberation Sans Narrow" pitchFamily="34" charset="-120"/>
-              </a:rPr>
-              <a:t>M8</a:t>
-            </a:r>
-            <a:endParaRPr lang="en-US" sz="900" dirty="0"/>
-          </a:p>
-        </p:txBody>
-      </p:sp>
-      <p:sp>
-        <p:nvSpPr>
-          <p:cNvPr id="15" name="Text 13"/>
-          <p:cNvSpPr/>
-          <p:nvPr/>
-        </p:nvSpPr>
-        <p:spPr>
-          <a:xfrm>
-            <a:off x="4629150" y="2603897"/>
-            <a:ext cx="1257300" cy="285179"/>
-          </a:xfrm>
-          <a:prstGeom prst="rect">
-            <a:avLst/>
-          </a:prstGeom>
-          <a:noFill/>
-          <a:ln/>
-        </p:spPr>
-        <p:txBody>
-          <a:bodyPr wrap="square" lIns="28575" tIns="0" rIns="28575" bIns="0" rtlCol="0" anchor="t"/>
-          <a:lstStyle/>
-          <a:p>
-            <a:pPr algn="ctr" indent="0" marL="0">
-              <a:lnSpc>
-                <a:spcPts val="877"/>
-              </a:lnSpc>
-              <a:buNone/>
-            </a:pPr>
-            <a:r>
-              <a:rPr lang="en-US" sz="800" dirty="0">
-                <a:solidFill>
-                  <a:srgbClr val="444444"/>
-                </a:solidFill>
-                <a:latin typeface="Liberation Sans Narrow" pitchFamily="34" charset="0"/>
-                <a:ea typeface="Liberation Sans Narrow" pitchFamily="34" charset="-122"/>
-                <a:cs typeface="Liberation Sans Narrow" pitchFamily="34" charset="-120"/>
-              </a:rPr>
-              <a:t>Flagship #4 — Builder Showcase</a:t>
-            </a:r>
-            <a:endParaRPr lang="en-US" sz="800" dirty="0"/>
-          </a:p>
-        </p:txBody>
-      </p:sp>
-      <p:sp>
-        <p:nvSpPr>
-          <p:cNvPr id="16" name="Text 14"/>
-          <p:cNvSpPr/>
-          <p:nvPr/>
-        </p:nvSpPr>
-        <p:spPr>
-          <a:xfrm>
-            <a:off x="6416532" y="2389584"/>
-            <a:ext cx="425736" cy="185166"/>
-          </a:xfrm>
-          <a:prstGeom prst="rect">
-            <a:avLst/>
-          </a:prstGeom>
-          <a:noFill/>
-          <a:ln/>
-        </p:spPr>
-        <p:txBody>
-          <a:bodyPr wrap="none" lIns="0" tIns="0" rIns="0" bIns="0" rtlCol="0" anchor="t"/>
-          <a:lstStyle/>
-          <a:p>
-            <a:pPr algn="ctr" indent="0" marL="0">
-              <a:lnSpc>
-                <a:spcPts val="1350"/>
-              </a:lnSpc>
-              <a:buNone/>
-            </a:pPr>
-            <a:r>
-              <a:rPr lang="en-US" sz="900" b="1" spc="-9" kern="0" dirty="0">
-                <a:solidFill>
-                  <a:srgbClr val="000000"/>
-                </a:solidFill>
-                <a:latin typeface="Liberation Sans Narrow" pitchFamily="34" charset="0"/>
-                <a:ea typeface="Liberation Sans Narrow" pitchFamily="34" charset="-122"/>
-                <a:cs typeface="Liberation Sans Narrow" pitchFamily="34" charset="-120"/>
-              </a:rPr>
-              <a:t>M10</a:t>
-            </a:r>
-            <a:endParaRPr lang="en-US" sz="900" dirty="0"/>
-          </a:p>
-        </p:txBody>
-      </p:sp>
-      <p:sp>
-        <p:nvSpPr>
-          <p:cNvPr id="17" name="Text 15"/>
-          <p:cNvSpPr/>
-          <p:nvPr/>
-        </p:nvSpPr>
-        <p:spPr>
-          <a:xfrm>
-            <a:off x="6000750" y="2603897"/>
-            <a:ext cx="1257300" cy="285179"/>
-          </a:xfrm>
-          <a:prstGeom prst="rect">
-            <a:avLst/>
-          </a:prstGeom>
-          <a:noFill/>
-          <a:ln/>
-        </p:spPr>
-        <p:txBody>
-          <a:bodyPr wrap="square" lIns="28575" tIns="0" rIns="28575" bIns="0" rtlCol="0" anchor="t"/>
-          <a:lstStyle/>
-          <a:p>
-            <a:pPr algn="ctr" indent="0" marL="0">
-              <a:lnSpc>
-                <a:spcPts val="877"/>
-              </a:lnSpc>
-              <a:buNone/>
-            </a:pPr>
-            <a:r>
-              <a:rPr lang="en-US" sz="800" dirty="0">
-                <a:solidFill>
-                  <a:srgbClr val="444444"/>
-                </a:solidFill>
-                <a:latin typeface="Liberation Sans Narrow" pitchFamily="34" charset="0"/>
-                <a:ea typeface="Liberation Sans Narrow" pitchFamily="34" charset="-122"/>
-                <a:cs typeface="Liberation Sans Narrow" pitchFamily="34" charset="-120"/>
-              </a:rPr>
-              <a:t>Flagship #5 — Global Bridge</a:t>
-            </a:r>
-            <a:endParaRPr lang="en-US" sz="800" dirty="0"/>
-          </a:p>
-        </p:txBody>
-      </p:sp>
-      <p:sp>
-        <p:nvSpPr>
-          <p:cNvPr id="18" name="Text 16"/>
-          <p:cNvSpPr/>
-          <p:nvPr/>
-        </p:nvSpPr>
-        <p:spPr>
-          <a:xfrm>
-            <a:off x="7788132" y="2389584"/>
-            <a:ext cx="425736" cy="185166"/>
-          </a:xfrm>
-          <a:prstGeom prst="rect">
-            <a:avLst/>
-          </a:prstGeom>
-          <a:noFill/>
-          <a:ln/>
-        </p:spPr>
-        <p:txBody>
-          <a:bodyPr wrap="none" lIns="0" tIns="0" rIns="0" bIns="0" rtlCol="0" anchor="t"/>
-          <a:lstStyle/>
-          <a:p>
-            <a:pPr algn="ctr" indent="0" marL="0">
-              <a:lnSpc>
-                <a:spcPts val="1350"/>
-              </a:lnSpc>
-              <a:buNone/>
-            </a:pPr>
-            <a:r>
-              <a:rPr lang="en-US" sz="900" b="1" spc="-9" kern="0" dirty="0">
-                <a:solidFill>
-                  <a:srgbClr val="000000"/>
-                </a:solidFill>
-                <a:latin typeface="Liberation Sans Narrow" pitchFamily="34" charset="0"/>
-                <a:ea typeface="Liberation Sans Narrow" pitchFamily="34" charset="-122"/>
-                <a:cs typeface="Liberation Sans Narrow" pitchFamily="34" charset="-120"/>
-              </a:rPr>
-              <a:t>M12</a:t>
-            </a:r>
-            <a:endParaRPr lang="en-US" sz="900" dirty="0"/>
-          </a:p>
-        </p:txBody>
-      </p:sp>
-      <p:sp>
-        <p:nvSpPr>
-          <p:cNvPr id="19" name="Text 17"/>
-          <p:cNvSpPr/>
-          <p:nvPr/>
-        </p:nvSpPr>
-        <p:spPr>
-          <a:xfrm>
-            <a:off x="7372350" y="2603897"/>
-            <a:ext cx="1257300" cy="285179"/>
-          </a:xfrm>
-          <a:prstGeom prst="rect">
-            <a:avLst/>
-          </a:prstGeom>
-          <a:noFill/>
-          <a:ln/>
-        </p:spPr>
-        <p:txBody>
-          <a:bodyPr wrap="square" lIns="28575" tIns="0" rIns="28575" bIns="0" rtlCol="0" anchor="t"/>
-          <a:lstStyle/>
-          <a:p>
-            <a:pPr algn="ctr" indent="0" marL="0">
-              <a:lnSpc>
-                <a:spcPts val="877"/>
-              </a:lnSpc>
-              <a:buNone/>
-            </a:pPr>
-            <a:r>
-              <a:rPr lang="en-US" sz="800" dirty="0">
-                <a:solidFill>
-                  <a:srgbClr val="444444"/>
-                </a:solidFill>
-                <a:latin typeface="Liberation Sans Narrow" pitchFamily="34" charset="0"/>
-                <a:ea typeface="Liberation Sans Narrow" pitchFamily="34" charset="-122"/>
-                <a:cs typeface="Liberation Sans Narrow" pitchFamily="34" charset="-120"/>
-              </a:rPr>
-              <a:t>Flagship #6 — Year-Cap Summit</a:t>
-            </a:r>
-            <a:endParaRPr lang="en-US" sz="800" dirty="0"/>
-          </a:p>
-        </p:txBody>
-      </p:sp>
-      <p:sp>
-        <p:nvSpPr>
-          <p:cNvPr id="20" name="Text 18"/>
-          <p:cNvSpPr/>
-          <p:nvPr/>
-        </p:nvSpPr>
-        <p:spPr>
-          <a:xfrm>
-            <a:off x="457200" y="3083868"/>
-            <a:ext cx="8229600" cy="7144"/>
-          </a:xfrm>
-          <a:prstGeom prst="rect">
-            <a:avLst/>
+          <p:cNvPr id="12" name="Text 9"/>
+          <p:cNvSpPr/>
+          <p:nvPr/>
+        </p:nvSpPr>
+        <p:spPr>
+          <a:xfrm>
+            <a:off x="3213460" y="1237431"/>
+            <a:ext cx="2716969" cy="1521619"/>
+          </a:xfrm>
+          <a:prstGeom prst="roundRect">
+            <a:avLst>
+              <a:gd name="adj" fmla="val 3756"/>
+            </a:avLst>
           </a:prstGeom>
           <a:solidFill>
-            <a:srgbClr val="000000">
-              <a:alpha val="10000"/>
+            <a:srgbClr val="FFFFFF"/>
+          </a:solidFill>
+          <a:ln w="7144">
+            <a:solidFill>
+              <a:srgbClr val="E5E5E5"/>
+            </a:solidFill>
+            <a:prstDash val="solid"/>
+          </a:ln>
+        </p:spPr>
+        <p:txBody>
+          <a:bodyPr wrap="square" rtlCol="0" anchor="ctr"/>
+          <a:lstStyle/>
+          <a:p>
+            <a:pPr indent="0" marL="0">
+              <a:buNone/>
+            </a:pPr>
+            <a:endParaRPr lang="en-US" dirty="0"/>
+          </a:p>
+        </p:txBody>
+      </p:sp>
+      <p:sp>
+        <p:nvSpPr>
+          <p:cNvPr id="13" name="Text 10"/>
+          <p:cNvSpPr/>
+          <p:nvPr/>
+        </p:nvSpPr>
+        <p:spPr>
+          <a:xfrm>
+            <a:off x="3217032" y="1241003"/>
+            <a:ext cx="2709825" cy="661690"/>
+          </a:xfrm>
+          <a:prstGeom prst="rect">
+            <a:avLst/>
+          </a:prstGeom>
+          <a:solidFill>
+            <a:srgbClr val="1A1A1A"/>
+          </a:solidFill>
+          <a:ln/>
+        </p:spPr>
+        <p:txBody>
+          <a:bodyPr wrap="square" rtlCol="0" anchor="ctr"/>
+          <a:lstStyle/>
+          <a:p>
+            <a:pPr indent="0" marL="0">
+              <a:buNone/>
+            </a:pPr>
+            <a:endParaRPr lang="en-US" dirty="0"/>
+          </a:p>
+        </p:txBody>
+      </p:sp>
+      <p:pic>
+        <p:nvPicPr>
+          <p:cNvPr id="14" name="Image 1" descr="/tmp/h2p-fit-1788201353187-6bhycp.png">    </p:cNvPr>
+          <p:cNvPicPr>
+            <a:picLocks noChangeAspect="1"/>
+          </p:cNvPicPr>
+          <p:nvPr/>
+        </p:nvPicPr>
+        <p:blipFill>
+          <a:blip r:embed="rId2"/>
+          <a:stretch>
+            <a:fillRect/>
+          </a:stretch>
+        </p:blipFill>
+        <p:spPr>
+          <a:xfrm>
+            <a:off x="3217032" y="1241003"/>
+            <a:ext cx="2709825" cy="661690"/>
+          </a:xfrm>
+          <a:prstGeom prst="rect">
+            <a:avLst/>
+          </a:prstGeom>
+        </p:spPr>
+      </p:pic>
+      <p:sp>
+        <p:nvSpPr>
+          <p:cNvPr id="15" name="Text 11"/>
+          <p:cNvSpPr/>
+          <p:nvPr/>
+        </p:nvSpPr>
+        <p:spPr>
+          <a:xfrm>
+            <a:off x="3294184" y="1978560"/>
+            <a:ext cx="970278" cy="184023"/>
+          </a:xfrm>
+          <a:prstGeom prst="roundRect">
+            <a:avLst>
+              <a:gd name="adj" fmla="val 5170807"/>
+            </a:avLst>
+          </a:prstGeom>
+          <a:solidFill>
+            <a:srgbClr val="FF005A">
+              <a:alpha val="8000"/>
             </a:srgbClr>
           </a:solidFill>
-          <a:ln/>
+          <a:ln w="7144">
+            <a:solidFill>
+              <a:srgbClr val="FF005A"/>
+            </a:solidFill>
+            <a:prstDash val="solid"/>
+          </a:ln>
         </p:spPr>
         <p:txBody>
           <a:bodyPr wrap="square" rtlCol="0" anchor="ctr"/>
@@ -6660,43 +6444,80 @@
       </p:sp>
       <p:sp>
         <p:nvSpPr>
-          <p:cNvPr id="21" name="Text 19"/>
-          <p:cNvSpPr/>
-          <p:nvPr/>
-        </p:nvSpPr>
-        <p:spPr>
-          <a:xfrm>
-            <a:off x="457200" y="3248174"/>
-            <a:ext cx="3528395" cy="119015"/>
-          </a:xfrm>
-          <a:prstGeom prst="rect">
-            <a:avLst/>
-          </a:prstGeom>
-          <a:noFill/>
-          <a:ln/>
-        </p:spPr>
-        <p:txBody>
-          <a:bodyPr wrap="none" lIns="0" tIns="0" rIns="0" bIns="0" rtlCol="0" anchor="t">
-            <a:normAutofit/>
-          </a:bodyPr>
-          <a:lstStyle/>
-          <a:p>
-            <a:pPr algn="l" indent="0" marL="0">
-              <a:lnSpc>
-                <a:spcPts val="928"/>
-              </a:lnSpc>
-              <a:buNone/>
-            </a:pPr>
-            <a:r>
-              <a:rPr lang="en-US" sz="800" b="1" spc="136" kern="0" dirty="0">
-                <a:solidFill>
-                  <a:srgbClr val="000000"/>
-                </a:solidFill>
-                <a:latin typeface="Liberation Sans Narrow" pitchFamily="34" charset="0"/>
-                <a:ea typeface="Liberation Sans Narrow" pitchFamily="34" charset="-122"/>
-                <a:cs typeface="Liberation Sans Narrow" pitchFamily="34" charset="-120"/>
-              </a:rPr>
-              <a:t>6 FLAGSHIP EVENTS</a:t>
+          <p:cNvPr id="16" name="Text 12"/>
+          <p:cNvSpPr/>
+          <p:nvPr/>
+        </p:nvSpPr>
+        <p:spPr>
+          <a:xfrm>
+            <a:off x="3495638" y="2031281"/>
+            <a:ext cx="681670" cy="120701"/>
+          </a:xfrm>
+          <a:prstGeom prst="rect">
+            <a:avLst/>
+          </a:prstGeom>
+          <a:noFill/>
+          <a:ln/>
+        </p:spPr>
+        <p:txBody>
+          <a:bodyPr wrap="none" lIns="0" tIns="0" rIns="0" bIns="0" rtlCol="0" anchor="t"/>
+          <a:lstStyle/>
+          <a:p>
+            <a:pPr algn="l" indent="0" marL="0">
+              <a:lnSpc>
+                <a:spcPts val="844"/>
+              </a:lnSpc>
+              <a:buNone/>
+            </a:pPr>
+            <a:r>
+              <a:rPr lang="en-US" sz="600" b="1" spc="68" kern="0" dirty="0">
+                <a:solidFill>
+                  <a:srgbClr val="FF005A"/>
+                </a:solidFill>
+                <a:latin typeface="Carlito" pitchFamily="34" charset="0"/>
+                <a:ea typeface="Carlito" pitchFamily="34" charset="-122"/>
+                <a:cs typeface="Carlito" pitchFamily="34" charset="-120"/>
+              </a:rPr>
+              <a:t>EARLY ACCESS</a:t>
+            </a:r>
+            <a:endParaRPr lang="en-US" sz="600" dirty="0"/>
+          </a:p>
+        </p:txBody>
+      </p:sp>
+      <p:sp>
+        <p:nvSpPr>
+          <p:cNvPr id="17" name="Text 13"/>
+          <p:cNvSpPr/>
+          <p:nvPr/>
+        </p:nvSpPr>
+        <p:spPr>
+          <a:xfrm>
+            <a:off x="3381338" y="2031281"/>
+            <a:ext cx="91440" cy="91440"/>
+          </a:xfrm>
+          <a:prstGeom prst="rect">
+            <a:avLst/>
+          </a:prstGeom>
+          <a:noFill/>
+          <a:ln/>
+        </p:spPr>
+        <p:txBody>
+          <a:bodyPr wrap="none" lIns="0" tIns="0" rIns="0" bIns="0" rtlCol="0" anchor="ctr"/>
+          <a:lstStyle/>
+          <a:p>
+            <a:pPr algn="ctr" indent="0" marL="0">
+              <a:buNone/>
+            </a:pPr>
+            <a:r>
+              <a:rPr lang="en-US" sz="800" dirty="0">
+                <a:solidFill>
+                  <a:srgbClr val="FF005A"/>
+                </a:solidFill>
+                <a:latin typeface="Segoe UI Symbol" pitchFamily="34" charset="0"/>
+                <a:ea typeface="Segoe UI Symbol" pitchFamily="34" charset="-122"/>
+                <a:cs typeface="Segoe UI Symbol" pitchFamily="34" charset="-120"/>
+              </a:rPr>
+              <a:t>⚿</a:t>
             </a:r>
             <a:endParaRPr lang="en-US" sz="800" dirty="0"/>
           </a:p>
@@ -6704,14 +6525,14 @@
       </p:sp>
       <p:sp>
         <p:nvSpPr>
-          <p:cNvPr id="22" name="Text 20"/>
-          <p:cNvSpPr/>
-          <p:nvPr/>
-        </p:nvSpPr>
-        <p:spPr>
-          <a:xfrm>
-            <a:off x="457200" y="3394621"/>
-            <a:ext cx="2839212" cy="153514"/>
+          <p:cNvPr id="18" name="Text 14"/>
+          <p:cNvSpPr/>
+          <p:nvPr/>
+        </p:nvSpPr>
+        <p:spPr>
+          <a:xfrm>
+            <a:off x="3317044" y="2209874"/>
+            <a:ext cx="2509800" cy="545604"/>
           </a:xfrm>
           <a:prstGeom prst="rect">
             <a:avLst/>
@@ -6725,7 +6546,7 @@
           <a:p>
             <a:pPr algn="l" indent="0" marL="0">
               <a:lnSpc>
-                <a:spcPts val="1024"/>
+                <a:spcPts val="906"/>
               </a:lnSpc>
               <a:buNone/>
             </a:pPr>
@@ -6734,11 +6555,45 @@
                 <a:solidFill>
                   <a:srgbClr val="444444"/>
                 </a:solidFill>
-                <a:latin typeface="Liberation Sans Narrow" pitchFamily="34" charset="0"/>
-                <a:ea typeface="Liberation Sans Narrow" pitchFamily="34" charset="-122"/>
-                <a:cs typeface="Liberation Sans Narrow" pitchFamily="34" charset="-120"/>
-              </a:rPr>
-              <a:t>$12K value-equivalent per activation</a:t>
+                <a:latin typeface="Carlito" pitchFamily="34" charset="0"/>
+                <a:ea typeface="Carlito" pitchFamily="34" charset="-122"/>
+                <a:cs typeface="Carlito" pitchFamily="34" charset="-120"/>
+              </a:rPr>
+              <a:t>OpenAI researcher on GPT-5 frontier reasoning, o3-style chain-of-thought, and agentic tool-use. </a:t>
+            </a:r>
+            <a:pPr algn="l" indent="0" marL="0">
+              <a:lnSpc>
+                <a:spcPts val="906"/>
+              </a:lnSpc>
+              <a:buNone/>
+            </a:pPr>
+            <a:r>
+              <a:rPr lang="en-US" sz="800" b="1" dirty="0">
+                <a:solidFill>
+                  <a:srgbClr val="444444"/>
+                </a:solidFill>
+                <a:latin typeface="Carlito" pitchFamily="34" charset="0"/>
+                <a:ea typeface="Carlito" pitchFamily="34" charset="-122"/>
+                <a:cs typeface="Carlito" pitchFamily="34" charset="-120"/>
+              </a:rPr>
+              <a:t>Community gets:</a:t>
+            </a:r>
+            <a:pPr algn="l" indent="0" marL="0">
+              <a:lnSpc>
+                <a:spcPts val="906"/>
+              </a:lnSpc>
+              <a:buNone/>
+            </a:pPr>
+            <a:r>
+              <a:rPr lang="en-US" sz="800" dirty="0">
+                <a:solidFill>
+                  <a:srgbClr val="444444"/>
+                </a:solidFill>
+                <a:latin typeface="Carlito" pitchFamily="34" charset="0"/>
+                <a:ea typeface="Carlito" pitchFamily="34" charset="-122"/>
+                <a:cs typeface="Carlito" pitchFamily="34" charset="-120"/>
+              </a:rPr>
+              <a:t> $5K in OpenAI API credits + early access to the Agents SDK for AI Salon TLV founders.</a:t>
             </a:r>
             <a:endParaRPr lang="en-US" sz="800" dirty="0"/>
           </a:p>
@@ -6746,14 +6601,1162 @@
       </p:sp>
       <p:sp>
         <p:nvSpPr>
-          <p:cNvPr id="23" name="Shape 21"/>
-          <p:cNvSpPr/>
-          <p:nvPr/>
-        </p:nvSpPr>
-        <p:spPr>
-          <a:xfrm>
-            <a:off x="3261122" y="3248174"/>
-            <a:ext cx="0" cy="276374"/>
+          <p:cNvPr id="19" name="Text 15"/>
+          <p:cNvSpPr/>
+          <p:nvPr/>
+        </p:nvSpPr>
+        <p:spPr>
+          <a:xfrm>
+            <a:off x="6023297" y="1237431"/>
+            <a:ext cx="2717081" cy="1521619"/>
+          </a:xfrm>
+          <a:prstGeom prst="roundRect">
+            <a:avLst>
+              <a:gd name="adj" fmla="val 3756"/>
+            </a:avLst>
+          </a:prstGeom>
+          <a:solidFill>
+            <a:srgbClr val="FFFFFF"/>
+          </a:solidFill>
+          <a:ln w="7144">
+            <a:solidFill>
+              <a:srgbClr val="E5E5E5"/>
+            </a:solidFill>
+            <a:prstDash val="solid"/>
+          </a:ln>
+        </p:spPr>
+        <p:txBody>
+          <a:bodyPr wrap="square" rtlCol="0" anchor="ctr"/>
+          <a:lstStyle/>
+          <a:p>
+            <a:pPr indent="0" marL="0">
+              <a:buNone/>
+            </a:pPr>
+            <a:endParaRPr lang="en-US" dirty="0"/>
+          </a:p>
+        </p:txBody>
+      </p:sp>
+      <p:sp>
+        <p:nvSpPr>
+          <p:cNvPr id="20" name="Text 16"/>
+          <p:cNvSpPr/>
+          <p:nvPr/>
+        </p:nvSpPr>
+        <p:spPr>
+          <a:xfrm>
+            <a:off x="6026869" y="1241003"/>
+            <a:ext cx="2709937" cy="661690"/>
+          </a:xfrm>
+          <a:prstGeom prst="rect">
+            <a:avLst/>
+          </a:prstGeom>
+          <a:solidFill>
+            <a:srgbClr val="1A1A1A"/>
+          </a:solidFill>
+          <a:ln/>
+        </p:spPr>
+        <p:txBody>
+          <a:bodyPr wrap="square" rtlCol="0" anchor="ctr"/>
+          <a:lstStyle/>
+          <a:p>
+            <a:pPr indent="0" marL="0">
+              <a:buNone/>
+            </a:pPr>
+            <a:endParaRPr lang="en-US" dirty="0"/>
+          </a:p>
+        </p:txBody>
+      </p:sp>
+      <p:pic>
+        <p:nvPicPr>
+          <p:cNvPr id="21" name="Image 2" descr="/tmp/h2p-fit-1788201353180-8nij95.png">    </p:cNvPr>
+          <p:cNvPicPr>
+            <a:picLocks noChangeAspect="1"/>
+          </p:cNvPicPr>
+          <p:nvPr/>
+        </p:nvPicPr>
+        <p:blipFill>
+          <a:blip r:embed="rId3"/>
+          <a:stretch>
+            <a:fillRect/>
+          </a:stretch>
+        </p:blipFill>
+        <p:spPr>
+          <a:xfrm>
+            <a:off x="6026869" y="1241003"/>
+            <a:ext cx="2709937" cy="661690"/>
+          </a:xfrm>
+          <a:prstGeom prst="rect">
+            <a:avLst/>
+          </a:prstGeom>
+        </p:spPr>
+      </p:pic>
+      <p:sp>
+        <p:nvSpPr>
+          <p:cNvPr id="22" name="Text 17"/>
+          <p:cNvSpPr/>
+          <p:nvPr/>
+        </p:nvSpPr>
+        <p:spPr>
+          <a:xfrm>
+            <a:off x="6104022" y="1978560"/>
+            <a:ext cx="970278" cy="184023"/>
+          </a:xfrm>
+          <a:prstGeom prst="roundRect">
+            <a:avLst>
+              <a:gd name="adj" fmla="val 5170807"/>
+            </a:avLst>
+          </a:prstGeom>
+          <a:solidFill>
+            <a:srgbClr val="FF005A">
+              <a:alpha val="8000"/>
+            </a:srgbClr>
+          </a:solidFill>
+          <a:ln w="7144">
+            <a:solidFill>
+              <a:srgbClr val="FF005A"/>
+            </a:solidFill>
+            <a:prstDash val="solid"/>
+          </a:ln>
+        </p:spPr>
+        <p:txBody>
+          <a:bodyPr wrap="square" rtlCol="0" anchor="ctr"/>
+          <a:lstStyle/>
+          <a:p>
+            <a:pPr indent="0" marL="0">
+              <a:buNone/>
+            </a:pPr>
+            <a:endParaRPr lang="en-US" dirty="0"/>
+          </a:p>
+        </p:txBody>
+      </p:sp>
+      <p:sp>
+        <p:nvSpPr>
+          <p:cNvPr id="23" name="Text 18"/>
+          <p:cNvSpPr/>
+          <p:nvPr/>
+        </p:nvSpPr>
+        <p:spPr>
+          <a:xfrm>
+            <a:off x="6305476" y="2031281"/>
+            <a:ext cx="681670" cy="120701"/>
+          </a:xfrm>
+          <a:prstGeom prst="rect">
+            <a:avLst/>
+          </a:prstGeom>
+          <a:noFill/>
+          <a:ln/>
+        </p:spPr>
+        <p:txBody>
+          <a:bodyPr wrap="none" lIns="0" tIns="0" rIns="0" bIns="0" rtlCol="0" anchor="t"/>
+          <a:lstStyle/>
+          <a:p>
+            <a:pPr algn="l" indent="0" marL="0">
+              <a:lnSpc>
+                <a:spcPts val="844"/>
+              </a:lnSpc>
+              <a:buNone/>
+            </a:pPr>
+            <a:r>
+              <a:rPr lang="en-US" sz="600" b="1" spc="68" kern="0" dirty="0">
+                <a:solidFill>
+                  <a:srgbClr val="FF005A"/>
+                </a:solidFill>
+                <a:latin typeface="Carlito" pitchFamily="34" charset="0"/>
+                <a:ea typeface="Carlito" pitchFamily="34" charset="-122"/>
+                <a:cs typeface="Carlito" pitchFamily="34" charset="-120"/>
+              </a:rPr>
+              <a:t>EARLY ACCESS</a:t>
+            </a:r>
+            <a:endParaRPr lang="en-US" sz="600" dirty="0"/>
+          </a:p>
+        </p:txBody>
+      </p:sp>
+      <p:sp>
+        <p:nvSpPr>
+          <p:cNvPr id="24" name="Text 19"/>
+          <p:cNvSpPr/>
+          <p:nvPr/>
+        </p:nvSpPr>
+        <p:spPr>
+          <a:xfrm>
+            <a:off x="6191176" y="2031281"/>
+            <a:ext cx="91440" cy="91440"/>
+          </a:xfrm>
+          <a:prstGeom prst="rect">
+            <a:avLst/>
+          </a:prstGeom>
+          <a:noFill/>
+          <a:ln/>
+        </p:spPr>
+        <p:txBody>
+          <a:bodyPr wrap="none" lIns="0" tIns="0" rIns="0" bIns="0" rtlCol="0" anchor="ctr"/>
+          <a:lstStyle/>
+          <a:p>
+            <a:pPr algn="ctr" indent="0" marL="0">
+              <a:buNone/>
+            </a:pPr>
+            <a:r>
+              <a:rPr lang="en-US" sz="800" dirty="0">
+                <a:solidFill>
+                  <a:srgbClr val="FF005A"/>
+                </a:solidFill>
+                <a:latin typeface="Segoe UI Symbol" pitchFamily="34" charset="0"/>
+                <a:ea typeface="Segoe UI Symbol" pitchFamily="34" charset="-122"/>
+                <a:cs typeface="Segoe UI Symbol" pitchFamily="34" charset="-120"/>
+              </a:rPr>
+              <a:t>⚿</a:t>
+            </a:r>
+            <a:endParaRPr lang="en-US" sz="800" dirty="0"/>
+          </a:p>
+        </p:txBody>
+      </p:sp>
+      <p:sp>
+        <p:nvSpPr>
+          <p:cNvPr id="25" name="Text 20"/>
+          <p:cNvSpPr/>
+          <p:nvPr/>
+        </p:nvSpPr>
+        <p:spPr>
+          <a:xfrm>
+            <a:off x="6126882" y="2209874"/>
+            <a:ext cx="2509912" cy="545604"/>
+          </a:xfrm>
+          <a:prstGeom prst="rect">
+            <a:avLst/>
+          </a:prstGeom>
+          <a:noFill/>
+          <a:ln/>
+        </p:spPr>
+        <p:txBody>
+          <a:bodyPr wrap="square" lIns="0" tIns="0" rIns="0" bIns="0" rtlCol="0" anchor="t"/>
+          <a:lstStyle/>
+          <a:p>
+            <a:pPr algn="l" indent="0" marL="0">
+              <a:lnSpc>
+                <a:spcPts val="906"/>
+              </a:lnSpc>
+              <a:buNone/>
+            </a:pPr>
+            <a:r>
+              <a:rPr lang="en-US" sz="800" dirty="0">
+                <a:solidFill>
+                  <a:srgbClr val="444444"/>
+                </a:solidFill>
+                <a:latin typeface="Carlito" pitchFamily="34" charset="0"/>
+                <a:ea typeface="Carlito" pitchFamily="34" charset="-122"/>
+                <a:cs typeface="Carlito" pitchFamily="34" charset="-120"/>
+              </a:rPr>
+              <a:t>Hands-on workshop building with Claude Sonnet 4.5's 200K context window + Claude Code agentic dev tools. </a:t>
+            </a:r>
+            <a:pPr algn="l" indent="0" marL="0">
+              <a:lnSpc>
+                <a:spcPts val="906"/>
+              </a:lnSpc>
+              <a:buNone/>
+            </a:pPr>
+            <a:r>
+              <a:rPr lang="en-US" sz="800" b="1" dirty="0">
+                <a:solidFill>
+                  <a:srgbClr val="444444"/>
+                </a:solidFill>
+                <a:latin typeface="Carlito" pitchFamily="34" charset="0"/>
+                <a:ea typeface="Carlito" pitchFamily="34" charset="-122"/>
+                <a:cs typeface="Carlito" pitchFamily="34" charset="-120"/>
+              </a:rPr>
+              <a:t>Community gets:</a:t>
+            </a:r>
+            <a:pPr algn="l" indent="0" marL="0">
+              <a:lnSpc>
+                <a:spcPts val="906"/>
+              </a:lnSpc>
+              <a:buNone/>
+            </a:pPr>
+            <a:r>
+              <a:rPr lang="en-US" sz="800" dirty="0">
+                <a:solidFill>
+                  <a:srgbClr val="444444"/>
+                </a:solidFill>
+                <a:latin typeface="Carlito" pitchFamily="34" charset="0"/>
+                <a:ea typeface="Carlito" pitchFamily="34" charset="-122"/>
+                <a:cs typeface="Carlito" pitchFamily="34" charset="-120"/>
+              </a:rPr>
+              <a:t> 30-day Claude Team seats + early Sonnet 4.5 preview.</a:t>
+            </a:r>
+            <a:endParaRPr lang="en-US" sz="800" dirty="0"/>
+          </a:p>
+        </p:txBody>
+      </p:sp>
+      <p:sp>
+        <p:nvSpPr>
+          <p:cNvPr id="26" name="Text 21"/>
+          <p:cNvSpPr/>
+          <p:nvPr/>
+        </p:nvSpPr>
+        <p:spPr>
+          <a:xfrm>
+            <a:off x="403622" y="2851919"/>
+            <a:ext cx="2716969" cy="1521619"/>
+          </a:xfrm>
+          <a:prstGeom prst="roundRect">
+            <a:avLst>
+              <a:gd name="adj" fmla="val 3756"/>
+            </a:avLst>
+          </a:prstGeom>
+          <a:solidFill>
+            <a:srgbClr val="FFFFFF"/>
+          </a:solidFill>
+          <a:ln w="7144">
+            <a:solidFill>
+              <a:srgbClr val="E5E5E5"/>
+            </a:solidFill>
+            <a:prstDash val="solid"/>
+          </a:ln>
+        </p:spPr>
+        <p:txBody>
+          <a:bodyPr wrap="square" rtlCol="0" anchor="ctr"/>
+          <a:lstStyle/>
+          <a:p>
+            <a:pPr indent="0" marL="0">
+              <a:buNone/>
+            </a:pPr>
+            <a:endParaRPr lang="en-US" dirty="0"/>
+          </a:p>
+        </p:txBody>
+      </p:sp>
+      <p:sp>
+        <p:nvSpPr>
+          <p:cNvPr id="27" name="Text 22"/>
+          <p:cNvSpPr/>
+          <p:nvPr/>
+        </p:nvSpPr>
+        <p:spPr>
+          <a:xfrm>
+            <a:off x="407194" y="2855491"/>
+            <a:ext cx="2709825" cy="661690"/>
+          </a:xfrm>
+          <a:prstGeom prst="rect">
+            <a:avLst/>
+          </a:prstGeom>
+          <a:solidFill>
+            <a:srgbClr val="1A1A1A"/>
+          </a:solidFill>
+          <a:ln/>
+        </p:spPr>
+        <p:txBody>
+          <a:bodyPr wrap="square" rtlCol="0" anchor="ctr"/>
+          <a:lstStyle/>
+          <a:p>
+            <a:pPr indent="0" marL="0">
+              <a:buNone/>
+            </a:pPr>
+            <a:endParaRPr lang="en-US" dirty="0"/>
+          </a:p>
+        </p:txBody>
+      </p:sp>
+      <p:pic>
+        <p:nvPicPr>
+          <p:cNvPr id="28" name="Image 3" descr="/tmp/h2p-fit-1788201353132-5h9ebc.png">    </p:cNvPr>
+          <p:cNvPicPr>
+            <a:picLocks noChangeAspect="1"/>
+          </p:cNvPicPr>
+          <p:nvPr/>
+        </p:nvPicPr>
+        <p:blipFill>
+          <a:blip r:embed="rId4"/>
+          <a:stretch>
+            <a:fillRect/>
+          </a:stretch>
+        </p:blipFill>
+        <p:spPr>
+          <a:xfrm>
+            <a:off x="407194" y="2855491"/>
+            <a:ext cx="2709825" cy="661690"/>
+          </a:xfrm>
+          <a:prstGeom prst="rect">
+            <a:avLst/>
+          </a:prstGeom>
+        </p:spPr>
+      </p:pic>
+      <p:sp>
+        <p:nvSpPr>
+          <p:cNvPr id="29" name="Text 23"/>
+          <p:cNvSpPr/>
+          <p:nvPr/>
+        </p:nvSpPr>
+        <p:spPr>
+          <a:xfrm>
+            <a:off x="484346" y="3593047"/>
+            <a:ext cx="970278" cy="184023"/>
+          </a:xfrm>
+          <a:prstGeom prst="roundRect">
+            <a:avLst>
+              <a:gd name="adj" fmla="val 5170807"/>
+            </a:avLst>
+          </a:prstGeom>
+          <a:solidFill>
+            <a:srgbClr val="FF005A">
+              <a:alpha val="8000"/>
+            </a:srgbClr>
+          </a:solidFill>
+          <a:ln w="7144">
+            <a:solidFill>
+              <a:srgbClr val="FF005A"/>
+            </a:solidFill>
+            <a:prstDash val="solid"/>
+          </a:ln>
+        </p:spPr>
+        <p:txBody>
+          <a:bodyPr wrap="square" rtlCol="0" anchor="ctr"/>
+          <a:lstStyle/>
+          <a:p>
+            <a:pPr indent="0" marL="0">
+              <a:buNone/>
+            </a:pPr>
+            <a:endParaRPr lang="en-US" dirty="0"/>
+          </a:p>
+        </p:txBody>
+      </p:sp>
+      <p:sp>
+        <p:nvSpPr>
+          <p:cNvPr id="30" name="Text 24"/>
+          <p:cNvSpPr/>
+          <p:nvPr/>
+        </p:nvSpPr>
+        <p:spPr>
+          <a:xfrm>
+            <a:off x="685800" y="3645768"/>
+            <a:ext cx="681670" cy="120701"/>
+          </a:xfrm>
+          <a:prstGeom prst="rect">
+            <a:avLst/>
+          </a:prstGeom>
+          <a:noFill/>
+          <a:ln/>
+        </p:spPr>
+        <p:txBody>
+          <a:bodyPr wrap="none" lIns="0" tIns="0" rIns="0" bIns="0" rtlCol="0" anchor="t"/>
+          <a:lstStyle/>
+          <a:p>
+            <a:pPr algn="l" indent="0" marL="0">
+              <a:lnSpc>
+                <a:spcPts val="844"/>
+              </a:lnSpc>
+              <a:buNone/>
+            </a:pPr>
+            <a:r>
+              <a:rPr lang="en-US" sz="600" b="1" spc="68" kern="0" dirty="0">
+                <a:solidFill>
+                  <a:srgbClr val="FF005A"/>
+                </a:solidFill>
+                <a:latin typeface="Carlito" pitchFamily="34" charset="0"/>
+                <a:ea typeface="Carlito" pitchFamily="34" charset="-122"/>
+                <a:cs typeface="Carlito" pitchFamily="34" charset="-120"/>
+              </a:rPr>
+              <a:t>EARLY ACCESS</a:t>
+            </a:r>
+            <a:endParaRPr lang="en-US" sz="600" dirty="0"/>
+          </a:p>
+        </p:txBody>
+      </p:sp>
+      <p:sp>
+        <p:nvSpPr>
+          <p:cNvPr id="31" name="Text 25"/>
+          <p:cNvSpPr/>
+          <p:nvPr/>
+        </p:nvSpPr>
+        <p:spPr>
+          <a:xfrm>
+            <a:off x="571500" y="3645768"/>
+            <a:ext cx="91440" cy="91440"/>
+          </a:xfrm>
+          <a:prstGeom prst="rect">
+            <a:avLst/>
+          </a:prstGeom>
+          <a:noFill/>
+          <a:ln/>
+        </p:spPr>
+        <p:txBody>
+          <a:bodyPr wrap="none" lIns="0" tIns="0" rIns="0" bIns="0" rtlCol="0" anchor="ctr"/>
+          <a:lstStyle/>
+          <a:p>
+            <a:pPr algn="ctr" indent="0" marL="0">
+              <a:buNone/>
+            </a:pPr>
+            <a:r>
+              <a:rPr lang="en-US" sz="800" dirty="0">
+                <a:solidFill>
+                  <a:srgbClr val="FF005A"/>
+                </a:solidFill>
+                <a:latin typeface="Segoe UI Symbol" pitchFamily="34" charset="0"/>
+                <a:ea typeface="Segoe UI Symbol" pitchFamily="34" charset="-122"/>
+                <a:cs typeface="Segoe UI Symbol" pitchFamily="34" charset="-120"/>
+              </a:rPr>
+              <a:t>⚿</a:t>
+            </a:r>
+            <a:endParaRPr lang="en-US" sz="800" dirty="0"/>
+          </a:p>
+        </p:txBody>
+      </p:sp>
+      <p:sp>
+        <p:nvSpPr>
+          <p:cNvPr id="32" name="Text 26"/>
+          <p:cNvSpPr/>
+          <p:nvPr/>
+        </p:nvSpPr>
+        <p:spPr>
+          <a:xfrm>
+            <a:off x="507206" y="3824362"/>
+            <a:ext cx="2509800" cy="545604"/>
+          </a:xfrm>
+          <a:prstGeom prst="rect">
+            <a:avLst/>
+          </a:prstGeom>
+          <a:noFill/>
+          <a:ln/>
+        </p:spPr>
+        <p:txBody>
+          <a:bodyPr wrap="square" lIns="0" tIns="0" rIns="0" bIns="0" rtlCol="0" anchor="t"/>
+          <a:lstStyle/>
+          <a:p>
+            <a:pPr algn="l" indent="0" marL="0">
+              <a:lnSpc>
+                <a:spcPts val="906"/>
+              </a:lnSpc>
+              <a:buNone/>
+            </a:pPr>
+            <a:r>
+              <a:rPr lang="en-US" sz="800" dirty="0">
+                <a:solidFill>
+                  <a:srgbClr val="444444"/>
+                </a:solidFill>
+                <a:latin typeface="Carlito" pitchFamily="34" charset="0"/>
+                <a:ea typeface="Carlito" pitchFamily="34" charset="-122"/>
+                <a:cs typeface="Carlito" pitchFamily="34" charset="-120"/>
+              </a:rPr>
+              <a:t>Google DeepMind team on Gemini 2.5 native multimodal understanding, video reasoning, and Vertex AI deployment. </a:t>
+            </a:r>
+            <a:pPr algn="l" indent="0" marL="0">
+              <a:lnSpc>
+                <a:spcPts val="906"/>
+              </a:lnSpc>
+              <a:buNone/>
+            </a:pPr>
+            <a:r>
+              <a:rPr lang="en-US" sz="800" b="1" dirty="0">
+                <a:solidFill>
+                  <a:srgbClr val="444444"/>
+                </a:solidFill>
+                <a:latin typeface="Carlito" pitchFamily="34" charset="0"/>
+                <a:ea typeface="Carlito" pitchFamily="34" charset="-122"/>
+                <a:cs typeface="Carlito" pitchFamily="34" charset="-120"/>
+              </a:rPr>
+              <a:t>Community gets:</a:t>
+            </a:r>
+            <a:pPr algn="l" indent="0" marL="0">
+              <a:lnSpc>
+                <a:spcPts val="906"/>
+              </a:lnSpc>
+              <a:buNone/>
+            </a:pPr>
+            <a:r>
+              <a:rPr lang="en-US" sz="800" dirty="0">
+                <a:solidFill>
+                  <a:srgbClr val="444444"/>
+                </a:solidFill>
+                <a:latin typeface="Carlito" pitchFamily="34" charset="0"/>
+                <a:ea typeface="Carlito" pitchFamily="34" charset="-122"/>
+                <a:cs typeface="Carlito" pitchFamily="34" charset="-120"/>
+              </a:rPr>
+              <a:t> $10K Google Cloud credits + Gemini 2.5 Pro early access.</a:t>
+            </a:r>
+            <a:endParaRPr lang="en-US" sz="800" dirty="0"/>
+          </a:p>
+        </p:txBody>
+      </p:sp>
+      <p:sp>
+        <p:nvSpPr>
+          <p:cNvPr id="33" name="Text 27"/>
+          <p:cNvSpPr/>
+          <p:nvPr/>
+        </p:nvSpPr>
+        <p:spPr>
+          <a:xfrm>
+            <a:off x="3213460" y="2851919"/>
+            <a:ext cx="2716969" cy="1521619"/>
+          </a:xfrm>
+          <a:prstGeom prst="roundRect">
+            <a:avLst>
+              <a:gd name="adj" fmla="val 3756"/>
+            </a:avLst>
+          </a:prstGeom>
+          <a:solidFill>
+            <a:srgbClr val="FFFFFF"/>
+          </a:solidFill>
+          <a:ln w="7144">
+            <a:solidFill>
+              <a:srgbClr val="E5E5E5"/>
+            </a:solidFill>
+            <a:prstDash val="solid"/>
+          </a:ln>
+        </p:spPr>
+        <p:txBody>
+          <a:bodyPr wrap="square" rtlCol="0" anchor="ctr"/>
+          <a:lstStyle/>
+          <a:p>
+            <a:pPr indent="0" marL="0">
+              <a:buNone/>
+            </a:pPr>
+            <a:endParaRPr lang="en-US" dirty="0"/>
+          </a:p>
+        </p:txBody>
+      </p:sp>
+      <p:sp>
+        <p:nvSpPr>
+          <p:cNvPr id="34" name="Text 28"/>
+          <p:cNvSpPr/>
+          <p:nvPr/>
+        </p:nvSpPr>
+        <p:spPr>
+          <a:xfrm>
+            <a:off x="3217032" y="2855491"/>
+            <a:ext cx="2709825" cy="661690"/>
+          </a:xfrm>
+          <a:prstGeom prst="rect">
+            <a:avLst/>
+          </a:prstGeom>
+          <a:solidFill>
+            <a:srgbClr val="1A1A1A"/>
+          </a:solidFill>
+          <a:ln/>
+        </p:spPr>
+        <p:txBody>
+          <a:bodyPr wrap="square" rtlCol="0" anchor="ctr"/>
+          <a:lstStyle/>
+          <a:p>
+            <a:pPr indent="0" marL="0">
+              <a:buNone/>
+            </a:pPr>
+            <a:endParaRPr lang="en-US" dirty="0"/>
+          </a:p>
+        </p:txBody>
+      </p:sp>
+      <p:pic>
+        <p:nvPicPr>
+          <p:cNvPr id="35" name="Image 4" descr="/tmp/h2p-fit-1788201353142-nlhjjg.png">    </p:cNvPr>
+          <p:cNvPicPr>
+            <a:picLocks noChangeAspect="1"/>
+          </p:cNvPicPr>
+          <p:nvPr/>
+        </p:nvPicPr>
+        <p:blipFill>
+          <a:blip r:embed="rId5"/>
+          <a:stretch>
+            <a:fillRect/>
+          </a:stretch>
+        </p:blipFill>
+        <p:spPr>
+          <a:xfrm>
+            <a:off x="3217032" y="2855491"/>
+            <a:ext cx="2709825" cy="661690"/>
+          </a:xfrm>
+          <a:prstGeom prst="rect">
+            <a:avLst/>
+          </a:prstGeom>
+        </p:spPr>
+      </p:pic>
+      <p:sp>
+        <p:nvSpPr>
+          <p:cNvPr id="36" name="Text 29"/>
+          <p:cNvSpPr/>
+          <p:nvPr/>
+        </p:nvSpPr>
+        <p:spPr>
+          <a:xfrm>
+            <a:off x="3294184" y="3593047"/>
+            <a:ext cx="970278" cy="184023"/>
+          </a:xfrm>
+          <a:prstGeom prst="roundRect">
+            <a:avLst>
+              <a:gd name="adj" fmla="val 5170807"/>
+            </a:avLst>
+          </a:prstGeom>
+          <a:solidFill>
+            <a:srgbClr val="FF005A">
+              <a:alpha val="8000"/>
+            </a:srgbClr>
+          </a:solidFill>
+          <a:ln w="7144">
+            <a:solidFill>
+              <a:srgbClr val="FF005A"/>
+            </a:solidFill>
+            <a:prstDash val="solid"/>
+          </a:ln>
+        </p:spPr>
+        <p:txBody>
+          <a:bodyPr wrap="square" rtlCol="0" anchor="ctr"/>
+          <a:lstStyle/>
+          <a:p>
+            <a:pPr indent="0" marL="0">
+              <a:buNone/>
+            </a:pPr>
+            <a:endParaRPr lang="en-US" dirty="0"/>
+          </a:p>
+        </p:txBody>
+      </p:sp>
+      <p:sp>
+        <p:nvSpPr>
+          <p:cNvPr id="37" name="Text 30"/>
+          <p:cNvSpPr/>
+          <p:nvPr/>
+        </p:nvSpPr>
+        <p:spPr>
+          <a:xfrm>
+            <a:off x="3495638" y="3645768"/>
+            <a:ext cx="681670" cy="120701"/>
+          </a:xfrm>
+          <a:prstGeom prst="rect">
+            <a:avLst/>
+          </a:prstGeom>
+          <a:noFill/>
+          <a:ln/>
+        </p:spPr>
+        <p:txBody>
+          <a:bodyPr wrap="none" lIns="0" tIns="0" rIns="0" bIns="0" rtlCol="0" anchor="t"/>
+          <a:lstStyle/>
+          <a:p>
+            <a:pPr algn="l" indent="0" marL="0">
+              <a:lnSpc>
+                <a:spcPts val="844"/>
+              </a:lnSpc>
+              <a:buNone/>
+            </a:pPr>
+            <a:r>
+              <a:rPr lang="en-US" sz="600" b="1" spc="68" kern="0" dirty="0">
+                <a:solidFill>
+                  <a:srgbClr val="FF005A"/>
+                </a:solidFill>
+                <a:latin typeface="Carlito" pitchFamily="34" charset="0"/>
+                <a:ea typeface="Carlito" pitchFamily="34" charset="-122"/>
+                <a:cs typeface="Carlito" pitchFamily="34" charset="-120"/>
+              </a:rPr>
+              <a:t>EARLY ACCESS</a:t>
+            </a:r>
+            <a:endParaRPr lang="en-US" sz="600" dirty="0"/>
+          </a:p>
+        </p:txBody>
+      </p:sp>
+      <p:sp>
+        <p:nvSpPr>
+          <p:cNvPr id="38" name="Text 31"/>
+          <p:cNvSpPr/>
+          <p:nvPr/>
+        </p:nvSpPr>
+        <p:spPr>
+          <a:xfrm>
+            <a:off x="3381338" y="3645768"/>
+            <a:ext cx="91440" cy="91440"/>
+          </a:xfrm>
+          <a:prstGeom prst="rect">
+            <a:avLst/>
+          </a:prstGeom>
+          <a:noFill/>
+          <a:ln/>
+        </p:spPr>
+        <p:txBody>
+          <a:bodyPr wrap="none" lIns="0" tIns="0" rIns="0" bIns="0" rtlCol="0" anchor="ctr"/>
+          <a:lstStyle/>
+          <a:p>
+            <a:pPr algn="ctr" indent="0" marL="0">
+              <a:buNone/>
+            </a:pPr>
+            <a:r>
+              <a:rPr lang="en-US" sz="800" dirty="0">
+                <a:solidFill>
+                  <a:srgbClr val="FF005A"/>
+                </a:solidFill>
+                <a:latin typeface="Segoe UI Symbol" pitchFamily="34" charset="0"/>
+                <a:ea typeface="Segoe UI Symbol" pitchFamily="34" charset="-122"/>
+                <a:cs typeface="Segoe UI Symbol" pitchFamily="34" charset="-120"/>
+              </a:rPr>
+              <a:t>⚿</a:t>
+            </a:r>
+            <a:endParaRPr lang="en-US" sz="800" dirty="0"/>
+          </a:p>
+        </p:txBody>
+      </p:sp>
+      <p:sp>
+        <p:nvSpPr>
+          <p:cNvPr id="39" name="Text 32"/>
+          <p:cNvSpPr/>
+          <p:nvPr/>
+        </p:nvSpPr>
+        <p:spPr>
+          <a:xfrm>
+            <a:off x="3317044" y="3824362"/>
+            <a:ext cx="2509800" cy="545604"/>
+          </a:xfrm>
+          <a:prstGeom prst="rect">
+            <a:avLst/>
+          </a:prstGeom>
+          <a:noFill/>
+          <a:ln/>
+        </p:spPr>
+        <p:txBody>
+          <a:bodyPr wrap="square" lIns="0" tIns="0" rIns="0" bIns="0" rtlCol="0" anchor="t"/>
+          <a:lstStyle/>
+          <a:p>
+            <a:pPr algn="l" indent="0" marL="0">
+              <a:lnSpc>
+                <a:spcPts val="906"/>
+              </a:lnSpc>
+              <a:buNone/>
+            </a:pPr>
+            <a:r>
+              <a:rPr lang="en-US" sz="800" dirty="0">
+                <a:solidFill>
+                  <a:srgbClr val="444444"/>
+                </a:solidFill>
+                <a:latin typeface="Carlito" pitchFamily="34" charset="0"/>
+                <a:ea typeface="Carlito" pitchFamily="34" charset="-122"/>
+                <a:cs typeface="Carlito" pitchFamily="34" charset="-120"/>
+              </a:rPr>
+              <a:t>Meta AI engineers lead a fine-tuning lab on Llama 4 open weights for Israeli-domain use cases (Hebrew, retail, defense). </a:t>
+            </a:r>
+            <a:pPr algn="l" indent="0" marL="0">
+              <a:lnSpc>
+                <a:spcPts val="906"/>
+              </a:lnSpc>
+              <a:buNone/>
+            </a:pPr>
+            <a:r>
+              <a:rPr lang="en-US" sz="800" b="1" dirty="0">
+                <a:solidFill>
+                  <a:srgbClr val="444444"/>
+                </a:solidFill>
+                <a:latin typeface="Carlito" pitchFamily="34" charset="0"/>
+                <a:ea typeface="Carlito" pitchFamily="34" charset="-122"/>
+                <a:cs typeface="Carlito" pitchFamily="34" charset="-120"/>
+              </a:rPr>
+              <a:t>Community gets:</a:t>
+            </a:r>
+            <a:pPr algn="l" indent="0" marL="0">
+              <a:lnSpc>
+                <a:spcPts val="906"/>
+              </a:lnSpc>
+              <a:buNone/>
+            </a:pPr>
+            <a:r>
+              <a:rPr lang="en-US" sz="800" dirty="0">
+                <a:solidFill>
+                  <a:srgbClr val="444444"/>
+                </a:solidFill>
+                <a:latin typeface="Carlito" pitchFamily="34" charset="0"/>
+                <a:ea typeface="Carlito" pitchFamily="34" charset="-122"/>
+                <a:cs typeface="Carlito" pitchFamily="34" charset="-120"/>
+              </a:rPr>
+              <a:t> free fine-tuned Llama 4 instance per startup + H100 compute hours.</a:t>
+            </a:r>
+            <a:endParaRPr lang="en-US" sz="800" dirty="0"/>
+          </a:p>
+        </p:txBody>
+      </p:sp>
+      <p:sp>
+        <p:nvSpPr>
+          <p:cNvPr id="40" name="Text 33"/>
+          <p:cNvSpPr/>
+          <p:nvPr/>
+        </p:nvSpPr>
+        <p:spPr>
+          <a:xfrm>
+            <a:off x="6023297" y="2851919"/>
+            <a:ext cx="2717081" cy="1521619"/>
+          </a:xfrm>
+          <a:prstGeom prst="roundRect">
+            <a:avLst>
+              <a:gd name="adj" fmla="val 3756"/>
+            </a:avLst>
+          </a:prstGeom>
+          <a:solidFill>
+            <a:srgbClr val="FFFFFF"/>
+          </a:solidFill>
+          <a:ln w="7144">
+            <a:solidFill>
+              <a:srgbClr val="E5E5E5"/>
+            </a:solidFill>
+            <a:prstDash val="solid"/>
+          </a:ln>
+        </p:spPr>
+        <p:txBody>
+          <a:bodyPr wrap="square" rtlCol="0" anchor="ctr"/>
+          <a:lstStyle/>
+          <a:p>
+            <a:pPr indent="0" marL="0">
+              <a:buNone/>
+            </a:pPr>
+            <a:endParaRPr lang="en-US" dirty="0"/>
+          </a:p>
+        </p:txBody>
+      </p:sp>
+      <p:sp>
+        <p:nvSpPr>
+          <p:cNvPr id="41" name="Text 34"/>
+          <p:cNvSpPr/>
+          <p:nvPr/>
+        </p:nvSpPr>
+        <p:spPr>
+          <a:xfrm>
+            <a:off x="6026869" y="2855491"/>
+            <a:ext cx="2709937" cy="661690"/>
+          </a:xfrm>
+          <a:prstGeom prst="rect">
+            <a:avLst/>
+          </a:prstGeom>
+          <a:solidFill>
+            <a:srgbClr val="1A1A1A"/>
+          </a:solidFill>
+          <a:ln/>
+        </p:spPr>
+        <p:txBody>
+          <a:bodyPr wrap="square" rtlCol="0" anchor="ctr"/>
+          <a:lstStyle/>
+          <a:p>
+            <a:pPr indent="0" marL="0">
+              <a:buNone/>
+            </a:pPr>
+            <a:endParaRPr lang="en-US" dirty="0"/>
+          </a:p>
+        </p:txBody>
+      </p:sp>
+      <p:pic>
+        <p:nvPicPr>
+          <p:cNvPr id="42" name="Image 5" descr="/tmp/h2p-fit-1788201353173-4h55o6.png">    </p:cNvPr>
+          <p:cNvPicPr>
+            <a:picLocks noChangeAspect="1"/>
+          </p:cNvPicPr>
+          <p:nvPr/>
+        </p:nvPicPr>
+        <p:blipFill>
+          <a:blip r:embed="rId6"/>
+          <a:stretch>
+            <a:fillRect/>
+          </a:stretch>
+        </p:blipFill>
+        <p:spPr>
+          <a:xfrm>
+            <a:off x="6026869" y="2855491"/>
+            <a:ext cx="2709937" cy="661690"/>
+          </a:xfrm>
+          <a:prstGeom prst="rect">
+            <a:avLst/>
+          </a:prstGeom>
+        </p:spPr>
+      </p:pic>
+      <p:sp>
+        <p:nvSpPr>
+          <p:cNvPr id="43" name="Text 35"/>
+          <p:cNvSpPr/>
+          <p:nvPr/>
+        </p:nvSpPr>
+        <p:spPr>
+          <a:xfrm>
+            <a:off x="6104022" y="3593047"/>
+            <a:ext cx="1094735" cy="184023"/>
+          </a:xfrm>
+          <a:prstGeom prst="roundRect">
+            <a:avLst>
+              <a:gd name="adj" fmla="val 5170807"/>
+            </a:avLst>
+          </a:prstGeom>
+          <a:solidFill>
+            <a:srgbClr val="FF005A">
+              <a:alpha val="8000"/>
+            </a:srgbClr>
+          </a:solidFill>
+          <a:ln w="7144">
+            <a:solidFill>
+              <a:srgbClr val="FF005A"/>
+            </a:solidFill>
+            <a:prstDash val="solid"/>
+          </a:ln>
+        </p:spPr>
+        <p:txBody>
+          <a:bodyPr wrap="square" rtlCol="0" anchor="ctr"/>
+          <a:lstStyle/>
+          <a:p>
+            <a:pPr indent="0" marL="0">
+              <a:buNone/>
+            </a:pPr>
+            <a:endParaRPr lang="en-US" dirty="0"/>
+          </a:p>
+        </p:txBody>
+      </p:sp>
+      <p:sp>
+        <p:nvSpPr>
+          <p:cNvPr id="44" name="Text 36"/>
+          <p:cNvSpPr/>
+          <p:nvPr/>
+        </p:nvSpPr>
+        <p:spPr>
+          <a:xfrm>
+            <a:off x="6305476" y="3645768"/>
+            <a:ext cx="806128" cy="120701"/>
+          </a:xfrm>
+          <a:prstGeom prst="rect">
+            <a:avLst/>
+          </a:prstGeom>
+          <a:noFill/>
+          <a:ln/>
+        </p:spPr>
+        <p:txBody>
+          <a:bodyPr wrap="none" lIns="0" tIns="0" rIns="0" bIns="0" rtlCol="0" anchor="t"/>
+          <a:lstStyle/>
+          <a:p>
+            <a:pPr algn="l" indent="0" marL="0">
+              <a:lnSpc>
+                <a:spcPts val="844"/>
+              </a:lnSpc>
+              <a:buNone/>
+            </a:pPr>
+            <a:r>
+              <a:rPr lang="en-US" sz="600" b="1" spc="68" kern="0" dirty="0">
+                <a:solidFill>
+                  <a:srgbClr val="FF005A"/>
+                </a:solidFill>
+                <a:latin typeface="Carlito" pitchFamily="34" charset="0"/>
+                <a:ea typeface="Carlito" pitchFamily="34" charset="-122"/>
+                <a:cs typeface="Carlito" pitchFamily="34" charset="-120"/>
+              </a:rPr>
+              <a:t>HEADLINE STAGE</a:t>
+            </a:r>
+            <a:endParaRPr lang="en-US" sz="600" dirty="0"/>
+          </a:p>
+        </p:txBody>
+      </p:sp>
+      <p:sp>
+        <p:nvSpPr>
+          <p:cNvPr id="45" name="Text 37"/>
+          <p:cNvSpPr/>
+          <p:nvPr/>
+        </p:nvSpPr>
+        <p:spPr>
+          <a:xfrm>
+            <a:off x="6191176" y="3645768"/>
+            <a:ext cx="91440" cy="91440"/>
+          </a:xfrm>
+          <a:prstGeom prst="rect">
+            <a:avLst/>
+          </a:prstGeom>
+          <a:noFill/>
+          <a:ln/>
+        </p:spPr>
+        <p:txBody>
+          <a:bodyPr wrap="none" lIns="0" tIns="0" rIns="0" bIns="0" rtlCol="0" anchor="ctr"/>
+          <a:lstStyle/>
+          <a:p>
+            <a:pPr algn="ctr" indent="0" marL="0">
+              <a:buNone/>
+            </a:pPr>
+            <a:r>
+              <a:rPr lang="en-US" sz="800" dirty="0">
+                <a:solidFill>
+                  <a:srgbClr val="FF005A"/>
+                </a:solidFill>
+                <a:latin typeface="Segoe UI Symbol" pitchFamily="34" charset="0"/>
+                <a:ea typeface="Segoe UI Symbol" pitchFamily="34" charset="-122"/>
+                <a:cs typeface="Segoe UI Symbol" pitchFamily="34" charset="-120"/>
+              </a:rPr>
+              <a:t>★</a:t>
+            </a:r>
+            <a:endParaRPr lang="en-US" sz="800" dirty="0"/>
+          </a:p>
+        </p:txBody>
+      </p:sp>
+      <p:sp>
+        <p:nvSpPr>
+          <p:cNvPr id="46" name="Text 38"/>
+          <p:cNvSpPr/>
+          <p:nvPr/>
+        </p:nvSpPr>
+        <p:spPr>
+          <a:xfrm>
+            <a:off x="6126882" y="3824362"/>
+            <a:ext cx="2509912" cy="545604"/>
+          </a:xfrm>
+          <a:prstGeom prst="rect">
+            <a:avLst/>
+          </a:prstGeom>
+          <a:noFill/>
+          <a:ln/>
+        </p:spPr>
+        <p:txBody>
+          <a:bodyPr wrap="square" lIns="0" tIns="0" rIns="0" bIns="0" rtlCol="0" anchor="t"/>
+          <a:lstStyle/>
+          <a:p>
+            <a:pPr algn="l" indent="0" marL="0">
+              <a:lnSpc>
+                <a:spcPts val="906"/>
+              </a:lnSpc>
+              <a:buNone/>
+            </a:pPr>
+            <a:r>
+              <a:rPr lang="en-US" sz="800" dirty="0">
+                <a:solidFill>
+                  <a:srgbClr val="444444"/>
+                </a:solidFill>
+                <a:latin typeface="Carlito" pitchFamily="34" charset="0"/>
+                <a:ea typeface="Carlito" pitchFamily="34" charset="-122"/>
+                <a:cs typeface="Carlito" pitchFamily="34" charset="-120"/>
+              </a:rPr>
+              <a:t>Qwen + OpenAI + Anthropic + Meta leaders on one stage. AliExpress opens with the 2027 retail-AI roadmap. </a:t>
+            </a:r>
+            <a:pPr algn="l" indent="0" marL="0">
+              <a:lnSpc>
+                <a:spcPts val="906"/>
+              </a:lnSpc>
+              <a:buNone/>
+            </a:pPr>
+            <a:r>
+              <a:rPr lang="en-US" sz="800" b="1" dirty="0">
+                <a:solidFill>
+                  <a:srgbClr val="444444"/>
+                </a:solidFill>
+                <a:latin typeface="Carlito" pitchFamily="34" charset="0"/>
+                <a:ea typeface="Carlito" pitchFamily="34" charset="-122"/>
+                <a:cs typeface="Carlito" pitchFamily="34" charset="-120"/>
+              </a:rPr>
+              <a:t>Community gets:</a:t>
+            </a:r>
+            <a:pPr algn="l" indent="0" marL="0">
+              <a:lnSpc>
+                <a:spcPts val="906"/>
+              </a:lnSpc>
+              <a:buNone/>
+            </a:pPr>
+            <a:r>
+              <a:rPr lang="en-US" sz="800" dirty="0">
+                <a:solidFill>
+                  <a:srgbClr val="444444"/>
+                </a:solidFill>
+                <a:latin typeface="Carlito" pitchFamily="34" charset="0"/>
+                <a:ea typeface="Carlito" pitchFamily="34" charset="-122"/>
+                <a:cs typeface="Carlito" pitchFamily="34" charset="-120"/>
+              </a:rPr>
+              <a:t> demo-day pitch slots + published whitepaper co-authored with AliExpress.</a:t>
+            </a:r>
+            <a:endParaRPr lang="en-US" sz="800" dirty="0"/>
+          </a:p>
+        </p:txBody>
+      </p:sp>
+      <p:sp>
+        <p:nvSpPr>
+          <p:cNvPr id="47" name="Shape 39"/>
+          <p:cNvSpPr/>
+          <p:nvPr/>
+        </p:nvSpPr>
+        <p:spPr>
+          <a:xfrm>
+            <a:off x="400050" y="4466406"/>
+            <a:ext cx="8343900" cy="0"/>
           </a:xfrm>
           <a:prstGeom prst="line">
             <a:avLst/>
@@ -6769,35 +7772,35 @@
       </p:sp>
       <p:sp>
         <p:nvSpPr>
-          <p:cNvPr id="24" name="Text 22"/>
-          <p:cNvSpPr/>
-          <p:nvPr/>
-        </p:nvSpPr>
-        <p:spPr>
-          <a:xfrm>
-            <a:off x="3436144" y="3248174"/>
-            <a:ext cx="2450306" cy="119015"/>
-          </a:xfrm>
-          <a:prstGeom prst="rect">
-            <a:avLst/>
-          </a:prstGeom>
-          <a:noFill/>
-          <a:ln/>
-        </p:spPr>
-        <p:txBody>
-          <a:bodyPr wrap="none" lIns="0" tIns="0" rIns="0" bIns="0" rtlCol="0" anchor="t">
+          <p:cNvPr id="48" name="Text 40"/>
+          <p:cNvSpPr/>
+          <p:nvPr/>
+        </p:nvSpPr>
+        <p:spPr>
+          <a:xfrm>
+            <a:off x="400050" y="4541416"/>
+            <a:ext cx="3048575" cy="91440"/>
+          </a:xfrm>
+          <a:prstGeom prst="rect">
+            <a:avLst/>
+          </a:prstGeom>
+          <a:noFill/>
+          <a:ln/>
+        </p:spPr>
+        <p:txBody>
+          <a:bodyPr wrap="square" lIns="0" tIns="0" rIns="0" bIns="0" rtlCol="0" anchor="t">
             <a:normAutofit/>
           </a:bodyPr>
           <a:lstStyle/>
           <a:p>
             <a:pPr algn="l" indent="0" marL="0">
               <a:lnSpc>
-                <a:spcPts val="928"/>
-              </a:lnSpc>
-              <a:buNone/>
-            </a:pPr>
-            <a:r>
-              <a:rPr lang="en-US" sz="800" b="1" spc="136" kern="0" dirty="0">
+                <a:spcPts val="759"/>
+              </a:lnSpc>
+              <a:buNone/>
+            </a:pPr>
+            <a:r>
+              <a:rPr lang="en-US" sz="800" b="1" spc="91" kern="0" dirty="0">
                 <a:solidFill>
                   <a:srgbClr val="000000"/>
                 </a:solidFill>
@@ -6805,7 +7808,7 @@
                 <a:ea typeface="Liberation Sans Narrow" pitchFamily="34" charset="-122"/>
                 <a:cs typeface="Liberation Sans Narrow" pitchFamily="34" charset="-120"/>
               </a:rPr>
-              <a:t>12 MONTHLY EMAIL BLASTS</a:t>
+              <a:t>6 FLAGSHIP EVENTS · $12K EACH</a:t>
             </a:r>
             <a:endParaRPr lang="en-US" sz="800" dirty="0"/>
           </a:p>
@@ -6813,14 +7816,14 @@
       </p:sp>
       <p:sp>
         <p:nvSpPr>
-          <p:cNvPr id="25" name="Text 23"/>
-          <p:cNvSpPr/>
-          <p:nvPr/>
-        </p:nvSpPr>
-        <p:spPr>
-          <a:xfrm>
-            <a:off x="3436144" y="3394621"/>
-            <a:ext cx="2560034" cy="129927"/>
+          <p:cNvPr id="49" name="Text 41"/>
+          <p:cNvSpPr/>
+          <p:nvPr/>
+        </p:nvSpPr>
+        <p:spPr>
+          <a:xfrm>
+            <a:off x="400050" y="4645000"/>
+            <a:ext cx="2714625" cy="204267"/>
           </a:xfrm>
           <a:prstGeom prst="rect">
             <a:avLst/>
@@ -6834,20 +7837,20 @@
           <a:p>
             <a:pPr algn="l" indent="0" marL="0">
               <a:lnSpc>
-                <a:spcPts val="1024"/>
+                <a:spcPts val="804"/>
               </a:lnSpc>
               <a:buNone/>
             </a:pPr>
             <a:r>
               <a:rPr lang="en-US" sz="800" dirty="0">
                 <a:solidFill>
-                  <a:srgbClr val="444444"/>
+                  <a:srgbClr val="555555"/>
                 </a:solidFill>
                 <a:latin typeface="Carlito" pitchFamily="34" charset="0"/>
                 <a:ea typeface="Carlito" pitchFamily="34" charset="-122"/>
                 <a:cs typeface="Carlito" pitchFamily="34" charset="-120"/>
               </a:rPr>
-              <a:t>Always-on digital presence</a:t>
+              <a:t>Themed around frontier LLMs — Qwen, GPT-5, Claude, Gemini, Llama, Multi-Model</a:t>
             </a:r>
             <a:endParaRPr lang="en-US" sz="800" dirty="0"/>
           </a:p>
@@ -6855,14 +7858,14 @@
       </p:sp>
       <p:sp>
         <p:nvSpPr>
-          <p:cNvPr id="26" name="Shape 24"/>
-          <p:cNvSpPr/>
-          <p:nvPr/>
-        </p:nvSpPr>
-        <p:spPr>
-          <a:xfrm>
-            <a:off x="6061472" y="3248174"/>
-            <a:ext cx="0" cy="276374"/>
+          <p:cNvPr id="50" name="Shape 42"/>
+          <p:cNvSpPr/>
+          <p:nvPr/>
+        </p:nvSpPr>
+        <p:spPr>
+          <a:xfrm>
+            <a:off x="3218259" y="4541416"/>
+            <a:ext cx="0" cy="307851"/>
           </a:xfrm>
           <a:prstGeom prst="line">
             <a:avLst/>
@@ -6878,14 +7881,14 @@
       </p:sp>
       <p:sp>
         <p:nvSpPr>
-          <p:cNvPr id="27" name="Text 25"/>
-          <p:cNvSpPr/>
-          <p:nvPr/>
-        </p:nvSpPr>
-        <p:spPr>
-          <a:xfrm>
-            <a:off x="6236494" y="3248174"/>
-            <a:ext cx="2450306" cy="119015"/>
+          <p:cNvPr id="51" name="Text 43"/>
+          <p:cNvSpPr/>
+          <p:nvPr/>
+        </p:nvSpPr>
+        <p:spPr>
+          <a:xfrm>
+            <a:off x="3321844" y="4541416"/>
+            <a:ext cx="2607469" cy="91440"/>
           </a:xfrm>
           <a:prstGeom prst="rect">
             <a:avLst/>
@@ -6901,12 +7904,12 @@
           <a:p>
             <a:pPr algn="l" indent="0" marL="0">
               <a:lnSpc>
-                <a:spcPts val="928"/>
-              </a:lnSpc>
-              <a:buNone/>
-            </a:pPr>
-            <a:r>
-              <a:rPr lang="en-US" sz="800" b="1" spc="136" kern="0" dirty="0">
+                <a:spcPts val="759"/>
+              </a:lnSpc>
+              <a:buNone/>
+            </a:pPr>
+            <a:r>
+              <a:rPr lang="en-US" sz="800" b="1" spc="91" kern="0" dirty="0">
                 <a:solidFill>
                   <a:srgbClr val="000000"/>
                 </a:solidFill>
@@ -6914,7 +7917,7 @@
                 <a:ea typeface="Liberation Sans Narrow" pitchFamily="34" charset="-122"/>
                 <a:cs typeface="Liberation Sans Narrow" pitchFamily="34" charset="-120"/>
               </a:rPr>
-              <a:t>24 WHATSAPP UPDATES</a:t>
+              <a:t>$32K+ IN COMMUNITY PERKS</a:t>
             </a:r>
             <a:endParaRPr lang="en-US" sz="800" dirty="0"/>
           </a:p>
@@ -6922,14 +7925,14 @@
       </p:sp>
       <p:sp>
         <p:nvSpPr>
-          <p:cNvPr id="28" name="Text 26"/>
-          <p:cNvSpPr/>
-          <p:nvPr/>
-        </p:nvSpPr>
-        <p:spPr>
-          <a:xfrm>
-            <a:off x="6236494" y="3394621"/>
-            <a:ext cx="2560034" cy="129927"/>
+          <p:cNvPr id="52" name="Text 44"/>
+          <p:cNvSpPr/>
+          <p:nvPr/>
+        </p:nvSpPr>
+        <p:spPr>
+          <a:xfrm>
+            <a:off x="3321844" y="4645000"/>
+            <a:ext cx="2607469" cy="142615"/>
           </a:xfrm>
           <a:prstGeom prst="rect">
             <a:avLst/>
@@ -6943,54 +7946,79 @@
           <a:p>
             <a:pPr algn="l" indent="0" marL="0">
               <a:lnSpc>
-                <a:spcPts val="1024"/>
-              </a:lnSpc>
-              <a:buNone/>
-            </a:pPr>
-            <a:r>
-              <a:rPr lang="en-US" sz="800" dirty="0">
-                <a:solidFill>
-                  <a:srgbClr val="444444"/>
+                <a:spcPts val="804"/>
+              </a:lnSpc>
+              <a:buNone/>
+            </a:pPr>
+            <a:r>
+              <a:rPr lang="en-US" sz="619" dirty="0">
+                <a:solidFill>
+                  <a:srgbClr val="555555"/>
                 </a:solidFill>
                 <a:latin typeface="Carlito" pitchFamily="34" charset="0"/>
                 <a:ea typeface="Carlito" pitchFamily="34" charset="-122"/>
                 <a:cs typeface="Carlito" pitchFamily="34" charset="-120"/>
               </a:rPr>
-              <a:t>Bi-monthly community drops</a:t>
-            </a:r>
-            <a:endParaRPr lang="en-US" sz="800" dirty="0"/>
-          </a:p>
-        </p:txBody>
-      </p:sp>
-      <p:sp>
-        <p:nvSpPr>
-          <p:cNvPr id="29" name="Text 27"/>
-          <p:cNvSpPr/>
-          <p:nvPr/>
-        </p:nvSpPr>
-        <p:spPr>
-          <a:xfrm>
-            <a:off x="457200" y="4843463"/>
-            <a:ext cx="7765703" cy="164592"/>
-          </a:xfrm>
-          <a:prstGeom prst="rect">
-            <a:avLst/>
-          </a:prstGeom>
-          <a:noFill/>
-          <a:ln/>
-        </p:spPr>
-        <p:txBody>
-          <a:bodyPr wrap="none" lIns="0" tIns="0" rIns="0" bIns="0" rtlCol="0" anchor="t"/>
-          <a:lstStyle/>
-          <a:p>
-            <a:pPr algn="l" indent="0" marL="0">
-              <a:lnSpc>
-                <a:spcPts val="1013"/>
-              </a:lnSpc>
-              <a:buNone/>
-            </a:pPr>
-            <a:r>
-              <a:rPr lang="en-US" sz="800" spc="135" kern="0" dirty="0">
+              <a:t>Early API access, credits, fine-tuning compute, and platform seats</a:t>
+            </a:r>
+            <a:endParaRPr lang="en-US" sz="619" dirty="0"/>
+          </a:p>
+        </p:txBody>
+      </p:sp>
+      <p:sp>
+        <p:nvSpPr>
+          <p:cNvPr id="53" name="Shape 45"/>
+          <p:cNvSpPr/>
+          <p:nvPr/>
+        </p:nvSpPr>
+        <p:spPr>
+          <a:xfrm>
+            <a:off x="6032897" y="4541416"/>
+            <a:ext cx="0" cy="307851"/>
+          </a:xfrm>
+          <a:prstGeom prst="line">
+            <a:avLst/>
+          </a:prstGeom>
+          <a:noFill/>
+          <a:ln w="7144">
+            <a:solidFill>
+              <a:srgbClr val="000000"/>
+            </a:solidFill>
+            <a:prstDash val="solid"/>
+          </a:ln>
+        </p:spPr>
+      </p:sp>
+      <p:sp>
+        <p:nvSpPr>
+          <p:cNvPr id="54" name="Text 46"/>
+          <p:cNvSpPr/>
+          <p:nvPr/>
+        </p:nvSpPr>
+        <p:spPr>
+          <a:xfrm>
+            <a:off x="6136481" y="4541416"/>
+            <a:ext cx="2717197" cy="91440"/>
+          </a:xfrm>
+          <a:prstGeom prst="rect">
+            <a:avLst/>
+          </a:prstGeom>
+          <a:noFill/>
+          <a:ln/>
+        </p:spPr>
+        <p:txBody>
+          <a:bodyPr wrap="square" lIns="0" tIns="0" rIns="0" bIns="0" rtlCol="0" anchor="t">
+            <a:normAutofit/>
+          </a:bodyPr>
+          <a:lstStyle/>
+          <a:p>
+            <a:pPr algn="l" indent="0" marL="0">
+              <a:lnSpc>
+                <a:spcPts val="759"/>
+              </a:lnSpc>
+              <a:buNone/>
+            </a:pPr>
+            <a:r>
+              <a:rPr lang="en-US" sz="800" b="1" spc="91" kern="0" dirty="0">
                 <a:solidFill>
                   <a:srgbClr val="000000"/>
                 </a:solidFill>
@@ -6998,7 +8026,7 @@
                 <a:ea typeface="Liberation Sans Narrow" pitchFamily="34" charset="-122"/>
                 <a:cs typeface="Liberation Sans Narrow" pitchFamily="34" charset="-120"/>
               </a:rPr>
-              <a:t>12-MONTH ANNUAL PARTNERSHIP</a:t>
+              <a:t>12 MONTHLY + 24 WHATSAPP DROPS</a:t>
             </a:r>
             <a:endParaRPr lang="en-US" sz="800" dirty="0"/>
           </a:p>
@@ -7006,14 +8034,56 @@
       </p:sp>
       <p:sp>
         <p:nvSpPr>
-          <p:cNvPr id="30" name="Text 28"/>
-          <p:cNvSpPr/>
-          <p:nvPr/>
-        </p:nvSpPr>
-        <p:spPr>
-          <a:xfrm>
-            <a:off x="8237190" y="4843463"/>
-            <a:ext cx="687341" cy="164592"/>
+          <p:cNvPr id="55" name="Text 47"/>
+          <p:cNvSpPr/>
+          <p:nvPr/>
+        </p:nvSpPr>
+        <p:spPr>
+          <a:xfrm>
+            <a:off x="6136481" y="4645000"/>
+            <a:ext cx="2607469" cy="142615"/>
+          </a:xfrm>
+          <a:prstGeom prst="rect">
+            <a:avLst/>
+          </a:prstGeom>
+          <a:noFill/>
+          <a:ln/>
+        </p:spPr>
+        <p:txBody>
+          <a:bodyPr wrap="square" lIns="0" tIns="0" rIns="0" bIns="0" rtlCol="0" anchor="t"/>
+          <a:lstStyle/>
+          <a:p>
+            <a:pPr algn="l" indent="0" marL="0">
+              <a:lnSpc>
+                <a:spcPts val="804"/>
+              </a:lnSpc>
+              <a:buNone/>
+            </a:pPr>
+            <a:r>
+              <a:rPr lang="en-US" sz="619" dirty="0">
+                <a:solidFill>
+                  <a:srgbClr val="555555"/>
+                </a:solidFill>
+                <a:latin typeface="Carlito" pitchFamily="34" charset="0"/>
+                <a:ea typeface="Carlito" pitchFamily="34" charset="-122"/>
+                <a:cs typeface="Carlito" pitchFamily="34" charset="-120"/>
+              </a:rPr>
+              <a:t>Always-on digital keeps AliExpress visible between events</a:t>
+            </a:r>
+            <a:endParaRPr lang="en-US" sz="619" dirty="0"/>
+          </a:p>
+        </p:txBody>
+      </p:sp>
+      <p:sp>
+        <p:nvSpPr>
+          <p:cNvPr id="56" name="Text 48"/>
+          <p:cNvSpPr/>
+          <p:nvPr/>
+        </p:nvSpPr>
+        <p:spPr>
+          <a:xfrm>
+            <a:off x="400050" y="4868466"/>
+            <a:ext cx="7917396" cy="164592"/>
           </a:xfrm>
           <a:prstGeom prst="rect">
             <a:avLst/>
@@ -7027,12 +8097,54 @@
           <a:p>
             <a:pPr algn="l" indent="0" marL="0">
               <a:lnSpc>
-                <a:spcPts val="1013"/>
-              </a:lnSpc>
-              <a:buNone/>
-            </a:pPr>
-            <a:r>
-              <a:rPr lang="en-US" sz="800" spc="135" kern="0" dirty="0">
+                <a:spcPts val="928"/>
+              </a:lnSpc>
+              <a:buNone/>
+            </a:pPr>
+            <a:r>
+              <a:rPr lang="en-US" sz="800" spc="124" kern="0" dirty="0">
+                <a:solidFill>
+                  <a:srgbClr val="000000"/>
+                </a:solidFill>
+                <a:latin typeface="Carlito" pitchFamily="34" charset="0"/>
+                <a:ea typeface="Carlito" pitchFamily="34" charset="-122"/>
+                <a:cs typeface="Carlito" pitchFamily="34" charset="-120"/>
+              </a:rPr>
+              <a:t>12-MONTH ANNUAL PARTNERSHIP · LLM-THEMED CALENDAR</a:t>
+            </a:r>
+            <a:endParaRPr lang="en-US" sz="800" dirty="0"/>
+          </a:p>
+        </p:txBody>
+      </p:sp>
+      <p:sp>
+        <p:nvSpPr>
+          <p:cNvPr id="57" name="Text 49"/>
+          <p:cNvSpPr/>
+          <p:nvPr/>
+        </p:nvSpPr>
+        <p:spPr>
+          <a:xfrm>
+            <a:off x="8331733" y="4868466"/>
+            <a:ext cx="624379" cy="164592"/>
+          </a:xfrm>
+          <a:prstGeom prst="rect">
+            <a:avLst/>
+          </a:prstGeom>
+          <a:noFill/>
+          <a:ln/>
+        </p:spPr>
+        <p:txBody>
+          <a:bodyPr wrap="none" lIns="0" tIns="0" rIns="0" bIns="0" rtlCol="0" anchor="t"/>
+          <a:lstStyle/>
+          <a:p>
+            <a:pPr algn="l" indent="0" marL="0">
+              <a:lnSpc>
+                <a:spcPts val="928"/>
+              </a:lnSpc>
+              <a:buNone/>
+            </a:pPr>
+            <a:r>
+              <a:rPr lang="en-US" sz="800" spc="124" kern="0" dirty="0">
                 <a:solidFill>
                   <a:srgbClr val="000000"/>
                 </a:solidFill>
@@ -7048,70 +8160,225 @@
       </p:sp>
       <p:sp>
         <p:nvSpPr>
-          <p:cNvPr id="31" name="Text 29"/>
-          <p:cNvSpPr/>
-          <p:nvPr/>
-        </p:nvSpPr>
-        <p:spPr>
-          <a:xfrm>
-            <a:off x="1042988" y="1932384"/>
-            <a:ext cx="200025" cy="200025"/>
-          </a:xfrm>
-          <a:prstGeom prst="rect">
-            <a:avLst/>
-          </a:prstGeom>
-          <a:noFill/>
-          <a:ln/>
-        </p:spPr>
-        <p:txBody>
-          <a:bodyPr wrap="none" lIns="0" tIns="0" rIns="0" bIns="0" rtlCol="0" anchor="ctr"/>
-          <a:lstStyle/>
-          <a:p>
-            <a:pPr algn="ctr" indent="0" marL="0">
-              <a:buNone/>
-            </a:pPr>
-            <a:r>
-              <a:rPr lang="en-US" sz="1969" dirty="0">
-                <a:solidFill>
-                  <a:srgbClr val="FF005A"/>
-                </a:solidFill>
-                <a:latin typeface="Segoe UI Symbol" pitchFamily="34" charset="0"/>
-                <a:ea typeface="Segoe UI Symbol" pitchFamily="34" charset="-122"/>
-                <a:cs typeface="Segoe UI Symbol" pitchFamily="34" charset="-120"/>
-              </a:rPr>
-              <a:t>➤</a:t>
-            </a:r>
-            <a:endParaRPr lang="en-US" sz="1969" dirty="0"/>
-          </a:p>
-        </p:txBody>
-      </p:sp>
-      <p:sp>
-        <p:nvSpPr>
-          <p:cNvPr id="32" name="Text 30"/>
-          <p:cNvSpPr/>
-          <p:nvPr/>
-        </p:nvSpPr>
-        <p:spPr>
-          <a:xfrm>
-            <a:off x="1092994" y="2189559"/>
-            <a:ext cx="100013" cy="100013"/>
-          </a:xfrm>
-          <a:prstGeom prst="ellipse">
-            <a:avLst/>
+          <p:cNvPr id="58" name="Text 50"/>
+          <p:cNvSpPr/>
+          <p:nvPr/>
+        </p:nvSpPr>
+        <p:spPr>
+          <a:xfrm>
+            <a:off x="462915" y="1309083"/>
+            <a:ext cx="653385" cy="196025"/>
+          </a:xfrm>
+          <a:prstGeom prst="roundRect">
+            <a:avLst>
+              <a:gd name="adj" fmla="val 14577"/>
+            </a:avLst>
           </a:prstGeom>
           <a:solidFill>
             <a:srgbClr val="FF005A"/>
           </a:solidFill>
           <a:ln/>
+        </p:spPr>
+        <p:txBody>
+          <a:bodyPr wrap="square" rtlCol="0" anchor="ctr"/>
+          <a:lstStyle/>
+          <a:p>
+            <a:pPr indent="0" marL="0">
+              <a:buNone/>
+            </a:pPr>
+            <a:endParaRPr lang="en-US" dirty="0"/>
+          </a:p>
+        </p:txBody>
+      </p:sp>
+      <p:sp>
+        <p:nvSpPr>
+          <p:cNvPr id="59" name="Text 51"/>
+          <p:cNvSpPr/>
+          <p:nvPr/>
+        </p:nvSpPr>
+        <p:spPr>
+          <a:xfrm>
+            <a:off x="485775" y="1319585"/>
+            <a:ext cx="607665" cy="175022"/>
+          </a:xfrm>
+          <a:prstGeom prst="rect">
+            <a:avLst/>
+          </a:prstGeom>
+          <a:noFill/>
+          <a:ln/>
+        </p:spPr>
+        <p:txBody>
+          <a:bodyPr wrap="none" lIns="0" tIns="0" rIns="0" bIns="0" rtlCol="0" anchor="ctr"/>
+          <a:lstStyle/>
+          <a:p>
+            <a:pPr algn="ctr" indent="0" marL="0">
+              <a:lnSpc>
+                <a:spcPts val="928"/>
+              </a:lnSpc>
+              <a:buNone/>
+            </a:pPr>
+            <a:r>
+              <a:rPr lang="en-US" sz="800" b="1" spc="93" kern="0" dirty="0">
+                <a:solidFill>
+                  <a:srgbClr val="FFFFFF"/>
+                </a:solidFill>
+                <a:latin typeface="Liberation Sans Narrow" pitchFamily="34" charset="0"/>
+                <a:ea typeface="Liberation Sans Narrow" pitchFamily="34" charset="-122"/>
+                <a:cs typeface="Liberation Sans Narrow" pitchFamily="34" charset="-120"/>
+              </a:rPr>
+              <a:t>M2 · FEB</a:t>
+            </a:r>
+            <a:endParaRPr lang="en-US" sz="800" dirty="0"/>
+          </a:p>
+        </p:txBody>
+      </p:sp>
+      <p:sp>
+        <p:nvSpPr>
+          <p:cNvPr id="60" name="Text 52"/>
+          <p:cNvSpPr/>
+          <p:nvPr/>
+        </p:nvSpPr>
+        <p:spPr>
+          <a:xfrm>
+            <a:off x="2634459" y="1309083"/>
+            <a:ext cx="419517" cy="196025"/>
+          </a:xfrm>
+          <a:prstGeom prst="roundRect">
+            <a:avLst>
+              <a:gd name="adj" fmla="val 14577"/>
+            </a:avLst>
+          </a:prstGeom>
+          <a:solidFill>
+            <a:srgbClr val="6F42C1"/>
+          </a:solidFill>
+          <a:ln/>
+        </p:spPr>
+        <p:txBody>
+          <a:bodyPr wrap="square" rtlCol="0" anchor="ctr"/>
+          <a:lstStyle/>
+          <a:p>
+            <a:pPr indent="0" marL="0">
+              <a:buNone/>
+            </a:pPr>
+            <a:endParaRPr lang="en-US" dirty="0"/>
+          </a:p>
+        </p:txBody>
+      </p:sp>
+      <p:sp>
+        <p:nvSpPr>
+          <p:cNvPr id="61" name="Text 53"/>
+          <p:cNvSpPr/>
+          <p:nvPr/>
+        </p:nvSpPr>
+        <p:spPr>
+          <a:xfrm>
+            <a:off x="2649996" y="1319585"/>
+            <a:ext cx="388441" cy="175022"/>
+          </a:xfrm>
+          <a:prstGeom prst="rect">
+            <a:avLst/>
+          </a:prstGeom>
+          <a:noFill/>
+          <a:ln/>
+        </p:spPr>
+        <p:txBody>
+          <a:bodyPr wrap="none" lIns="0" tIns="0" rIns="0" bIns="0" rtlCol="0" anchor="ctr"/>
+          <a:lstStyle/>
+          <a:p>
+            <a:pPr algn="ctr" indent="0" marL="0">
+              <a:lnSpc>
+                <a:spcPts val="928"/>
+              </a:lnSpc>
+              <a:buNone/>
+            </a:pPr>
+            <a:r>
+              <a:rPr lang="en-US" sz="800" b="1" spc="-6" kern="0" dirty="0">
+                <a:solidFill>
+                  <a:srgbClr val="FFFFFF"/>
+                </a:solidFill>
+                <a:latin typeface="Carlito" pitchFamily="34" charset="0"/>
+                <a:ea typeface="Carlito" pitchFamily="34" charset="-122"/>
+                <a:cs typeface="Carlito" pitchFamily="34" charset="-120"/>
+              </a:rPr>
+              <a:t>Qwen</a:t>
+            </a:r>
+            <a:endParaRPr lang="en-US" sz="800" dirty="0"/>
+          </a:p>
+        </p:txBody>
+      </p:sp>
+      <p:sp>
+        <p:nvSpPr>
+          <p:cNvPr id="62" name="Text 54"/>
+          <p:cNvSpPr/>
+          <p:nvPr/>
+        </p:nvSpPr>
+        <p:spPr>
+          <a:xfrm>
+            <a:off x="500063" y="1451967"/>
+            <a:ext cx="2524088" cy="277749"/>
+          </a:xfrm>
+          <a:prstGeom prst="rect">
+            <a:avLst/>
+          </a:prstGeom>
+          <a:noFill/>
+          <a:ln/>
           <a:effectLst>
-            <a:outerShdw sx="100000" sy="100000" kx="0" ky="0" algn="bl" rotWithShape="0" blurRad="101600" dist="50800" dir="16200000">
-              <a:srgbClr val="FFFFFF">
-                <a:alpha val="50000"/>
+            <a:outerShdw sx="100000" sy="100000" kx="0" ky="0" algn="bl" rotWithShape="0" blurRad="38100" dist="9525" dir="5400000">
+              <a:srgbClr val="000000">
+                <a:alpha val="40000"/>
               </a:srgbClr>
             </a:outerShdw>
           </a:effectLst>
         </p:spPr>
         <p:txBody>
+          <a:bodyPr wrap="square" lIns="0" tIns="0" rIns="0" bIns="0" rtlCol="0" anchor="t"/>
+          <a:lstStyle/>
+          <a:p>
+            <a:pPr algn="l" indent="0" marL="0">
+              <a:lnSpc>
+                <a:spcPts val="1013"/>
+              </a:lnSpc>
+              <a:buNone/>
+            </a:pPr>
+            <a:r>
+              <a:rPr lang="en-US" sz="844" b="1" spc="-8" kern="0" dirty="0">
+                <a:solidFill>
+                  <a:srgbClr val="FFFFFF"/>
+                </a:solidFill>
+                <a:latin typeface="Carlito" pitchFamily="34" charset="0"/>
+                <a:ea typeface="Carlito" pitchFamily="34" charset="-122"/>
+                <a:cs typeface="Carlito" pitchFamily="34" charset="-120"/>
+              </a:rPr>
+              <a:t>Qwen Unveiled — Agentic Commerce at Scale</a:t>
+            </a:r>
+            <a:endParaRPr lang="en-US" sz="844" dirty="0"/>
+          </a:p>
+        </p:txBody>
+      </p:sp>
+      <p:sp>
+        <p:nvSpPr>
+          <p:cNvPr id="63" name="Text 55"/>
+          <p:cNvSpPr/>
+          <p:nvPr/>
+        </p:nvSpPr>
+        <p:spPr>
+          <a:xfrm>
+            <a:off x="3265609" y="1301940"/>
+            <a:ext cx="664994" cy="196025"/>
+          </a:xfrm>
+          <a:prstGeom prst="roundRect">
+            <a:avLst>
+              <a:gd name="adj" fmla="val 14577"/>
+            </a:avLst>
+          </a:prstGeom>
+          <a:solidFill>
+            <a:srgbClr val="000000">
+              <a:alpha val="70000"/>
+            </a:srgbClr>
+          </a:solidFill>
+          <a:ln/>
+        </p:spPr>
+        <p:txBody>
           <a:bodyPr wrap="square" rtlCol="0" anchor="ctr"/>
           <a:lstStyle/>
           <a:p>
@@ -7124,14 +8391,14 @@
       </p:sp>
       <p:sp>
         <p:nvSpPr>
-          <p:cNvPr id="33" name="Text 31"/>
-          <p:cNvSpPr/>
-          <p:nvPr/>
-        </p:nvSpPr>
-        <p:spPr>
-          <a:xfrm>
-            <a:off x="2414588" y="1932384"/>
-            <a:ext cx="200025" cy="200025"/>
+          <p:cNvPr id="64" name="Text 56"/>
+          <p:cNvSpPr/>
+          <p:nvPr/>
+        </p:nvSpPr>
+        <p:spPr>
+          <a:xfrm>
+            <a:off x="3288469" y="1312441"/>
+            <a:ext cx="619274" cy="175022"/>
           </a:xfrm>
           <a:prstGeom prst="rect">
             <a:avLst/>
@@ -7144,50 +8411,173 @@
           <a:lstStyle/>
           <a:p>
             <a:pPr algn="ctr" indent="0" marL="0">
-              <a:buNone/>
-            </a:pPr>
-            <a:r>
-              <a:rPr lang="en-US" sz="1969" dirty="0">
-                <a:solidFill>
-                  <a:srgbClr val="FF005A"/>
-                </a:solidFill>
-                <a:latin typeface="Segoe UI Symbol" pitchFamily="34" charset="0"/>
-                <a:ea typeface="Segoe UI Symbol" pitchFamily="34" charset="-122"/>
-                <a:cs typeface="Segoe UI Symbol" pitchFamily="34" charset="-120"/>
-              </a:rPr>
-              <a:t>◆</a:t>
-            </a:r>
-            <a:endParaRPr lang="en-US" sz="1969" dirty="0"/>
-          </a:p>
-        </p:txBody>
-      </p:sp>
-      <p:sp>
-        <p:nvSpPr>
-          <p:cNvPr id="34" name="Text 32"/>
-          <p:cNvSpPr/>
-          <p:nvPr/>
-        </p:nvSpPr>
-        <p:spPr>
-          <a:xfrm>
-            <a:off x="2464594" y="2189559"/>
-            <a:ext cx="100013" cy="100013"/>
-          </a:xfrm>
-          <a:prstGeom prst="ellipse">
-            <a:avLst/>
+              <a:lnSpc>
+                <a:spcPts val="928"/>
+              </a:lnSpc>
+              <a:buNone/>
+            </a:pPr>
+            <a:r>
+              <a:rPr lang="en-US" sz="800" b="1" spc="93" kern="0" dirty="0">
+                <a:solidFill>
+                  <a:srgbClr val="FFFFFF"/>
+                </a:solidFill>
+                <a:latin typeface="Liberation Sans Narrow" pitchFamily="34" charset="0"/>
+                <a:ea typeface="Liberation Sans Narrow" pitchFamily="34" charset="-122"/>
+                <a:cs typeface="Liberation Sans Narrow" pitchFamily="34" charset="-120"/>
+              </a:rPr>
+              <a:t>M4 · APR</a:t>
+            </a:r>
+            <a:endParaRPr lang="en-US" sz="800" dirty="0"/>
+          </a:p>
+        </p:txBody>
+      </p:sp>
+      <p:sp>
+        <p:nvSpPr>
+          <p:cNvPr id="65" name="Text 57"/>
+          <p:cNvSpPr/>
+          <p:nvPr/>
+        </p:nvSpPr>
+        <p:spPr>
+          <a:xfrm>
+            <a:off x="5449351" y="1301940"/>
+            <a:ext cx="421687" cy="196025"/>
+          </a:xfrm>
+          <a:prstGeom prst="roundRect">
+            <a:avLst>
+              <a:gd name="adj" fmla="val 14577"/>
+            </a:avLst>
           </a:prstGeom>
           <a:solidFill>
-            <a:srgbClr val="FF005A"/>
+            <a:srgbClr val="10A37F"/>
           </a:solidFill>
           <a:ln/>
+        </p:spPr>
+        <p:txBody>
+          <a:bodyPr wrap="square" rtlCol="0" anchor="ctr"/>
+          <a:lstStyle/>
+          <a:p>
+            <a:pPr indent="0" marL="0">
+              <a:buNone/>
+            </a:pPr>
+            <a:endParaRPr lang="en-US" dirty="0"/>
+          </a:p>
+        </p:txBody>
+      </p:sp>
+      <p:sp>
+        <p:nvSpPr>
+          <p:cNvPr id="66" name="Text 58"/>
+          <p:cNvSpPr/>
+          <p:nvPr/>
+        </p:nvSpPr>
+        <p:spPr>
+          <a:xfrm>
+            <a:off x="5464969" y="1312441"/>
+            <a:ext cx="390451" cy="175022"/>
+          </a:xfrm>
+          <a:prstGeom prst="rect">
+            <a:avLst/>
+          </a:prstGeom>
+          <a:noFill/>
+          <a:ln/>
+        </p:spPr>
+        <p:txBody>
+          <a:bodyPr wrap="none" lIns="0" tIns="0" rIns="0" bIns="0" rtlCol="0" anchor="ctr"/>
+          <a:lstStyle/>
+          <a:p>
+            <a:pPr algn="ctr" indent="0" marL="0">
+              <a:lnSpc>
+                <a:spcPts val="928"/>
+              </a:lnSpc>
+              <a:buNone/>
+            </a:pPr>
+            <a:r>
+              <a:rPr lang="en-US" sz="800" b="1" spc="-6" kern="0" dirty="0">
+                <a:solidFill>
+                  <a:srgbClr val="FFFFFF"/>
+                </a:solidFill>
+                <a:latin typeface="Liberation Sans Narrow" pitchFamily="34" charset="0"/>
+                <a:ea typeface="Liberation Sans Narrow" pitchFamily="34" charset="-122"/>
+                <a:cs typeface="Liberation Sans Narrow" pitchFamily="34" charset="-120"/>
+              </a:rPr>
+              <a:t>GPT-5</a:t>
+            </a:r>
+            <a:endParaRPr lang="en-US" sz="800" dirty="0"/>
+          </a:p>
+        </p:txBody>
+      </p:sp>
+      <p:sp>
+        <p:nvSpPr>
+          <p:cNvPr id="67" name="Text 59"/>
+          <p:cNvSpPr/>
+          <p:nvPr/>
+        </p:nvSpPr>
+        <p:spPr>
+          <a:xfrm>
+            <a:off x="3302757" y="1702668"/>
+            <a:ext cx="2733828" cy="138875"/>
+          </a:xfrm>
+          <a:prstGeom prst="rect">
+            <a:avLst/>
+          </a:prstGeom>
+          <a:noFill/>
+          <a:ln/>
           <a:effectLst>
-            <a:outerShdw sx="100000" sy="100000" kx="0" ky="0" algn="bl" rotWithShape="0" blurRad="101600" dist="50800" dir="16200000">
-              <a:srgbClr val="FFFFFF">
-                <a:alpha val="50000"/>
+            <a:outerShdw sx="100000" sy="100000" kx="0" ky="0" algn="bl" rotWithShape="0" blurRad="38100" dist="9525" dir="5400000">
+              <a:srgbClr val="000000">
+                <a:alpha val="40000"/>
               </a:srgbClr>
             </a:outerShdw>
           </a:effectLst>
         </p:spPr>
         <p:txBody>
+          <a:bodyPr wrap="square" lIns="0" tIns="0" rIns="0" bIns="0" rtlCol="0" anchor="t"/>
+          <a:lstStyle/>
+          <a:p>
+            <a:pPr algn="l" indent="0" marL="0">
+              <a:lnSpc>
+                <a:spcPts val="1013"/>
+              </a:lnSpc>
+              <a:buNone/>
+            </a:pPr>
+            <a:r>
+              <a:rPr lang="en-US" sz="844" b="1" spc="-8" kern="0" dirty="0">
+                <a:solidFill>
+                  <a:srgbClr val="FFFFFF"/>
+                </a:solidFill>
+                <a:latin typeface="Liberation Sans Narrow" pitchFamily="34" charset="0"/>
+                <a:ea typeface="Liberation Sans Narrow" pitchFamily="34" charset="-122"/>
+                <a:cs typeface="Liberation Sans Narrow" pitchFamily="34" charset="-120"/>
+              </a:rPr>
+              <a:t>GPT-5 Frontier — Reasoning &amp; Agents</a:t>
+            </a:r>
+            <a:endParaRPr lang="en-US" sz="844" dirty="0"/>
+          </a:p>
+        </p:txBody>
+      </p:sp>
+      <p:sp>
+        <p:nvSpPr>
+          <p:cNvPr id="68" name="Text 60"/>
+          <p:cNvSpPr/>
+          <p:nvPr/>
+        </p:nvSpPr>
+        <p:spPr>
+          <a:xfrm>
+            <a:off x="6075447" y="1301940"/>
+            <a:ext cx="644902" cy="196025"/>
+          </a:xfrm>
+          <a:prstGeom prst="roundRect">
+            <a:avLst>
+              <a:gd name="adj" fmla="val 14577"/>
+            </a:avLst>
+          </a:prstGeom>
+          <a:solidFill>
+            <a:srgbClr val="000000">
+              <a:alpha val="70000"/>
+            </a:srgbClr>
+          </a:solidFill>
+          <a:ln/>
+        </p:spPr>
+        <p:txBody>
           <a:bodyPr wrap="square" rtlCol="0" anchor="ctr"/>
           <a:lstStyle/>
           <a:p>
@@ -7200,14 +8590,14 @@
       </p:sp>
       <p:sp>
         <p:nvSpPr>
-          <p:cNvPr id="35" name="Text 33"/>
-          <p:cNvSpPr/>
-          <p:nvPr/>
-        </p:nvSpPr>
-        <p:spPr>
-          <a:xfrm>
-            <a:off x="3786188" y="1932384"/>
-            <a:ext cx="200025" cy="200025"/>
+          <p:cNvPr id="69" name="Text 61"/>
+          <p:cNvSpPr/>
+          <p:nvPr/>
+        </p:nvSpPr>
+        <p:spPr>
+          <a:xfrm>
+            <a:off x="6098307" y="1312441"/>
+            <a:ext cx="599182" cy="175022"/>
           </a:xfrm>
           <a:prstGeom prst="rect">
             <a:avLst/>
@@ -7220,50 +8610,173 @@
           <a:lstStyle/>
           <a:p>
             <a:pPr algn="ctr" indent="0" marL="0">
-              <a:buNone/>
-            </a:pPr>
-            <a:r>
-              <a:rPr lang="en-US" sz="1969" dirty="0">
-                <a:solidFill>
-                  <a:srgbClr val="FF005A"/>
-                </a:solidFill>
-                <a:latin typeface="Segoe UI Symbol" pitchFamily="34" charset="0"/>
-                <a:ea typeface="Segoe UI Symbol" pitchFamily="34" charset="-122"/>
-                <a:cs typeface="Segoe UI Symbol" pitchFamily="34" charset="-120"/>
-              </a:rPr>
-              <a:t>✦</a:t>
-            </a:r>
-            <a:endParaRPr lang="en-US" sz="1969" dirty="0"/>
-          </a:p>
-        </p:txBody>
-      </p:sp>
-      <p:sp>
-        <p:nvSpPr>
-          <p:cNvPr id="36" name="Text 34"/>
-          <p:cNvSpPr/>
-          <p:nvPr/>
-        </p:nvSpPr>
-        <p:spPr>
-          <a:xfrm>
-            <a:off x="3836194" y="2189559"/>
-            <a:ext cx="100013" cy="100013"/>
-          </a:xfrm>
-          <a:prstGeom prst="ellipse">
-            <a:avLst/>
+              <a:lnSpc>
+                <a:spcPts val="928"/>
+              </a:lnSpc>
+              <a:buNone/>
+            </a:pPr>
+            <a:r>
+              <a:rPr lang="en-US" sz="800" b="1" spc="93" kern="0" dirty="0">
+                <a:solidFill>
+                  <a:srgbClr val="FFFFFF"/>
+                </a:solidFill>
+                <a:latin typeface="Liberation Sans Narrow" pitchFamily="34" charset="0"/>
+                <a:ea typeface="Liberation Sans Narrow" pitchFamily="34" charset="-122"/>
+                <a:cs typeface="Liberation Sans Narrow" pitchFamily="34" charset="-120"/>
+              </a:rPr>
+              <a:t>M6 · JUN</a:t>
+            </a:r>
+            <a:endParaRPr lang="en-US" sz="800" dirty="0"/>
+          </a:p>
+        </p:txBody>
+      </p:sp>
+      <p:sp>
+        <p:nvSpPr>
+          <p:cNvPr id="70" name="Text 62"/>
+          <p:cNvSpPr/>
+          <p:nvPr/>
+        </p:nvSpPr>
+        <p:spPr>
+          <a:xfrm>
+            <a:off x="8206365" y="1301940"/>
+            <a:ext cx="476658" cy="196025"/>
+          </a:xfrm>
+          <a:prstGeom prst="roundRect">
+            <a:avLst>
+              <a:gd name="adj" fmla="val 14577"/>
+            </a:avLst>
           </a:prstGeom>
           <a:solidFill>
-            <a:srgbClr val="FF005A"/>
+            <a:srgbClr val="D97757"/>
           </a:solidFill>
           <a:ln/>
+        </p:spPr>
+        <p:txBody>
+          <a:bodyPr wrap="square" rtlCol="0" anchor="ctr"/>
+          <a:lstStyle/>
+          <a:p>
+            <a:pPr indent="0" marL="0">
+              <a:buNone/>
+            </a:pPr>
+            <a:endParaRPr lang="en-US" dirty="0"/>
+          </a:p>
+        </p:txBody>
+      </p:sp>
+      <p:sp>
+        <p:nvSpPr>
+          <p:cNvPr id="71" name="Text 63"/>
+          <p:cNvSpPr/>
+          <p:nvPr/>
+        </p:nvSpPr>
+        <p:spPr>
+          <a:xfrm>
+            <a:off x="8224019" y="1312441"/>
+            <a:ext cx="441350" cy="175022"/>
+          </a:xfrm>
+          <a:prstGeom prst="rect">
+            <a:avLst/>
+          </a:prstGeom>
+          <a:noFill/>
+          <a:ln/>
+        </p:spPr>
+        <p:txBody>
+          <a:bodyPr wrap="none" lIns="0" tIns="0" rIns="0" bIns="0" rtlCol="0" anchor="ctr"/>
+          <a:lstStyle/>
+          <a:p>
+            <a:pPr algn="ctr" indent="0" marL="0">
+              <a:lnSpc>
+                <a:spcPts val="928"/>
+              </a:lnSpc>
+              <a:buNone/>
+            </a:pPr>
+            <a:r>
+              <a:rPr lang="en-US" sz="800" b="1" spc="-6" kern="0" dirty="0">
+                <a:solidFill>
+                  <a:srgbClr val="FFFFFF"/>
+                </a:solidFill>
+                <a:latin typeface="Carlito" pitchFamily="34" charset="0"/>
+                <a:ea typeface="Carlito" pitchFamily="34" charset="-122"/>
+                <a:cs typeface="Carlito" pitchFamily="34" charset="-120"/>
+              </a:rPr>
+              <a:t>Claude</a:t>
+            </a:r>
+            <a:endParaRPr lang="en-US" sz="800" dirty="0"/>
+          </a:p>
+        </p:txBody>
+      </p:sp>
+      <p:sp>
+        <p:nvSpPr>
+          <p:cNvPr id="72" name="Text 64"/>
+          <p:cNvSpPr/>
+          <p:nvPr/>
+        </p:nvSpPr>
+        <p:spPr>
+          <a:xfrm>
+            <a:off x="6112594" y="1574081"/>
+            <a:ext cx="2538487" cy="277749"/>
+          </a:xfrm>
+          <a:prstGeom prst="rect">
+            <a:avLst/>
+          </a:prstGeom>
+          <a:noFill/>
+          <a:ln/>
           <a:effectLst>
-            <a:outerShdw sx="100000" sy="100000" kx="0" ky="0" algn="bl" rotWithShape="0" blurRad="101600" dist="50800" dir="16200000">
-              <a:srgbClr val="FFFFFF">
-                <a:alpha val="50000"/>
+            <a:outerShdw sx="100000" sy="100000" kx="0" ky="0" algn="bl" rotWithShape="0" blurRad="38100" dist="9525" dir="5400000">
+              <a:srgbClr val="000000">
+                <a:alpha val="40000"/>
               </a:srgbClr>
             </a:outerShdw>
           </a:effectLst>
         </p:spPr>
         <p:txBody>
+          <a:bodyPr wrap="square" lIns="0" tIns="0" rIns="0" bIns="0" rtlCol="0" anchor="t"/>
+          <a:lstStyle/>
+          <a:p>
+            <a:pPr algn="l" indent="0" marL="0">
+              <a:lnSpc>
+                <a:spcPts val="1013"/>
+              </a:lnSpc>
+              <a:buNone/>
+            </a:pPr>
+            <a:r>
+              <a:rPr lang="en-US" sz="844" b="1" spc="-8" kern="0" dirty="0">
+                <a:solidFill>
+                  <a:srgbClr val="FFFFFF"/>
+                </a:solidFill>
+                <a:latin typeface="Carlito" pitchFamily="34" charset="0"/>
+                <a:ea typeface="Carlito" pitchFamily="34" charset="-122"/>
+                <a:cs typeface="Carlito" pitchFamily="34" charset="-120"/>
+              </a:rPr>
+              <a:t>Claude Code Live — 200K Context Workshop</a:t>
+            </a:r>
+            <a:endParaRPr lang="en-US" sz="844" dirty="0"/>
+          </a:p>
+        </p:txBody>
+      </p:sp>
+      <p:sp>
+        <p:nvSpPr>
+          <p:cNvPr id="73" name="Text 65"/>
+          <p:cNvSpPr/>
+          <p:nvPr/>
+        </p:nvSpPr>
+        <p:spPr>
+          <a:xfrm>
+            <a:off x="455771" y="2916427"/>
+            <a:ext cx="672807" cy="196025"/>
+          </a:xfrm>
+          <a:prstGeom prst="roundRect">
+            <a:avLst>
+              <a:gd name="adj" fmla="val 14577"/>
+            </a:avLst>
+          </a:prstGeom>
+          <a:solidFill>
+            <a:srgbClr val="000000">
+              <a:alpha val="70000"/>
+            </a:srgbClr>
+          </a:solidFill>
+          <a:ln/>
+        </p:spPr>
+        <p:txBody>
           <a:bodyPr wrap="square" rtlCol="0" anchor="ctr"/>
           <a:lstStyle/>
           <a:p>
@@ -7276,14 +8789,14 @@
       </p:sp>
       <p:sp>
         <p:nvSpPr>
-          <p:cNvPr id="37" name="Text 35"/>
-          <p:cNvSpPr/>
-          <p:nvPr/>
-        </p:nvSpPr>
-        <p:spPr>
-          <a:xfrm>
-            <a:off x="5157788" y="1932384"/>
-            <a:ext cx="200025" cy="200025"/>
+          <p:cNvPr id="74" name="Text 66"/>
+          <p:cNvSpPr/>
+          <p:nvPr/>
+        </p:nvSpPr>
+        <p:spPr>
+          <a:xfrm>
+            <a:off x="478631" y="2926928"/>
+            <a:ext cx="627087" cy="175022"/>
           </a:xfrm>
           <a:prstGeom prst="rect">
             <a:avLst/>
@@ -7296,50 +8809,173 @@
           <a:lstStyle/>
           <a:p>
             <a:pPr algn="ctr" indent="0" marL="0">
-              <a:buNone/>
-            </a:pPr>
-            <a:r>
-              <a:rPr lang="en-US" sz="1969" dirty="0">
-                <a:solidFill>
-                  <a:srgbClr val="FF005A"/>
-                </a:solidFill>
-                <a:latin typeface="Segoe UI Symbol" pitchFamily="34" charset="0"/>
-                <a:ea typeface="Segoe UI Symbol" pitchFamily="34" charset="-122"/>
-                <a:cs typeface="Segoe UI Symbol" pitchFamily="34" charset="-120"/>
-              </a:rPr>
-              <a:t>✦</a:t>
-            </a:r>
-            <a:endParaRPr lang="en-US" sz="1969" dirty="0"/>
-          </a:p>
-        </p:txBody>
-      </p:sp>
-      <p:sp>
-        <p:nvSpPr>
-          <p:cNvPr id="38" name="Text 36"/>
-          <p:cNvSpPr/>
-          <p:nvPr/>
-        </p:nvSpPr>
-        <p:spPr>
-          <a:xfrm>
-            <a:off x="5207794" y="2189559"/>
-            <a:ext cx="100013" cy="100013"/>
-          </a:xfrm>
-          <a:prstGeom prst="ellipse">
-            <a:avLst/>
+              <a:lnSpc>
+                <a:spcPts val="928"/>
+              </a:lnSpc>
+              <a:buNone/>
+            </a:pPr>
+            <a:r>
+              <a:rPr lang="en-US" sz="800" b="1" spc="93" kern="0" dirty="0">
+                <a:solidFill>
+                  <a:srgbClr val="FFFFFF"/>
+                </a:solidFill>
+                <a:latin typeface="Liberation Sans Narrow" pitchFamily="34" charset="0"/>
+                <a:ea typeface="Liberation Sans Narrow" pitchFamily="34" charset="-122"/>
+                <a:cs typeface="Liberation Sans Narrow" pitchFamily="34" charset="-120"/>
+              </a:rPr>
+              <a:t>M8 · AUG</a:t>
+            </a:r>
+            <a:endParaRPr lang="en-US" sz="800" dirty="0"/>
+          </a:p>
+        </p:txBody>
+      </p:sp>
+      <p:sp>
+        <p:nvSpPr>
+          <p:cNvPr id="75" name="Text 67"/>
+          <p:cNvSpPr/>
+          <p:nvPr/>
+        </p:nvSpPr>
+        <p:spPr>
+          <a:xfrm>
+            <a:off x="2579961" y="2916427"/>
+            <a:ext cx="483529" cy="196025"/>
+          </a:xfrm>
+          <a:prstGeom prst="roundRect">
+            <a:avLst>
+              <a:gd name="adj" fmla="val 14577"/>
+            </a:avLst>
           </a:prstGeom>
           <a:solidFill>
-            <a:srgbClr val="FF005A"/>
+            <a:srgbClr val="4285F4"/>
           </a:solidFill>
           <a:ln/>
+        </p:spPr>
+        <p:txBody>
+          <a:bodyPr wrap="square" rtlCol="0" anchor="ctr"/>
+          <a:lstStyle/>
+          <a:p>
+            <a:pPr indent="0" marL="0">
+              <a:buNone/>
+            </a:pPr>
+            <a:endParaRPr lang="en-US" dirty="0"/>
+          </a:p>
+        </p:txBody>
+      </p:sp>
+      <p:sp>
+        <p:nvSpPr>
+          <p:cNvPr id="76" name="Text 68"/>
+          <p:cNvSpPr/>
+          <p:nvPr/>
+        </p:nvSpPr>
+        <p:spPr>
+          <a:xfrm>
+            <a:off x="2597869" y="2926928"/>
+            <a:ext cx="447712" cy="175022"/>
+          </a:xfrm>
+          <a:prstGeom prst="rect">
+            <a:avLst/>
+          </a:prstGeom>
+          <a:noFill/>
+          <a:ln/>
+        </p:spPr>
+        <p:txBody>
+          <a:bodyPr wrap="none" lIns="0" tIns="0" rIns="0" bIns="0" rtlCol="0" anchor="ctr"/>
+          <a:lstStyle/>
+          <a:p>
+            <a:pPr algn="ctr" indent="0" marL="0">
+              <a:lnSpc>
+                <a:spcPts val="928"/>
+              </a:lnSpc>
+              <a:buNone/>
+            </a:pPr>
+            <a:r>
+              <a:rPr lang="en-US" sz="800" b="1" spc="-6" kern="0" dirty="0">
+                <a:solidFill>
+                  <a:srgbClr val="FFFFFF"/>
+                </a:solidFill>
+                <a:latin typeface="Carlito" pitchFamily="34" charset="0"/>
+                <a:ea typeface="Carlito" pitchFamily="34" charset="-122"/>
+                <a:cs typeface="Carlito" pitchFamily="34" charset="-120"/>
+              </a:rPr>
+              <a:t>Gemini</a:t>
+            </a:r>
+            <a:endParaRPr lang="en-US" sz="800" dirty="0"/>
+          </a:p>
+        </p:txBody>
+      </p:sp>
+      <p:sp>
+        <p:nvSpPr>
+          <p:cNvPr id="77" name="Text 69"/>
+          <p:cNvSpPr/>
+          <p:nvPr/>
+        </p:nvSpPr>
+        <p:spPr>
+          <a:xfrm>
+            <a:off x="492919" y="3317156"/>
+            <a:ext cx="2733828" cy="138875"/>
+          </a:xfrm>
+          <a:prstGeom prst="rect">
+            <a:avLst/>
+          </a:prstGeom>
+          <a:noFill/>
+          <a:ln/>
           <a:effectLst>
-            <a:outerShdw sx="100000" sy="100000" kx="0" ky="0" algn="bl" rotWithShape="0" blurRad="101600" dist="50800" dir="16200000">
-              <a:srgbClr val="FFFFFF">
-                <a:alpha val="50000"/>
+            <a:outerShdw sx="100000" sy="100000" kx="0" ky="0" algn="bl" rotWithShape="0" blurRad="38100" dist="9525" dir="5400000">
+              <a:srgbClr val="000000">
+                <a:alpha val="40000"/>
               </a:srgbClr>
             </a:outerShdw>
           </a:effectLst>
         </p:spPr>
         <p:txBody>
+          <a:bodyPr wrap="square" lIns="0" tIns="0" rIns="0" bIns="0" rtlCol="0" anchor="t"/>
+          <a:lstStyle/>
+          <a:p>
+            <a:pPr algn="l" indent="0" marL="0">
+              <a:lnSpc>
+                <a:spcPts val="1013"/>
+              </a:lnSpc>
+              <a:buNone/>
+            </a:pPr>
+            <a:r>
+              <a:rPr lang="en-US" sz="844" b="1" spc="-8" kern="0" dirty="0">
+                <a:solidFill>
+                  <a:srgbClr val="FFFFFF"/>
+                </a:solidFill>
+                <a:latin typeface="Carlito" pitchFamily="34" charset="0"/>
+                <a:ea typeface="Carlito" pitchFamily="34" charset="-122"/>
+                <a:cs typeface="Carlito" pitchFamily="34" charset="-120"/>
+              </a:rPr>
+              <a:t>Gemini Multimodal — Vision + Vertex AI</a:t>
+            </a:r>
+            <a:endParaRPr lang="en-US" sz="844" dirty="0"/>
+          </a:p>
+        </p:txBody>
+      </p:sp>
+      <p:sp>
+        <p:nvSpPr>
+          <p:cNvPr id="78" name="Text 70"/>
+          <p:cNvSpPr/>
+          <p:nvPr/>
+        </p:nvSpPr>
+        <p:spPr>
+          <a:xfrm>
+            <a:off x="3265609" y="2916427"/>
+            <a:ext cx="730627" cy="196025"/>
+          </a:xfrm>
+          <a:prstGeom prst="roundRect">
+            <a:avLst>
+              <a:gd name="adj" fmla="val 14577"/>
+            </a:avLst>
+          </a:prstGeom>
+          <a:solidFill>
+            <a:srgbClr val="000000">
+              <a:alpha val="70000"/>
+            </a:srgbClr>
+          </a:solidFill>
+          <a:ln/>
+        </p:spPr>
+        <p:txBody>
           <a:bodyPr wrap="square" rtlCol="0" anchor="ctr"/>
           <a:lstStyle/>
           <a:p>
@@ -7352,14 +8988,14 @@
       </p:sp>
       <p:sp>
         <p:nvSpPr>
-          <p:cNvPr id="39" name="Text 37"/>
-          <p:cNvSpPr/>
-          <p:nvPr/>
-        </p:nvSpPr>
-        <p:spPr>
-          <a:xfrm>
-            <a:off x="6529388" y="1932384"/>
-            <a:ext cx="200025" cy="200025"/>
+          <p:cNvPr id="79" name="Text 71"/>
+          <p:cNvSpPr/>
+          <p:nvPr/>
+        </p:nvSpPr>
+        <p:spPr>
+          <a:xfrm>
+            <a:off x="3288469" y="2926928"/>
+            <a:ext cx="684907" cy="175022"/>
           </a:xfrm>
           <a:prstGeom prst="rect">
             <a:avLst/>
@@ -7372,50 +9008,173 @@
           <a:lstStyle/>
           <a:p>
             <a:pPr algn="ctr" indent="0" marL="0">
-              <a:buNone/>
-            </a:pPr>
-            <a:r>
-              <a:rPr lang="en-US" sz="1969" dirty="0">
-                <a:solidFill>
-                  <a:srgbClr val="FF005A"/>
-                </a:solidFill>
-                <a:latin typeface="Segoe UI Symbol" pitchFamily="34" charset="0"/>
-                <a:ea typeface="Segoe UI Symbol" pitchFamily="34" charset="-122"/>
-                <a:cs typeface="Segoe UI Symbol" pitchFamily="34" charset="-120"/>
-              </a:rPr>
-              <a:t>◯</a:t>
-            </a:r>
-            <a:endParaRPr lang="en-US" sz="1969" dirty="0"/>
-          </a:p>
-        </p:txBody>
-      </p:sp>
-      <p:sp>
-        <p:nvSpPr>
-          <p:cNvPr id="40" name="Text 38"/>
-          <p:cNvSpPr/>
-          <p:nvPr/>
-        </p:nvSpPr>
-        <p:spPr>
-          <a:xfrm>
-            <a:off x="6579394" y="2189559"/>
-            <a:ext cx="100013" cy="100013"/>
-          </a:xfrm>
-          <a:prstGeom prst="ellipse">
-            <a:avLst/>
+              <a:lnSpc>
+                <a:spcPts val="928"/>
+              </a:lnSpc>
+              <a:buNone/>
+            </a:pPr>
+            <a:r>
+              <a:rPr lang="en-US" sz="800" b="1" spc="93" kern="0" dirty="0">
+                <a:solidFill>
+                  <a:srgbClr val="FFFFFF"/>
+                </a:solidFill>
+                <a:latin typeface="Liberation Sans Narrow" pitchFamily="34" charset="0"/>
+                <a:ea typeface="Liberation Sans Narrow" pitchFamily="34" charset="-122"/>
+                <a:cs typeface="Liberation Sans Narrow" pitchFamily="34" charset="-120"/>
+              </a:rPr>
+              <a:t>M10 · OCT</a:t>
+            </a:r>
+            <a:endParaRPr lang="en-US" sz="800" dirty="0"/>
+          </a:p>
+        </p:txBody>
+      </p:sp>
+      <p:sp>
+        <p:nvSpPr>
+          <p:cNvPr id="80" name="Text 72"/>
+          <p:cNvSpPr/>
+          <p:nvPr/>
+        </p:nvSpPr>
+        <p:spPr>
+          <a:xfrm>
+            <a:off x="5351606" y="2916427"/>
+            <a:ext cx="523190" cy="196025"/>
+          </a:xfrm>
+          <a:prstGeom prst="roundRect">
+            <a:avLst>
+              <a:gd name="adj" fmla="val 14577"/>
+            </a:avLst>
           </a:prstGeom>
           <a:solidFill>
-            <a:srgbClr val="FF005A"/>
+            <a:srgbClr val="0467DF"/>
           </a:solidFill>
           <a:ln/>
+        </p:spPr>
+        <p:txBody>
+          <a:bodyPr wrap="square" rtlCol="0" anchor="ctr"/>
+          <a:lstStyle/>
+          <a:p>
+            <a:pPr indent="0" marL="0">
+              <a:buNone/>
+            </a:pPr>
+            <a:endParaRPr lang="en-US" dirty="0"/>
+          </a:p>
+        </p:txBody>
+      </p:sp>
+      <p:sp>
+        <p:nvSpPr>
+          <p:cNvPr id="81" name="Text 73"/>
+          <p:cNvSpPr/>
+          <p:nvPr/>
+        </p:nvSpPr>
+        <p:spPr>
+          <a:xfrm>
+            <a:off x="5370984" y="2926928"/>
+            <a:ext cx="484436" cy="175022"/>
+          </a:xfrm>
+          <a:prstGeom prst="rect">
+            <a:avLst/>
+          </a:prstGeom>
+          <a:noFill/>
+          <a:ln/>
+        </p:spPr>
+        <p:txBody>
+          <a:bodyPr wrap="none" lIns="0" tIns="0" rIns="0" bIns="0" rtlCol="0" anchor="ctr"/>
+          <a:lstStyle/>
+          <a:p>
+            <a:pPr algn="ctr" indent="0" marL="0">
+              <a:lnSpc>
+                <a:spcPts val="928"/>
+              </a:lnSpc>
+              <a:buNone/>
+            </a:pPr>
+            <a:r>
+              <a:rPr lang="en-US" sz="800" b="1" spc="-6" kern="0" dirty="0">
+                <a:solidFill>
+                  <a:srgbClr val="FFFFFF"/>
+                </a:solidFill>
+                <a:latin typeface="Liberation Sans Narrow" pitchFamily="34" charset="0"/>
+                <a:ea typeface="Liberation Sans Narrow" pitchFamily="34" charset="-122"/>
+                <a:cs typeface="Liberation Sans Narrow" pitchFamily="34" charset="-120"/>
+              </a:rPr>
+              <a:t>Llama 4</a:t>
+            </a:r>
+            <a:endParaRPr lang="en-US" sz="800" dirty="0"/>
+          </a:p>
+        </p:txBody>
+      </p:sp>
+      <p:sp>
+        <p:nvSpPr>
+          <p:cNvPr id="82" name="Text 74"/>
+          <p:cNvSpPr/>
+          <p:nvPr/>
+        </p:nvSpPr>
+        <p:spPr>
+          <a:xfrm>
+            <a:off x="3302757" y="3317156"/>
+            <a:ext cx="2733828" cy="138875"/>
+          </a:xfrm>
+          <a:prstGeom prst="rect">
+            <a:avLst/>
+          </a:prstGeom>
+          <a:noFill/>
+          <a:ln/>
           <a:effectLst>
-            <a:outerShdw sx="100000" sy="100000" kx="0" ky="0" algn="bl" rotWithShape="0" blurRad="101600" dist="50800" dir="16200000">
-              <a:srgbClr val="FFFFFF">
-                <a:alpha val="50000"/>
+            <a:outerShdw sx="100000" sy="100000" kx="0" ky="0" algn="bl" rotWithShape="0" blurRad="38100" dist="9525" dir="5400000">
+              <a:srgbClr val="000000">
+                <a:alpha val="40000"/>
               </a:srgbClr>
             </a:outerShdw>
           </a:effectLst>
         </p:spPr>
         <p:txBody>
+          <a:bodyPr wrap="square" lIns="0" tIns="0" rIns="0" bIns="0" rtlCol="0" anchor="t"/>
+          <a:lstStyle/>
+          <a:p>
+            <a:pPr algn="l" indent="0" marL="0">
+              <a:lnSpc>
+                <a:spcPts val="1013"/>
+              </a:lnSpc>
+              <a:buNone/>
+            </a:pPr>
+            <a:r>
+              <a:rPr lang="en-US" sz="844" b="1" spc="-8" kern="0" dirty="0">
+                <a:solidFill>
+                  <a:srgbClr val="FFFFFF"/>
+                </a:solidFill>
+                <a:latin typeface="Carlito" pitchFamily="34" charset="0"/>
+                <a:ea typeface="Carlito" pitchFamily="34" charset="-122"/>
+                <a:cs typeface="Carlito" pitchFamily="34" charset="-120"/>
+              </a:rPr>
+              <a:t>Llama Open Lab — Fine-Tune Your Own</a:t>
+            </a:r>
+            <a:endParaRPr lang="en-US" sz="844" dirty="0"/>
+          </a:p>
+        </p:txBody>
+      </p:sp>
+      <p:sp>
+        <p:nvSpPr>
+          <p:cNvPr id="83" name="Text 75"/>
+          <p:cNvSpPr/>
+          <p:nvPr/>
+        </p:nvSpPr>
+        <p:spPr>
+          <a:xfrm>
+            <a:off x="6075447" y="2916427"/>
+            <a:ext cx="729176" cy="196025"/>
+          </a:xfrm>
+          <a:prstGeom prst="roundRect">
+            <a:avLst>
+              <a:gd name="adj" fmla="val 14577"/>
+            </a:avLst>
+          </a:prstGeom>
+          <a:solidFill>
+            <a:srgbClr val="000000">
+              <a:alpha val="70000"/>
+            </a:srgbClr>
+          </a:solidFill>
+          <a:ln/>
+        </p:spPr>
+        <p:txBody>
           <a:bodyPr wrap="square" rtlCol="0" anchor="ctr"/>
           <a:lstStyle/>
           <a:p>
@@ -7428,14 +9187,14 @@
       </p:sp>
       <p:sp>
         <p:nvSpPr>
-          <p:cNvPr id="41" name="Text 39"/>
-          <p:cNvSpPr/>
-          <p:nvPr/>
-        </p:nvSpPr>
-        <p:spPr>
-          <a:xfrm>
-            <a:off x="7900988" y="1932384"/>
-            <a:ext cx="200025" cy="200025"/>
+          <p:cNvPr id="84" name="Text 76"/>
+          <p:cNvSpPr/>
+          <p:nvPr/>
+        </p:nvSpPr>
+        <p:spPr>
+          <a:xfrm>
+            <a:off x="6098307" y="2926928"/>
+            <a:ext cx="683456" cy="175022"/>
           </a:xfrm>
           <a:prstGeom prst="rect">
             <a:avLst/>
@@ -7448,57 +9207,138 @@
           <a:lstStyle/>
           <a:p>
             <a:pPr algn="ctr" indent="0" marL="0">
-              <a:buNone/>
-            </a:pPr>
-            <a:r>
-              <a:rPr lang="en-US" sz="1969" dirty="0">
-                <a:solidFill>
-                  <a:srgbClr val="FF005A"/>
-                </a:solidFill>
-                <a:latin typeface="Segoe UI Symbol" pitchFamily="34" charset="0"/>
-                <a:ea typeface="Segoe UI Symbol" pitchFamily="34" charset="-122"/>
-                <a:cs typeface="Segoe UI Symbol" pitchFamily="34" charset="-120"/>
-              </a:rPr>
-              <a:t>✦</a:t>
-            </a:r>
-            <a:endParaRPr lang="en-US" sz="1969" dirty="0"/>
-          </a:p>
-        </p:txBody>
-      </p:sp>
-      <p:sp>
-        <p:nvSpPr>
-          <p:cNvPr id="42" name="Text 40"/>
-          <p:cNvSpPr/>
-          <p:nvPr/>
-        </p:nvSpPr>
-        <p:spPr>
-          <a:xfrm>
-            <a:off x="7950994" y="2189559"/>
-            <a:ext cx="100013" cy="100013"/>
-          </a:xfrm>
-          <a:prstGeom prst="ellipse">
-            <a:avLst/>
-          </a:prstGeom>
-          <a:solidFill>
-            <a:srgbClr val="FF005A"/>
-          </a:solidFill>
+              <a:lnSpc>
+                <a:spcPts val="928"/>
+              </a:lnSpc>
+              <a:buNone/>
+            </a:pPr>
+            <a:r>
+              <a:rPr lang="en-US" sz="800" b="1" spc="93" kern="0" dirty="0">
+                <a:solidFill>
+                  <a:srgbClr val="FFFFFF"/>
+                </a:solidFill>
+                <a:latin typeface="Liberation Sans Narrow" pitchFamily="34" charset="0"/>
+                <a:ea typeface="Liberation Sans Narrow" pitchFamily="34" charset="-122"/>
+                <a:cs typeface="Liberation Sans Narrow" pitchFamily="34" charset="-120"/>
+              </a:rPr>
+              <a:t>M12 · DEC</a:t>
+            </a:r>
+            <a:endParaRPr lang="en-US" sz="800" dirty="0"/>
+          </a:p>
+        </p:txBody>
+      </p:sp>
+      <p:pic>
+        <p:nvPicPr>
+          <p:cNvPr id="85" name="Image 6" descr="preencoded.png">    </p:cNvPr>
+          <p:cNvPicPr>
+            <a:picLocks noChangeAspect="1"/>
+          </p:cNvPicPr>
+          <p:nvPr/>
+        </p:nvPicPr>
+        <p:blipFill>
+          <a:blip r:embed="rId7"/>
+          <a:stretch>
+            <a:fillRect/>
+          </a:stretch>
+        </p:blipFill>
+        <p:spPr>
+          <a:xfrm>
+            <a:off x="8004237" y="2926928"/>
+            <a:ext cx="661132" cy="175022"/>
+          </a:xfrm>
+          <a:prstGeom prst="rect">
+            <a:avLst/>
+          </a:prstGeom>
+        </p:spPr>
+      </p:pic>
+      <p:sp>
+        <p:nvSpPr>
+          <p:cNvPr id="86" name="Text 77"/>
+          <p:cNvSpPr/>
+          <p:nvPr/>
+        </p:nvSpPr>
+        <p:spPr>
+          <a:xfrm>
+            <a:off x="7966350" y="2926928"/>
+            <a:ext cx="736905" cy="175022"/>
+          </a:xfrm>
+          <a:prstGeom prst="rect">
+            <a:avLst/>
+          </a:prstGeom>
+          <a:noFill/>
+          <a:ln/>
+        </p:spPr>
+        <p:txBody>
+          <a:bodyPr wrap="none" lIns="0" tIns="0" rIns="0" bIns="0" rtlCol="0" anchor="ctr"/>
+          <a:lstStyle/>
+          <a:p>
+            <a:pPr algn="ctr" indent="0" marL="0">
+              <a:lnSpc>
+                <a:spcPts val="928"/>
+              </a:lnSpc>
+              <a:buNone/>
+            </a:pPr>
+            <a:r>
+              <a:rPr lang="en-US" sz="800" b="1" spc="-6" kern="0" dirty="0">
+                <a:solidFill>
+                  <a:srgbClr val="FFFFFF"/>
+                </a:solidFill>
+                <a:latin typeface="Carlito" pitchFamily="34" charset="0"/>
+                <a:ea typeface="Carlito" pitchFamily="34" charset="-122"/>
+                <a:cs typeface="Carlito" pitchFamily="34" charset="-120"/>
+              </a:rPr>
+              <a:t>Multi-Model</a:t>
+            </a:r>
+            <a:endParaRPr lang="en-US" sz="800" dirty="0"/>
+          </a:p>
+        </p:txBody>
+      </p:sp>
+      <p:sp>
+        <p:nvSpPr>
+          <p:cNvPr id="87" name="Text 78"/>
+          <p:cNvSpPr/>
+          <p:nvPr/>
+        </p:nvSpPr>
+        <p:spPr>
+          <a:xfrm>
+            <a:off x="6112594" y="3317156"/>
+            <a:ext cx="2733940" cy="138875"/>
+          </a:xfrm>
+          <a:prstGeom prst="rect">
+            <a:avLst/>
+          </a:prstGeom>
+          <a:noFill/>
           <a:ln/>
           <a:effectLst>
-            <a:outerShdw sx="100000" sy="100000" kx="0" ky="0" algn="bl" rotWithShape="0" blurRad="101600" dist="50800" dir="16200000">
-              <a:srgbClr val="FFFFFF">
-                <a:alpha val="50000"/>
+            <a:outerShdw sx="100000" sy="100000" kx="0" ky="0" algn="bl" rotWithShape="0" blurRad="38100" dist="9525" dir="5400000">
+              <a:srgbClr val="000000">
+                <a:alpha val="40000"/>
               </a:srgbClr>
             </a:outerShdw>
           </a:effectLst>
         </p:spPr>
         <p:txBody>
-          <a:bodyPr wrap="square" rtlCol="0" anchor="ctr"/>
-          <a:lstStyle/>
-          <a:p>
-            <a:pPr indent="0" marL="0">
-              <a:buNone/>
-            </a:pPr>
-            <a:endParaRPr lang="en-US" dirty="0"/>
+          <a:bodyPr wrap="square" lIns="0" tIns="0" rIns="0" bIns="0" rtlCol="0" anchor="t"/>
+          <a:lstStyle/>
+          <a:p>
+            <a:pPr algn="l" indent="0" marL="0">
+              <a:lnSpc>
+                <a:spcPts val="1013"/>
+              </a:lnSpc>
+              <a:buNone/>
+            </a:pPr>
+            <a:r>
+              <a:rPr lang="en-US" sz="844" b="1" spc="-8" kern="0" dirty="0">
+                <a:solidFill>
+                  <a:srgbClr val="FFFFFF"/>
+                </a:solidFill>
+                <a:latin typeface="Liberation Sans Narrow" pitchFamily="34" charset="0"/>
+                <a:ea typeface="Liberation Sans Narrow" pitchFamily="34" charset="-122"/>
+                <a:cs typeface="Liberation Sans Narrow" pitchFamily="34" charset="-120"/>
+              </a:rPr>
+              <a:t>Year-Cap Summit — The 2027 Roadmap</a:t>
+            </a:r>
+            <a:endParaRPr lang="en-US" sz="844" dirty="0"/>
           </a:p>
         </p:txBody>
       </p:sp>

</xml_diff>

<commit_message>
Slide 4 Qwen-only redesign + companion Session Agenda PDF
</commit_message>
<xml_diff>
--- a/public/AI-Salon-TelAviv-AliExpress-Sponsorship-Proposal.pptx
+++ b/public/AI-Salon-TelAviv-AliExpress-Sponsorship-Proposal.pptx
@@ -882,11 +882,11 @@
             <a:r>
               <a:rPr lang="en-US" dirty="0"/>
               <a:t>Speaker notes:
-- Open with the strategic positioning: every bi-monthly event is themed around a frontier LLM, so each one has a clear hook and a clear reason for the audience to attend.
-- The M2 Qwen flagship is the anchor — AliExpress's in-house LLM is the natural opener, demonstrating retail-commerce at scale and giving the community early API access. This positions AliExpress as a serious AI player, not just a marketplace.
-- Walk through the model lineup: GPT-5 reasoning, Claude's 200K context + agentic dev tools, Gemini multimodal, Llama open-source fine-tuning, and the M12 multi-model year-cap summit.
-- Emphasize the early-access layer: every event pairs the technical deep-dive with concrete perks — API credits, preview access, fine-tuning compute. $32K+ in community value over the year.
-- Close with the rhythm: 6 flagship events + 12 monthly email blasts + 24 WhatsApp community drops = continuous visibility for AliExpress, never just one-off moments.</a:t>
+- Open with the strategic positioning: the entire 12-month calendar is built exclusively around the Qwen model family — AliExpress's in-house LLM. This is the strongest possible brand alignment: every event is a Qwen event.
+- Walk through the Qwen lineup: M2 Qwen-Max flagship, M4 Qwen-VL-Max for vision, M6 Qwen-Coder for dev tools, M8 Qwen3 open weights for fine-tuning, M10 Qwen-Agent for production agents, M12 Qwen-Next roadmap preview.
+- Each event has a dedicated session with an AliExpress technical speaker — that's 6 sessions over the year, each one positioning AliExpress as a serious AI builder, not just a marketplace.
+- Emphasize the early-access layer: every event pairs the deep-dive with concrete perks — API credits, preview access, fine-tuning compute, closed-beta seats. Hundreds of dollars of community value per event.
+- Close with the rhythm: 6 flagship Qwen events + 12 monthly email blasts + 24 WhatsApp community drops = continuous visibility for AliExpress as the exclusive Qwen partner in Israel.</a:t>
             </a:r>
             <a:endParaRPr lang="en-US" dirty="0"/>
           </a:p>
@@ -2060,7 +2060,7 @@
       </p:sp>
       <p:pic>
         <p:nvPicPr>
-          <p:cNvPr id="11" name="Image 2" descr="/tmp/h2p-fit-1788201349274-djtvr4.png">    </p:cNvPr>
+          <p:cNvPr id="11" name="Image 2" descr="/tmp/h2p-fit-1788202050902-t5w6rd.png">    </p:cNvPr>
           <p:cNvPicPr>
             <a:picLocks noChangeAspect="1"/>
           </p:cNvPicPr>
@@ -5914,68 +5914,26 @@
                 <a:solidFill>
                   <a:srgbClr val="00E6FF"/>
                 </a:solidFill>
-                <a:latin typeface="Liberation Sans Narrow" pitchFamily="34" charset="0"/>
-                <a:ea typeface="Liberation Sans Narrow" pitchFamily="34" charset="-122"/>
-                <a:cs typeface="Liberation Sans Narrow" pitchFamily="34" charset="-120"/>
-              </a:rPr>
-              <a:t>12-MONTH LLM ACTIVATION CALENDAR</a:t>
-            </a:r>
-            <a:endParaRPr lang="en-US" sz="800" dirty="0"/>
-          </a:p>
-        </p:txBody>
-      </p:sp>
-      <p:sp>
-        <p:nvSpPr>
-          <p:cNvPr id="3" name="Text 1"/>
-          <p:cNvSpPr/>
-          <p:nvPr/>
-        </p:nvSpPr>
-        <p:spPr>
-          <a:xfrm>
-            <a:off x="400050" y="417909"/>
-            <a:ext cx="8636000" cy="275338"/>
-          </a:xfrm>
-          <a:prstGeom prst="rect">
-            <a:avLst/>
-          </a:prstGeom>
-          <a:noFill/>
-          <a:ln/>
-        </p:spPr>
-        <p:txBody>
-          <a:bodyPr wrap="square" lIns="0" tIns="0" rIns="0" bIns="0" rtlCol="0" anchor="t"/>
-          <a:lstStyle/>
-          <a:p>
-            <a:pPr algn="l" indent="0" marL="0">
-              <a:lnSpc>
-                <a:spcPts val="2008"/>
-              </a:lnSpc>
-              <a:buNone/>
-            </a:pPr>
-            <a:r>
-              <a:rPr lang="en-US" sz="1913" b="1" spc="-38" kern="0" dirty="0">
-                <a:solidFill>
-                  <a:srgbClr val="000000"/>
-                </a:solidFill>
                 <a:latin typeface="Carlito" pitchFamily="34" charset="0"/>
                 <a:ea typeface="Carlito" pitchFamily="34" charset="-122"/>
                 <a:cs typeface="Carlito" pitchFamily="34" charset="-120"/>
               </a:rPr>
-              <a:t>Six flagship events, each anchored by a frontier LLM</a:t>
-            </a:r>
-            <a:endParaRPr lang="en-US" sz="1913" dirty="0"/>
-          </a:p>
-        </p:txBody>
-      </p:sp>
-      <p:sp>
-        <p:nvSpPr>
-          <p:cNvPr id="4" name="Text 2"/>
-          <p:cNvSpPr/>
-          <p:nvPr/>
-        </p:nvSpPr>
-        <p:spPr>
-          <a:xfrm>
-            <a:off x="400050" y="730002"/>
-            <a:ext cx="5429250" cy="477159"/>
+              <a:t>12-MONTH QWEN ACTIVATION CALENDAR · ALIEXPRESS EXCLUSIVE</a:t>
+            </a:r>
+            <a:endParaRPr lang="en-US" sz="800" dirty="0"/>
+          </a:p>
+        </p:txBody>
+      </p:sp>
+      <p:sp>
+        <p:nvSpPr>
+          <p:cNvPr id="3" name="Text 1"/>
+          <p:cNvSpPr/>
+          <p:nvPr/>
+        </p:nvSpPr>
+        <p:spPr>
+          <a:xfrm>
+            <a:off x="400050" y="417909"/>
+            <a:ext cx="8636000" cy="275338"/>
           </a:xfrm>
           <a:prstGeom prst="rect">
             <a:avLst/>
@@ -5989,20 +5947,62 @@
           <a:p>
             <a:pPr algn="l" indent="0" marL="0">
               <a:lnSpc>
-                <a:spcPts val="1060"/>
-              </a:lnSpc>
-              <a:buNone/>
-            </a:pPr>
-            <a:r>
-              <a:rPr lang="en-US" sz="800" dirty="0">
-                <a:solidFill>
-                  <a:srgbClr val="6B6B6B"/>
+                <a:spcPts val="2008"/>
+              </a:lnSpc>
+              <a:buNone/>
+            </a:pPr>
+            <a:r>
+              <a:rPr lang="en-US" sz="1913" b="1" spc="-38" kern="0" dirty="0">
+                <a:solidFill>
+                  <a:srgbClr val="000000"/>
                 </a:solidFill>
                 <a:latin typeface="Carlito" pitchFamily="34" charset="0"/>
                 <a:ea typeface="Carlito" pitchFamily="34" charset="-122"/>
                 <a:cs typeface="Carlito" pitchFamily="34" charset="-120"/>
               </a:rPr>
-              <a:t>Bi-monthly flagship events themed around the world's leading AI models. AliExpress opens the Qwen flagship in Month 2 — its in-house retail-commerce LLM — and closes the year hosting a multi-model summit. Every event pairs a technical deep-dive with early-access benefits for the AI Salon TLV community.</a:t>
+              <a:t>Six flagship events, all anchored by the Qwen model family</a:t>
+            </a:r>
+            <a:endParaRPr lang="en-US" sz="1913" dirty="0"/>
+          </a:p>
+        </p:txBody>
+      </p:sp>
+      <p:sp>
+        <p:nvSpPr>
+          <p:cNvPr id="4" name="Text 2"/>
+          <p:cNvSpPr/>
+          <p:nvPr/>
+        </p:nvSpPr>
+        <p:spPr>
+          <a:xfrm>
+            <a:off x="400050" y="730002"/>
+            <a:ext cx="5429250" cy="477159"/>
+          </a:xfrm>
+          <a:prstGeom prst="rect">
+            <a:avLst/>
+          </a:prstGeom>
+          <a:noFill/>
+          <a:ln/>
+        </p:spPr>
+        <p:txBody>
+          <a:bodyPr wrap="square" lIns="0" tIns="0" rIns="0" bIns="0" rtlCol="0" anchor="t"/>
+          <a:lstStyle/>
+          <a:p>
+            <a:pPr algn="l" indent="0" marL="0">
+              <a:lnSpc>
+                <a:spcPts val="1060"/>
+              </a:lnSpc>
+              <a:buNone/>
+            </a:pPr>
+            <a:r>
+              <a:rPr lang="en-US" sz="800" dirty="0">
+                <a:solidFill>
+                  <a:srgbClr val="6B6B6B"/>
+                </a:solidFill>
+                <a:latin typeface="Carlito" pitchFamily="34" charset="0"/>
+                <a:ea typeface="Carlito" pitchFamily="34" charset="-122"/>
+                <a:cs typeface="Carlito" pitchFamily="34" charset="-120"/>
+              </a:rPr>
+              <a:t>An exclusive 12-month series built entirely around Alibaba's Qwen LLM family — Qwen-Max, Qwen-VL-Max, Qwen-Coder, Qwen3 open weights, Qwen-Agent, and a Qwen-Next preview. Each bi-monthly event pairs a technical deep-dive with a dedicated session and early-access benefits for the AI Salon TLV community.</a:t>
             </a:r>
             <a:endParaRPr lang="en-US" sz="800" dirty="0"/>
           </a:p>
@@ -6054,7 +6054,7 @@
         <p:spPr>
           <a:xfrm>
             <a:off x="414338" y="1248147"/>
-            <a:ext cx="2695538" cy="532433"/>
+            <a:ext cx="2695538" cy="373484"/>
           </a:xfrm>
           <a:prstGeom prst="rect">
             <a:avLst/>
@@ -6077,7 +6077,7 @@
       </p:sp>
       <p:pic>
         <p:nvPicPr>
-          <p:cNvPr id="7" name="Image 0" descr="/tmp/h2p-fit-1788201353088-lt6j5d.png">    </p:cNvPr>
+          <p:cNvPr id="7" name="Image 0" descr="/tmp/h2p-fit-1788202053802-3ughoe.png">    </p:cNvPr>
           <p:cNvPicPr>
             <a:picLocks noChangeAspect="1"/>
           </p:cNvPicPr>
@@ -6092,7 +6092,7 @@
         <p:spPr>
           <a:xfrm>
             <a:off x="414338" y="1248147"/>
-            <a:ext cx="2695538" cy="532433"/>
+            <a:ext cx="2695538" cy="373484"/>
           </a:xfrm>
           <a:prstGeom prst="rect">
             <a:avLst/>
@@ -6107,7 +6107,7 @@
         </p:nvSpPr>
         <p:spPr>
           <a:xfrm>
-            <a:off x="491490" y="1856446"/>
+            <a:off x="491490" y="1697498"/>
             <a:ext cx="970278" cy="184023"/>
           </a:xfrm>
           <a:prstGeom prst="roundRect">
@@ -6146,7 +6146,7 @@
         </p:nvSpPr>
         <p:spPr>
           <a:xfrm>
-            <a:off x="692944" y="1909167"/>
+            <a:off x="692944" y="1750219"/>
             <a:ext cx="681670" cy="120701"/>
           </a:xfrm>
           <a:prstGeom prst="rect">
@@ -6188,7 +6188,7 @@
         </p:nvSpPr>
         <p:spPr>
           <a:xfrm>
-            <a:off x="578644" y="1909167"/>
+            <a:off x="578644" y="1750219"/>
             <a:ext cx="91440" cy="91440"/>
           </a:xfrm>
           <a:prstGeom prst="rect">
@@ -6227,27 +6227,29 @@
         </p:nvSpPr>
         <p:spPr>
           <a:xfrm>
-            <a:off x="514350" y="2087761"/>
-            <a:ext cx="2495513" cy="660574"/>
-          </a:xfrm>
-          <a:prstGeom prst="rect">
-            <a:avLst/>
-          </a:prstGeom>
-          <a:noFill/>
-          <a:ln/>
-        </p:spPr>
-        <p:txBody>
-          <a:bodyPr wrap="square" lIns="0" tIns="0" rIns="0" bIns="0" rtlCol="0" anchor="t"/>
-          <a:lstStyle/>
-          <a:p>
-            <a:pPr algn="l" indent="0" marL="0">
-              <a:lnSpc>
-                <a:spcPts val="906"/>
-              </a:lnSpc>
-              <a:buNone/>
-            </a:pPr>
-            <a:r>
-              <a:rPr lang="en-US" sz="800" b="1" dirty="0">
+            <a:off x="514350" y="1928813"/>
+            <a:ext cx="2495513" cy="468166"/>
+          </a:xfrm>
+          <a:prstGeom prst="rect">
+            <a:avLst/>
+          </a:prstGeom>
+          <a:noFill/>
+          <a:ln/>
+        </p:spPr>
+        <p:txBody>
+          <a:bodyPr wrap="square" lIns="0" tIns="0" rIns="0" bIns="0" rtlCol="0" anchor="t">
+            <a:normAutofit/>
+          </a:bodyPr>
+          <a:lstStyle/>
+          <a:p>
+            <a:pPr algn="l" indent="0" marL="0">
+              <a:lnSpc>
+                <a:spcPts val="835"/>
+              </a:lnSpc>
+              <a:buNone/>
+            </a:pPr>
+            <a:r>
+              <a:rPr lang="en-US" sz="800" dirty="0">
                 <a:solidFill>
                   <a:srgbClr val="444444"/>
                 </a:solidFill>
@@ -6255,16 +6257,16 @@
                 <a:ea typeface="Carlito" pitchFamily="34" charset="-122"/>
                 <a:cs typeface="Carlito" pitchFamily="34" charset="-120"/>
               </a:rPr>
-              <a:t>AliExpress's in-house LLM.</a:t>
-            </a:r>
-            <a:pPr algn="l" indent="0" marL="0">
-              <a:lnSpc>
-                <a:spcPts val="906"/>
-              </a:lnSpc>
-              <a:buNone/>
-            </a:pPr>
-            <a:r>
-              <a:rPr lang="en-US" sz="800" dirty="0">
+              <a:t>Live demo of Qwen-Max powering agent-driven product discovery, cross-language search, and global catalog reasoning at marketplace scale. </a:t>
+            </a:r>
+            <a:pPr algn="l" indent="0" marL="0">
+              <a:lnSpc>
+                <a:spcPts val="835"/>
+              </a:lnSpc>
+              <a:buNone/>
+            </a:pPr>
+            <a:r>
+              <a:rPr lang="en-US" sz="800" b="1" dirty="0">
                 <a:solidFill>
                   <a:srgbClr val="444444"/>
                 </a:solidFill>
@@ -6272,16 +6274,16 @@
                 <a:ea typeface="Carlito" pitchFamily="34" charset="-122"/>
                 <a:cs typeface="Carlito" pitchFamily="34" charset="-120"/>
               </a:rPr>
-              <a:t> Live demo of Qwen-Max powering agent-driven product discovery, cross-language search, and global catalog reasoning at marketplace scale. </a:t>
-            </a:r>
-            <a:pPr algn="l" indent="0" marL="0">
-              <a:lnSpc>
-                <a:spcPts val="906"/>
-              </a:lnSpc>
-              <a:buNone/>
-            </a:pPr>
-            <a:r>
-              <a:rPr lang="en-US" sz="800" b="1" dirty="0">
+              <a:t>Community gets:</a:t>
+            </a:r>
+            <a:pPr algn="l" indent="0" marL="0">
+              <a:lnSpc>
+                <a:spcPts val="835"/>
+              </a:lnSpc>
+              <a:buNone/>
+            </a:pPr>
+            <a:r>
+              <a:rPr lang="en-US" sz="800" dirty="0">
                 <a:solidFill>
                   <a:srgbClr val="444444"/>
                 </a:solidFill>
@@ -6289,24 +6291,72 @@
                 <a:ea typeface="Carlito" pitchFamily="34" charset="-122"/>
                 <a:cs typeface="Carlito" pitchFamily="34" charset="-120"/>
               </a:rPr>
-              <a:t>Community gets:</a:t>
-            </a:r>
-            <a:pPr algn="l" indent="0" marL="0">
-              <a:lnSpc>
-                <a:spcPts val="906"/>
-              </a:lnSpc>
-              <a:buNone/>
-            </a:pPr>
-            <a:r>
-              <a:rPr lang="en-US" sz="800" dirty="0">
-                <a:solidFill>
-                  <a:srgbClr val="444444"/>
+              <a:t> private Qwen-Max API sandbox + $2K in credits.</a:t>
+            </a:r>
+            <a:endParaRPr lang="en-US" sz="800" dirty="0"/>
+          </a:p>
+        </p:txBody>
+      </p:sp>
+      <p:sp>
+        <p:nvSpPr>
+          <p:cNvPr id="12" name="Shape 9"/>
+          <p:cNvSpPr/>
+          <p:nvPr/>
+        </p:nvSpPr>
+        <p:spPr>
+          <a:xfrm>
+            <a:off x="514350" y="2427982"/>
+            <a:ext cx="2495513" cy="0"/>
+          </a:xfrm>
+          <a:prstGeom prst="line">
+            <a:avLst/>
+          </a:prstGeom>
+          <a:noFill/>
+          <a:ln w="7144">
+            <a:solidFill>
+              <a:srgbClr val="E5E5E5"/>
+            </a:solidFill>
+            <a:prstDash val="dash"/>
+          </a:ln>
+        </p:spPr>
+      </p:sp>
+      <p:sp>
+        <p:nvSpPr>
+          <p:cNvPr id="13" name="Text 10"/>
+          <p:cNvSpPr/>
+          <p:nvPr/>
+        </p:nvSpPr>
+        <p:spPr>
+          <a:xfrm>
+            <a:off x="514350" y="2460129"/>
+            <a:ext cx="607300" cy="176784"/>
+          </a:xfrm>
+          <a:prstGeom prst="rect">
+            <a:avLst/>
+          </a:prstGeom>
+          <a:noFill/>
+          <a:ln/>
+        </p:spPr>
+        <p:txBody>
+          <a:bodyPr wrap="none" lIns="0" tIns="7144" rIns="0" bIns="0" rtlCol="0" anchor="t"/>
+          <a:lstStyle/>
+          <a:p>
+            <a:pPr algn="l" indent="0" marL="0">
+              <a:lnSpc>
+                <a:spcPts val="759"/>
+              </a:lnSpc>
+              <a:buNone/>
+            </a:pPr>
+            <a:r>
+              <a:rPr lang="en-US" sz="800" b="1" spc="91" kern="0" dirty="0">
+                <a:solidFill>
+                  <a:srgbClr val="6F42C1"/>
                 </a:solidFill>
                 <a:latin typeface="Carlito" pitchFamily="34" charset="0"/>
                 <a:ea typeface="Carlito" pitchFamily="34" charset="-122"/>
                 <a:cs typeface="Carlito" pitchFamily="34" charset="-120"/>
               </a:rPr>
-              <a:t> private Qwen API sandbox + $2K in credits.</a:t>
+              <a:t>SESSION</a:t>
             </a:r>
             <a:endParaRPr lang="en-US" sz="800" dirty="0"/>
           </a:p>
@@ -6314,7 +6364,49 @@
       </p:sp>
       <p:sp>
         <p:nvSpPr>
-          <p:cNvPr id="12" name="Text 9"/>
+          <p:cNvPr id="14" name="Text 11"/>
+          <p:cNvSpPr/>
+          <p:nvPr/>
+        </p:nvSpPr>
+        <p:spPr>
+          <a:xfrm>
+            <a:off x="950565" y="2460129"/>
+            <a:ext cx="2059298" cy="202481"/>
+          </a:xfrm>
+          <a:prstGeom prst="rect">
+            <a:avLst/>
+          </a:prstGeom>
+          <a:noFill/>
+          <a:ln/>
+        </p:spPr>
+        <p:txBody>
+          <a:bodyPr wrap="square" lIns="0" tIns="0" rIns="0" bIns="0" rtlCol="0" anchor="t"/>
+          <a:lstStyle/>
+          <a:p>
+            <a:pPr algn="l" indent="0" marL="0">
+              <a:lnSpc>
+                <a:spcPts val="797"/>
+              </a:lnSpc>
+              <a:buNone/>
+            </a:pPr>
+            <a:r>
+              <a:rPr lang="en-US" sz="800" i="1" dirty="0">
+                <a:solidFill>
+                  <a:srgbClr val="333333"/>
+                </a:solidFill>
+                <a:latin typeface="Carlito" pitchFamily="34" charset="0"/>
+                <a:ea typeface="Carlito" pitchFamily="34" charset="-122"/>
+                <a:cs typeface="Carlito" pitchFamily="34" charset="-120"/>
+              </a:rPr>
+              <a:t>Qwen-Max in Production: Powering Agent-Driven Catalog Reasoning at AliExpress</a:t>
+            </a:r>
+            <a:endParaRPr lang="en-US" sz="800" dirty="0"/>
+          </a:p>
+        </p:txBody>
+      </p:sp>
+      <p:sp>
+        <p:nvSpPr>
+          <p:cNvPr id="15" name="Text 12"/>
           <p:cNvSpPr/>
           <p:nvPr/>
         </p:nvSpPr>
@@ -6351,14 +6443,14 @@
       </p:sp>
       <p:sp>
         <p:nvSpPr>
-          <p:cNvPr id="13" name="Text 10"/>
+          <p:cNvPr id="16" name="Text 13"/>
           <p:cNvSpPr/>
           <p:nvPr/>
         </p:nvSpPr>
         <p:spPr>
           <a:xfrm>
             <a:off x="3217032" y="1241003"/>
-            <a:ext cx="2709825" cy="661690"/>
+            <a:ext cx="2709825" cy="387772"/>
           </a:xfrm>
           <a:prstGeom prst="rect">
             <a:avLst/>
@@ -6381,7 +6473,7 @@
       </p:sp>
       <p:pic>
         <p:nvPicPr>
-          <p:cNvPr id="14" name="Image 1" descr="/tmp/h2p-fit-1788201353187-6bhycp.png">    </p:cNvPr>
+          <p:cNvPr id="17" name="Image 1" descr="/tmp/h2p-fit-1788202053918-i0t6wd.png">    </p:cNvPr>
           <p:cNvPicPr>
             <a:picLocks noChangeAspect="1"/>
           </p:cNvPicPr>
@@ -6396,7 +6488,7 @@
         <p:spPr>
           <a:xfrm>
             <a:off x="3217032" y="1241003"/>
-            <a:ext cx="2709825" cy="661690"/>
+            <a:ext cx="2709825" cy="387772"/>
           </a:xfrm>
           <a:prstGeom prst="rect">
             <a:avLst/>
@@ -6405,13 +6497,13 @@
       </p:pic>
       <p:sp>
         <p:nvSpPr>
-          <p:cNvPr id="15" name="Text 11"/>
-          <p:cNvSpPr/>
-          <p:nvPr/>
-        </p:nvSpPr>
-        <p:spPr>
-          <a:xfrm>
-            <a:off x="3294184" y="1978560"/>
+          <p:cNvPr id="18" name="Text 14"/>
+          <p:cNvSpPr/>
+          <p:nvPr/>
+        </p:nvSpPr>
+        <p:spPr>
+          <a:xfrm>
+            <a:off x="3294184" y="1704642"/>
             <a:ext cx="970278" cy="184023"/>
           </a:xfrm>
           <a:prstGeom prst="roundRect">
@@ -6444,13 +6536,13 @@
       </p:sp>
       <p:sp>
         <p:nvSpPr>
-          <p:cNvPr id="16" name="Text 12"/>
-          <p:cNvSpPr/>
-          <p:nvPr/>
-        </p:nvSpPr>
-        <p:spPr>
-          <a:xfrm>
-            <a:off x="3495638" y="2031281"/>
+          <p:cNvPr id="19" name="Text 15"/>
+          <p:cNvSpPr/>
+          <p:nvPr/>
+        </p:nvSpPr>
+        <p:spPr>
+          <a:xfrm>
+            <a:off x="3495638" y="1757363"/>
             <a:ext cx="681670" cy="120701"/>
           </a:xfrm>
           <a:prstGeom prst="rect">
@@ -6486,13 +6578,13 @@
       </p:sp>
       <p:sp>
         <p:nvSpPr>
-          <p:cNvPr id="17" name="Text 13"/>
-          <p:cNvSpPr/>
-          <p:nvPr/>
-        </p:nvSpPr>
-        <p:spPr>
-          <a:xfrm>
-            <a:off x="3381338" y="2031281"/>
+          <p:cNvPr id="20" name="Text 16"/>
+          <p:cNvSpPr/>
+          <p:nvPr/>
+        </p:nvSpPr>
+        <p:spPr>
+          <a:xfrm>
+            <a:off x="3381338" y="1757363"/>
             <a:ext cx="91440" cy="91440"/>
           </a:xfrm>
           <a:prstGeom prst="rect">
@@ -6525,28 +6617,30 @@
       </p:sp>
       <p:sp>
         <p:nvSpPr>
-          <p:cNvPr id="18" name="Text 14"/>
-          <p:cNvSpPr/>
-          <p:nvPr/>
-        </p:nvSpPr>
-        <p:spPr>
-          <a:xfrm>
-            <a:off x="3317044" y="2209874"/>
-            <a:ext cx="2509800" cy="545604"/>
-          </a:xfrm>
-          <a:prstGeom prst="rect">
-            <a:avLst/>
-          </a:prstGeom>
-          <a:noFill/>
-          <a:ln/>
-        </p:spPr>
-        <p:txBody>
-          <a:bodyPr wrap="square" lIns="0" tIns="0" rIns="0" bIns="0" rtlCol="0" anchor="t"/>
-          <a:lstStyle/>
-          <a:p>
-            <a:pPr algn="l" indent="0" marL="0">
-              <a:lnSpc>
-                <a:spcPts val="906"/>
+          <p:cNvPr id="21" name="Text 17"/>
+          <p:cNvSpPr/>
+          <p:nvPr/>
+        </p:nvSpPr>
+        <p:spPr>
+          <a:xfrm>
+            <a:off x="3317044" y="1935956"/>
+            <a:ext cx="2509800" cy="468166"/>
+          </a:xfrm>
+          <a:prstGeom prst="rect">
+            <a:avLst/>
+          </a:prstGeom>
+          <a:noFill/>
+          <a:ln/>
+        </p:spPr>
+        <p:txBody>
+          <a:bodyPr wrap="square" lIns="0" tIns="0" rIns="0" bIns="0" rtlCol="0" anchor="t">
+            <a:normAutofit/>
+          </a:bodyPr>
+          <a:lstStyle/>
+          <a:p>
+            <a:pPr algn="l" indent="0" marL="0">
+              <a:lnSpc>
+                <a:spcPts val="835"/>
               </a:lnSpc>
               <a:buNone/>
             </a:pPr>
@@ -6559,11 +6653,11 @@
                 <a:ea typeface="Carlito" pitchFamily="34" charset="-122"/>
                 <a:cs typeface="Carlito" pitchFamily="34" charset="-120"/>
               </a:rPr>
-              <a:t>OpenAI researcher on GPT-5 frontier reasoning, o3-style chain-of-thought, and agentic tool-use. </a:t>
-            </a:r>
-            <a:pPr algn="l" indent="0" marL="0">
-              <a:lnSpc>
-                <a:spcPts val="906"/>
+              <a:t>Qwen-VL-Max for retail: multimodal product understanding, image-based search, visual QA at catalog scale. </a:t>
+            </a:r>
+            <a:pPr algn="l" indent="0" marL="0">
+              <a:lnSpc>
+                <a:spcPts val="835"/>
               </a:lnSpc>
               <a:buNone/>
             </a:pPr>
@@ -6580,7 +6674,7 @@
             </a:r>
             <a:pPr algn="l" indent="0" marL="0">
               <a:lnSpc>
-                <a:spcPts val="906"/>
+                <a:spcPts val="835"/>
               </a:lnSpc>
               <a:buNone/>
             </a:pPr>
@@ -6593,7 +6687,7 @@
                 <a:ea typeface="Carlito" pitchFamily="34" charset="-122"/>
                 <a:cs typeface="Carlito" pitchFamily="34" charset="-120"/>
               </a:rPr>
-              <a:t> $5K in OpenAI API credits + early access to the Agents SDK for AI Salon TLV founders.</a:t>
+              <a:t> Qwen-VL-Max preview + sample retail vision dataset for benchmarks.</a:t>
             </a:r>
             <a:endParaRPr lang="en-US" sz="800" dirty="0"/>
           </a:p>
@@ -6601,7 +6695,114 @@
       </p:sp>
       <p:sp>
         <p:nvSpPr>
-          <p:cNvPr id="19" name="Text 15"/>
+          <p:cNvPr id="22" name="Shape 18"/>
+          <p:cNvSpPr/>
+          <p:nvPr/>
+        </p:nvSpPr>
+        <p:spPr>
+          <a:xfrm>
+            <a:off x="3317044" y="2435126"/>
+            <a:ext cx="2509800" cy="0"/>
+          </a:xfrm>
+          <a:prstGeom prst="line">
+            <a:avLst/>
+          </a:prstGeom>
+          <a:noFill/>
+          <a:ln w="7144">
+            <a:solidFill>
+              <a:srgbClr val="E5E5E5"/>
+            </a:solidFill>
+            <a:prstDash val="dash"/>
+          </a:ln>
+        </p:spPr>
+      </p:sp>
+      <p:sp>
+        <p:nvSpPr>
+          <p:cNvPr id="23" name="Text 19"/>
+          <p:cNvSpPr/>
+          <p:nvPr/>
+        </p:nvSpPr>
+        <p:spPr>
+          <a:xfrm>
+            <a:off x="3317044" y="2467273"/>
+            <a:ext cx="607300" cy="176784"/>
+          </a:xfrm>
+          <a:prstGeom prst="rect">
+            <a:avLst/>
+          </a:prstGeom>
+          <a:noFill/>
+          <a:ln/>
+        </p:spPr>
+        <p:txBody>
+          <a:bodyPr wrap="none" lIns="0" tIns="7144" rIns="0" bIns="0" rtlCol="0" anchor="t"/>
+          <a:lstStyle/>
+          <a:p>
+            <a:pPr algn="l" indent="0" marL="0">
+              <a:lnSpc>
+                <a:spcPts val="759"/>
+              </a:lnSpc>
+              <a:buNone/>
+            </a:pPr>
+            <a:r>
+              <a:rPr lang="en-US" sz="800" b="1" spc="91" kern="0" dirty="0">
+                <a:solidFill>
+                  <a:srgbClr val="6F42C1"/>
+                </a:solidFill>
+                <a:latin typeface="Carlito" pitchFamily="34" charset="0"/>
+                <a:ea typeface="Carlito" pitchFamily="34" charset="-122"/>
+                <a:cs typeface="Carlito" pitchFamily="34" charset="-120"/>
+              </a:rPr>
+              <a:t>SESSION</a:t>
+            </a:r>
+            <a:endParaRPr lang="en-US" sz="800" dirty="0"/>
+          </a:p>
+        </p:txBody>
+      </p:sp>
+      <p:sp>
+        <p:nvSpPr>
+          <p:cNvPr id="24" name="Text 20"/>
+          <p:cNvSpPr/>
+          <p:nvPr/>
+        </p:nvSpPr>
+        <p:spPr>
+          <a:xfrm>
+            <a:off x="3753259" y="2467273"/>
+            <a:ext cx="2073585" cy="202481"/>
+          </a:xfrm>
+          <a:prstGeom prst="rect">
+            <a:avLst/>
+          </a:prstGeom>
+          <a:noFill/>
+          <a:ln/>
+        </p:spPr>
+        <p:txBody>
+          <a:bodyPr wrap="square" lIns="0" tIns="0" rIns="0" bIns="0" rtlCol="0" anchor="t"/>
+          <a:lstStyle/>
+          <a:p>
+            <a:pPr algn="l" indent="0" marL="0">
+              <a:lnSpc>
+                <a:spcPts val="797"/>
+              </a:lnSpc>
+              <a:buNone/>
+            </a:pPr>
+            <a:r>
+              <a:rPr lang="en-US" sz="800" i="1" dirty="0">
+                <a:solidFill>
+                  <a:srgbClr val="333333"/>
+                </a:solidFill>
+                <a:latin typeface="Carlito" pitchFamily="34" charset="0"/>
+                <a:ea typeface="Carlito" pitchFamily="34" charset="-122"/>
+                <a:cs typeface="Carlito" pitchFamily="34" charset="-120"/>
+              </a:rPr>
+              <a:t>Qwen-VL-Max for Retail: Multimodal Product Understanding at Scale</a:t>
+            </a:r>
+            <a:endParaRPr lang="en-US" sz="800" dirty="0"/>
+          </a:p>
+        </p:txBody>
+      </p:sp>
+      <p:sp>
+        <p:nvSpPr>
+          <p:cNvPr id="25" name="Text 21"/>
           <p:cNvSpPr/>
           <p:nvPr/>
         </p:nvSpPr>
@@ -6638,14 +6839,14 @@
       </p:sp>
       <p:sp>
         <p:nvSpPr>
-          <p:cNvPr id="20" name="Text 16"/>
+          <p:cNvPr id="26" name="Text 22"/>
           <p:cNvSpPr/>
           <p:nvPr/>
         </p:nvSpPr>
         <p:spPr>
           <a:xfrm>
             <a:off x="6026869" y="1241003"/>
-            <a:ext cx="2709937" cy="661690"/>
+            <a:ext cx="2709937" cy="387772"/>
           </a:xfrm>
           <a:prstGeom prst="rect">
             <a:avLst/>
@@ -6668,7 +6869,7 @@
       </p:sp>
       <p:pic>
         <p:nvPicPr>
-          <p:cNvPr id="21" name="Image 2" descr="/tmp/h2p-fit-1788201353180-8nij95.png">    </p:cNvPr>
+          <p:cNvPr id="27" name="Image 2" descr="/tmp/h2p-fit-1788202054181-jah48u.png">    </p:cNvPr>
           <p:cNvPicPr>
             <a:picLocks noChangeAspect="1"/>
           </p:cNvPicPr>
@@ -6683,7 +6884,7 @@
         <p:spPr>
           <a:xfrm>
             <a:off x="6026869" y="1241003"/>
-            <a:ext cx="2709937" cy="661690"/>
+            <a:ext cx="2709937" cy="387772"/>
           </a:xfrm>
           <a:prstGeom prst="rect">
             <a:avLst/>
@@ -6692,13 +6893,13 @@
       </p:pic>
       <p:sp>
         <p:nvSpPr>
-          <p:cNvPr id="22" name="Text 17"/>
-          <p:cNvSpPr/>
-          <p:nvPr/>
-        </p:nvSpPr>
-        <p:spPr>
-          <a:xfrm>
-            <a:off x="6104022" y="1978560"/>
+          <p:cNvPr id="28" name="Text 23"/>
+          <p:cNvSpPr/>
+          <p:nvPr/>
+        </p:nvSpPr>
+        <p:spPr>
+          <a:xfrm>
+            <a:off x="6104022" y="1704642"/>
             <a:ext cx="970278" cy="184023"/>
           </a:xfrm>
           <a:prstGeom prst="roundRect">
@@ -6731,13 +6932,13 @@
       </p:sp>
       <p:sp>
         <p:nvSpPr>
-          <p:cNvPr id="23" name="Text 18"/>
-          <p:cNvSpPr/>
-          <p:nvPr/>
-        </p:nvSpPr>
-        <p:spPr>
-          <a:xfrm>
-            <a:off x="6305476" y="2031281"/>
+          <p:cNvPr id="29" name="Text 24"/>
+          <p:cNvSpPr/>
+          <p:nvPr/>
+        </p:nvSpPr>
+        <p:spPr>
+          <a:xfrm>
+            <a:off x="6305476" y="1757363"/>
             <a:ext cx="681670" cy="120701"/>
           </a:xfrm>
           <a:prstGeom prst="rect">
@@ -6773,13 +6974,13 @@
       </p:sp>
       <p:sp>
         <p:nvSpPr>
-          <p:cNvPr id="24" name="Text 19"/>
-          <p:cNvSpPr/>
-          <p:nvPr/>
-        </p:nvSpPr>
-        <p:spPr>
-          <a:xfrm>
-            <a:off x="6191176" y="2031281"/>
+          <p:cNvPr id="30" name="Text 25"/>
+          <p:cNvSpPr/>
+          <p:nvPr/>
+        </p:nvSpPr>
+        <p:spPr>
+          <a:xfrm>
+            <a:off x="6191176" y="1757363"/>
             <a:ext cx="91440" cy="91440"/>
           </a:xfrm>
           <a:prstGeom prst="rect">
@@ -6812,28 +7013,30 @@
       </p:sp>
       <p:sp>
         <p:nvSpPr>
-          <p:cNvPr id="25" name="Text 20"/>
-          <p:cNvSpPr/>
-          <p:nvPr/>
-        </p:nvSpPr>
-        <p:spPr>
-          <a:xfrm>
-            <a:off x="6126882" y="2209874"/>
-            <a:ext cx="2509912" cy="545604"/>
-          </a:xfrm>
-          <a:prstGeom prst="rect">
-            <a:avLst/>
-          </a:prstGeom>
-          <a:noFill/>
-          <a:ln/>
-        </p:spPr>
-        <p:txBody>
-          <a:bodyPr wrap="square" lIns="0" tIns="0" rIns="0" bIns="0" rtlCol="0" anchor="t"/>
-          <a:lstStyle/>
-          <a:p>
-            <a:pPr algn="l" indent="0" marL="0">
-              <a:lnSpc>
-                <a:spcPts val="906"/>
+          <p:cNvPr id="31" name="Text 26"/>
+          <p:cNvSpPr/>
+          <p:nvPr/>
+        </p:nvSpPr>
+        <p:spPr>
+          <a:xfrm>
+            <a:off x="6126882" y="1935956"/>
+            <a:ext cx="2509912" cy="468166"/>
+          </a:xfrm>
+          <a:prstGeom prst="rect">
+            <a:avLst/>
+          </a:prstGeom>
+          <a:noFill/>
+          <a:ln/>
+        </p:spPr>
+        <p:txBody>
+          <a:bodyPr wrap="square" lIns="0" tIns="0" rIns="0" bIns="0" rtlCol="0" anchor="t">
+            <a:normAutofit/>
+          </a:bodyPr>
+          <a:lstStyle/>
+          <a:p>
+            <a:pPr algn="l" indent="0" marL="0">
+              <a:lnSpc>
+                <a:spcPts val="835"/>
               </a:lnSpc>
               <a:buNone/>
             </a:pPr>
@@ -6846,11 +7049,11 @@
                 <a:ea typeface="Carlito" pitchFamily="34" charset="-122"/>
                 <a:cs typeface="Carlito" pitchFamily="34" charset="-120"/>
               </a:rPr>
-              <a:t>Hands-on workshop building with Claude Sonnet 4.5's 200K context window + Claude Code agentic dev tools. </a:t>
-            </a:r>
-            <a:pPr algn="l" indent="0" marL="0">
-              <a:lnSpc>
-                <a:spcPts val="906"/>
+              <a:t>Hands-on workshop with Qwen-Coder building tools that read, query, and reason over the AliExpress catalog. </a:t>
+            </a:r>
+            <a:pPr algn="l" indent="0" marL="0">
+              <a:lnSpc>
+                <a:spcPts val="835"/>
               </a:lnSpc>
               <a:buNone/>
             </a:pPr>
@@ -6867,7 +7070,7 @@
             </a:r>
             <a:pPr algn="l" indent="0" marL="0">
               <a:lnSpc>
-                <a:spcPts val="906"/>
+                <a:spcPts val="835"/>
               </a:lnSpc>
               <a:buNone/>
             </a:pPr>
@@ -6880,7 +7083,7 @@
                 <a:ea typeface="Carlito" pitchFamily="34" charset="-122"/>
                 <a:cs typeface="Carlito" pitchFamily="34" charset="-120"/>
               </a:rPr>
-              <a:t> 30-day Claude Team seats + early Sonnet 4.5 preview.</a:t>
+              <a:t> Qwen-Coder dev seats + pair-programming lab with AliExpress engineers.</a:t>
             </a:r>
             <a:endParaRPr lang="en-US" sz="800" dirty="0"/>
           </a:p>
@@ -6888,7 +7091,114 @@
       </p:sp>
       <p:sp>
         <p:nvSpPr>
-          <p:cNvPr id="26" name="Text 21"/>
+          <p:cNvPr id="32" name="Shape 27"/>
+          <p:cNvSpPr/>
+          <p:nvPr/>
+        </p:nvSpPr>
+        <p:spPr>
+          <a:xfrm>
+            <a:off x="6126882" y="2435126"/>
+            <a:ext cx="2509912" cy="0"/>
+          </a:xfrm>
+          <a:prstGeom prst="line">
+            <a:avLst/>
+          </a:prstGeom>
+          <a:noFill/>
+          <a:ln w="7144">
+            <a:solidFill>
+              <a:srgbClr val="E5E5E5"/>
+            </a:solidFill>
+            <a:prstDash val="dash"/>
+          </a:ln>
+        </p:spPr>
+      </p:sp>
+      <p:sp>
+        <p:nvSpPr>
+          <p:cNvPr id="33" name="Text 28"/>
+          <p:cNvSpPr/>
+          <p:nvPr/>
+        </p:nvSpPr>
+        <p:spPr>
+          <a:xfrm>
+            <a:off x="6126882" y="2467273"/>
+            <a:ext cx="607300" cy="176784"/>
+          </a:xfrm>
+          <a:prstGeom prst="rect">
+            <a:avLst/>
+          </a:prstGeom>
+          <a:noFill/>
+          <a:ln/>
+        </p:spPr>
+        <p:txBody>
+          <a:bodyPr wrap="none" lIns="0" tIns="7144" rIns="0" bIns="0" rtlCol="0" anchor="t"/>
+          <a:lstStyle/>
+          <a:p>
+            <a:pPr algn="l" indent="0" marL="0">
+              <a:lnSpc>
+                <a:spcPts val="759"/>
+              </a:lnSpc>
+              <a:buNone/>
+            </a:pPr>
+            <a:r>
+              <a:rPr lang="en-US" sz="800" b="1" spc="91" kern="0" dirty="0">
+                <a:solidFill>
+                  <a:srgbClr val="6F42C1"/>
+                </a:solidFill>
+                <a:latin typeface="Carlito" pitchFamily="34" charset="0"/>
+                <a:ea typeface="Carlito" pitchFamily="34" charset="-122"/>
+                <a:cs typeface="Carlito" pitchFamily="34" charset="-120"/>
+              </a:rPr>
+              <a:t>SESSION</a:t>
+            </a:r>
+            <a:endParaRPr lang="en-US" sz="800" dirty="0"/>
+          </a:p>
+        </p:txBody>
+      </p:sp>
+      <p:sp>
+        <p:nvSpPr>
+          <p:cNvPr id="34" name="Text 29"/>
+          <p:cNvSpPr/>
+          <p:nvPr/>
+        </p:nvSpPr>
+        <p:spPr>
+          <a:xfrm>
+            <a:off x="6563097" y="2467273"/>
+            <a:ext cx="2073697" cy="202481"/>
+          </a:xfrm>
+          <a:prstGeom prst="rect">
+            <a:avLst/>
+          </a:prstGeom>
+          <a:noFill/>
+          <a:ln/>
+        </p:spPr>
+        <p:txBody>
+          <a:bodyPr wrap="square" lIns="0" tIns="0" rIns="0" bIns="0" rtlCol="0" anchor="t"/>
+          <a:lstStyle/>
+          <a:p>
+            <a:pPr algn="l" indent="0" marL="0">
+              <a:lnSpc>
+                <a:spcPts val="797"/>
+              </a:lnSpc>
+              <a:buNone/>
+            </a:pPr>
+            <a:r>
+              <a:rPr lang="en-US" sz="800" i="1" dirty="0">
+                <a:solidFill>
+                  <a:srgbClr val="333333"/>
+                </a:solidFill>
+                <a:latin typeface="Carlito" pitchFamily="34" charset="0"/>
+                <a:ea typeface="Carlito" pitchFamily="34" charset="-122"/>
+                <a:cs typeface="Carlito" pitchFamily="34" charset="-120"/>
+              </a:rPr>
+              <a:t>Agentic Coding with Qwen-Coder: Building Tools for the AliExpress Catalog</a:t>
+            </a:r>
+            <a:endParaRPr lang="en-US" sz="800" dirty="0"/>
+          </a:p>
+        </p:txBody>
+      </p:sp>
+      <p:sp>
+        <p:nvSpPr>
+          <p:cNvPr id="35" name="Text 30"/>
           <p:cNvSpPr/>
           <p:nvPr/>
         </p:nvSpPr>
@@ -6925,14 +7235,14 @@
       </p:sp>
       <p:sp>
         <p:nvSpPr>
-          <p:cNvPr id="27" name="Text 22"/>
+          <p:cNvPr id="36" name="Text 31"/>
           <p:cNvSpPr/>
           <p:nvPr/>
         </p:nvSpPr>
         <p:spPr>
           <a:xfrm>
             <a:off x="407194" y="2855491"/>
-            <a:ext cx="2709825" cy="661690"/>
+            <a:ext cx="2709825" cy="387772"/>
           </a:xfrm>
           <a:prstGeom prst="rect">
             <a:avLst/>
@@ -6955,7 +7265,7 @@
       </p:sp>
       <p:pic>
         <p:nvPicPr>
-          <p:cNvPr id="28" name="Image 3" descr="/tmp/h2p-fit-1788201353132-5h9ebc.png">    </p:cNvPr>
+          <p:cNvPr id="37" name="Image 3" descr="/tmp/h2p-fit-1788202053835-l6u49v.png">    </p:cNvPr>
           <p:cNvPicPr>
             <a:picLocks noChangeAspect="1"/>
           </p:cNvPicPr>
@@ -6970,7 +7280,7 @@
         <p:spPr>
           <a:xfrm>
             <a:off x="407194" y="2855491"/>
-            <a:ext cx="2709825" cy="661690"/>
+            <a:ext cx="2709825" cy="387772"/>
           </a:xfrm>
           <a:prstGeom prst="rect">
             <a:avLst/>
@@ -6979,13 +7289,13 @@
       </p:pic>
       <p:sp>
         <p:nvSpPr>
-          <p:cNvPr id="29" name="Text 23"/>
-          <p:cNvSpPr/>
-          <p:nvPr/>
-        </p:nvSpPr>
-        <p:spPr>
-          <a:xfrm>
-            <a:off x="484346" y="3593047"/>
+          <p:cNvPr id="38" name="Text 32"/>
+          <p:cNvSpPr/>
+          <p:nvPr/>
+        </p:nvSpPr>
+        <p:spPr>
+          <a:xfrm>
+            <a:off x="484346" y="3319129"/>
             <a:ext cx="970278" cy="184023"/>
           </a:xfrm>
           <a:prstGeom prst="roundRect">
@@ -7018,13 +7328,13 @@
       </p:sp>
       <p:sp>
         <p:nvSpPr>
-          <p:cNvPr id="30" name="Text 24"/>
-          <p:cNvSpPr/>
-          <p:nvPr/>
-        </p:nvSpPr>
-        <p:spPr>
-          <a:xfrm>
-            <a:off x="685800" y="3645768"/>
+          <p:cNvPr id="39" name="Text 33"/>
+          <p:cNvSpPr/>
+          <p:nvPr/>
+        </p:nvSpPr>
+        <p:spPr>
+          <a:xfrm>
+            <a:off x="685800" y="3371850"/>
             <a:ext cx="681670" cy="120701"/>
           </a:xfrm>
           <a:prstGeom prst="rect">
@@ -7060,13 +7370,13 @@
       </p:sp>
       <p:sp>
         <p:nvSpPr>
-          <p:cNvPr id="31" name="Text 25"/>
-          <p:cNvSpPr/>
-          <p:nvPr/>
-        </p:nvSpPr>
-        <p:spPr>
-          <a:xfrm>
-            <a:off x="571500" y="3645768"/>
+          <p:cNvPr id="40" name="Text 34"/>
+          <p:cNvSpPr/>
+          <p:nvPr/>
+        </p:nvSpPr>
+        <p:spPr>
+          <a:xfrm>
+            <a:off x="571500" y="3371850"/>
             <a:ext cx="91440" cy="91440"/>
           </a:xfrm>
           <a:prstGeom prst="rect">
@@ -7099,28 +7409,30 @@
       </p:sp>
       <p:sp>
         <p:nvSpPr>
-          <p:cNvPr id="32" name="Text 26"/>
-          <p:cNvSpPr/>
-          <p:nvPr/>
-        </p:nvSpPr>
-        <p:spPr>
-          <a:xfrm>
-            <a:off x="507206" y="3824362"/>
-            <a:ext cx="2509800" cy="545604"/>
-          </a:xfrm>
-          <a:prstGeom prst="rect">
-            <a:avLst/>
-          </a:prstGeom>
-          <a:noFill/>
-          <a:ln/>
-        </p:spPr>
-        <p:txBody>
-          <a:bodyPr wrap="square" lIns="0" tIns="0" rIns="0" bIns="0" rtlCol="0" anchor="t"/>
-          <a:lstStyle/>
-          <a:p>
-            <a:pPr algn="l" indent="0" marL="0">
-              <a:lnSpc>
-                <a:spcPts val="906"/>
+          <p:cNvPr id="41" name="Text 35"/>
+          <p:cNvSpPr/>
+          <p:nvPr/>
+        </p:nvSpPr>
+        <p:spPr>
+          <a:xfrm>
+            <a:off x="507206" y="3550444"/>
+            <a:ext cx="2509800" cy="468166"/>
+          </a:xfrm>
+          <a:prstGeom prst="rect">
+            <a:avLst/>
+          </a:prstGeom>
+          <a:noFill/>
+          <a:ln/>
+        </p:spPr>
+        <p:txBody>
+          <a:bodyPr wrap="square" lIns="0" tIns="0" rIns="0" bIns="0" rtlCol="0" anchor="t">
+            <a:normAutofit/>
+          </a:bodyPr>
+          <a:lstStyle/>
+          <a:p>
+            <a:pPr algn="l" indent="0" marL="0">
+              <a:lnSpc>
+                <a:spcPts val="835"/>
               </a:lnSpc>
               <a:buNone/>
             </a:pPr>
@@ -7133,11 +7445,11 @@
                 <a:ea typeface="Carlito" pitchFamily="34" charset="-122"/>
                 <a:cs typeface="Carlito" pitchFamily="34" charset="-120"/>
               </a:rPr>
-              <a:t>Google DeepMind team on Gemini 2.5 native multimodal understanding, video reasoning, and Vertex AI deployment. </a:t>
-            </a:r>
-            <a:pPr algn="l" indent="0" marL="0">
-              <a:lnSpc>
-                <a:spcPts val="906"/>
+              <a:t>Hands-on fine-tuning lab on Qwen3 open weights for Israeli-domain use cases (Hebrew, retail, commerce). </a:t>
+            </a:r>
+            <a:pPr algn="l" indent="0" marL="0">
+              <a:lnSpc>
+                <a:spcPts val="835"/>
               </a:lnSpc>
               <a:buNone/>
             </a:pPr>
@@ -7154,7 +7466,7 @@
             </a:r>
             <a:pPr algn="l" indent="0" marL="0">
               <a:lnSpc>
-                <a:spcPts val="906"/>
+                <a:spcPts val="835"/>
               </a:lnSpc>
               <a:buNone/>
             </a:pPr>
@@ -7167,7 +7479,7 @@
                 <a:ea typeface="Carlito" pitchFamily="34" charset="-122"/>
                 <a:cs typeface="Carlito" pitchFamily="34" charset="-120"/>
               </a:rPr>
-              <a:t> $10K Google Cloud credits + Gemini 2.5 Pro early access.</a:t>
+              <a:t> free fine-tuned Qwen3 instance per startup + H100 compute hours.</a:t>
             </a:r>
             <a:endParaRPr lang="en-US" sz="800" dirty="0"/>
           </a:p>
@@ -7175,7 +7487,114 @@
       </p:sp>
       <p:sp>
         <p:nvSpPr>
-          <p:cNvPr id="33" name="Text 27"/>
+          <p:cNvPr id="42" name="Shape 36"/>
+          <p:cNvSpPr/>
+          <p:nvPr/>
+        </p:nvSpPr>
+        <p:spPr>
+          <a:xfrm>
+            <a:off x="507206" y="4049613"/>
+            <a:ext cx="2509800" cy="0"/>
+          </a:xfrm>
+          <a:prstGeom prst="line">
+            <a:avLst/>
+          </a:prstGeom>
+          <a:noFill/>
+          <a:ln w="7144">
+            <a:solidFill>
+              <a:srgbClr val="E5E5E5"/>
+            </a:solidFill>
+            <a:prstDash val="dash"/>
+          </a:ln>
+        </p:spPr>
+      </p:sp>
+      <p:sp>
+        <p:nvSpPr>
+          <p:cNvPr id="43" name="Text 37"/>
+          <p:cNvSpPr/>
+          <p:nvPr/>
+        </p:nvSpPr>
+        <p:spPr>
+          <a:xfrm>
+            <a:off x="507206" y="4081760"/>
+            <a:ext cx="607300" cy="176784"/>
+          </a:xfrm>
+          <a:prstGeom prst="rect">
+            <a:avLst/>
+          </a:prstGeom>
+          <a:noFill/>
+          <a:ln/>
+        </p:spPr>
+        <p:txBody>
+          <a:bodyPr wrap="none" lIns="0" tIns="7144" rIns="0" bIns="0" rtlCol="0" anchor="t"/>
+          <a:lstStyle/>
+          <a:p>
+            <a:pPr algn="l" indent="0" marL="0">
+              <a:lnSpc>
+                <a:spcPts val="759"/>
+              </a:lnSpc>
+              <a:buNone/>
+            </a:pPr>
+            <a:r>
+              <a:rPr lang="en-US" sz="800" b="1" spc="91" kern="0" dirty="0">
+                <a:solidFill>
+                  <a:srgbClr val="6F42C1"/>
+                </a:solidFill>
+                <a:latin typeface="Carlito" pitchFamily="34" charset="0"/>
+                <a:ea typeface="Carlito" pitchFamily="34" charset="-122"/>
+                <a:cs typeface="Carlito" pitchFamily="34" charset="-120"/>
+              </a:rPr>
+              <a:t>SESSION</a:t>
+            </a:r>
+            <a:endParaRPr lang="en-US" sz="800" dirty="0"/>
+          </a:p>
+        </p:txBody>
+      </p:sp>
+      <p:sp>
+        <p:nvSpPr>
+          <p:cNvPr id="44" name="Text 38"/>
+          <p:cNvSpPr/>
+          <p:nvPr/>
+        </p:nvSpPr>
+        <p:spPr>
+          <a:xfrm>
+            <a:off x="943421" y="4081760"/>
+            <a:ext cx="2073585" cy="202481"/>
+          </a:xfrm>
+          <a:prstGeom prst="rect">
+            <a:avLst/>
+          </a:prstGeom>
+          <a:noFill/>
+          <a:ln/>
+        </p:spPr>
+        <p:txBody>
+          <a:bodyPr wrap="square" lIns="0" tIns="0" rIns="0" bIns="0" rtlCol="0" anchor="t"/>
+          <a:lstStyle/>
+          <a:p>
+            <a:pPr algn="l" indent="0" marL="0">
+              <a:lnSpc>
+                <a:spcPts val="797"/>
+              </a:lnSpc>
+              <a:buNone/>
+            </a:pPr>
+            <a:r>
+              <a:rPr lang="en-US" sz="800" i="1" dirty="0">
+                <a:solidFill>
+                  <a:srgbClr val="333333"/>
+                </a:solidFill>
+                <a:latin typeface="Carlito" pitchFamily="34" charset="0"/>
+                <a:ea typeface="Carlito" pitchFamily="34" charset="-122"/>
+                <a:cs typeface="Carlito" pitchFamily="34" charset="-120"/>
+              </a:rPr>
+              <a:t>Open-Weight Qwen3 Fine-Tuning Lab: Hebrew, Retail, and Beyond</a:t>
+            </a:r>
+            <a:endParaRPr lang="en-US" sz="800" dirty="0"/>
+          </a:p>
+        </p:txBody>
+      </p:sp>
+      <p:sp>
+        <p:nvSpPr>
+          <p:cNvPr id="45" name="Text 39"/>
           <p:cNvSpPr/>
           <p:nvPr/>
         </p:nvSpPr>
@@ -7212,14 +7631,14 @@
       </p:sp>
       <p:sp>
         <p:nvSpPr>
-          <p:cNvPr id="34" name="Text 28"/>
+          <p:cNvPr id="46" name="Text 40"/>
           <p:cNvSpPr/>
           <p:nvPr/>
         </p:nvSpPr>
         <p:spPr>
           <a:xfrm>
             <a:off x="3217032" y="2855491"/>
-            <a:ext cx="2709825" cy="661690"/>
+            <a:ext cx="2709825" cy="387772"/>
           </a:xfrm>
           <a:prstGeom prst="rect">
             <a:avLst/>
@@ -7242,7 +7661,7 @@
       </p:sp>
       <p:pic>
         <p:nvPicPr>
-          <p:cNvPr id="35" name="Image 4" descr="/tmp/h2p-fit-1788201353142-nlhjjg.png">    </p:cNvPr>
+          <p:cNvPr id="47" name="Image 4" descr="/tmp/h2p-fit-1788202053820-me4h6y.png">    </p:cNvPr>
           <p:cNvPicPr>
             <a:picLocks noChangeAspect="1"/>
           </p:cNvPicPr>
@@ -7257,7 +7676,7 @@
         <p:spPr>
           <a:xfrm>
             <a:off x="3217032" y="2855491"/>
-            <a:ext cx="2709825" cy="661690"/>
+            <a:ext cx="2709825" cy="387772"/>
           </a:xfrm>
           <a:prstGeom prst="rect">
             <a:avLst/>
@@ -7266,13 +7685,13 @@
       </p:pic>
       <p:sp>
         <p:nvSpPr>
-          <p:cNvPr id="36" name="Text 29"/>
-          <p:cNvSpPr/>
-          <p:nvPr/>
-        </p:nvSpPr>
-        <p:spPr>
-          <a:xfrm>
-            <a:off x="3294184" y="3593047"/>
+          <p:cNvPr id="48" name="Text 41"/>
+          <p:cNvSpPr/>
+          <p:nvPr/>
+        </p:nvSpPr>
+        <p:spPr>
+          <a:xfrm>
+            <a:off x="3294184" y="3319129"/>
             <a:ext cx="970278" cy="184023"/>
           </a:xfrm>
           <a:prstGeom prst="roundRect">
@@ -7305,13 +7724,13 @@
       </p:sp>
       <p:sp>
         <p:nvSpPr>
-          <p:cNvPr id="37" name="Text 30"/>
-          <p:cNvSpPr/>
-          <p:nvPr/>
-        </p:nvSpPr>
-        <p:spPr>
-          <a:xfrm>
-            <a:off x="3495638" y="3645768"/>
+          <p:cNvPr id="49" name="Text 42"/>
+          <p:cNvSpPr/>
+          <p:nvPr/>
+        </p:nvSpPr>
+        <p:spPr>
+          <a:xfrm>
+            <a:off x="3495638" y="3371850"/>
             <a:ext cx="681670" cy="120701"/>
           </a:xfrm>
           <a:prstGeom prst="rect">
@@ -7347,13 +7766,13 @@
       </p:sp>
       <p:sp>
         <p:nvSpPr>
-          <p:cNvPr id="38" name="Text 31"/>
-          <p:cNvSpPr/>
-          <p:nvPr/>
-        </p:nvSpPr>
-        <p:spPr>
-          <a:xfrm>
-            <a:off x="3381338" y="3645768"/>
+          <p:cNvPr id="50" name="Text 43"/>
+          <p:cNvSpPr/>
+          <p:nvPr/>
+        </p:nvSpPr>
+        <p:spPr>
+          <a:xfrm>
+            <a:off x="3381338" y="3371850"/>
             <a:ext cx="91440" cy="91440"/>
           </a:xfrm>
           <a:prstGeom prst="rect">
@@ -7386,28 +7805,30 @@
       </p:sp>
       <p:sp>
         <p:nvSpPr>
-          <p:cNvPr id="39" name="Text 32"/>
-          <p:cNvSpPr/>
-          <p:nvPr/>
-        </p:nvSpPr>
-        <p:spPr>
-          <a:xfrm>
-            <a:off x="3317044" y="3824362"/>
-            <a:ext cx="2509800" cy="545604"/>
-          </a:xfrm>
-          <a:prstGeom prst="rect">
-            <a:avLst/>
-          </a:prstGeom>
-          <a:noFill/>
-          <a:ln/>
-        </p:spPr>
-        <p:txBody>
-          <a:bodyPr wrap="square" lIns="0" tIns="0" rIns="0" bIns="0" rtlCol="0" anchor="t"/>
-          <a:lstStyle/>
-          <a:p>
-            <a:pPr algn="l" indent="0" marL="0">
-              <a:lnSpc>
-                <a:spcPts val="906"/>
+          <p:cNvPr id="51" name="Text 44"/>
+          <p:cNvSpPr/>
+          <p:nvPr/>
+        </p:nvSpPr>
+        <p:spPr>
+          <a:xfrm>
+            <a:off x="3317044" y="3550444"/>
+            <a:ext cx="2509800" cy="468166"/>
+          </a:xfrm>
+          <a:prstGeom prst="rect">
+            <a:avLst/>
+          </a:prstGeom>
+          <a:noFill/>
+          <a:ln/>
+        </p:spPr>
+        <p:txBody>
+          <a:bodyPr wrap="square" lIns="0" tIns="0" rIns="0" bIns="0" rtlCol="0" anchor="t">
+            <a:normAutofit/>
+          </a:bodyPr>
+          <a:lstStyle/>
+          <a:p>
+            <a:pPr algn="l" indent="0" marL="0">
+              <a:lnSpc>
+                <a:spcPts val="835"/>
               </a:lnSpc>
               <a:buNone/>
             </a:pPr>
@@ -7420,11 +7841,11 @@
                 <a:ea typeface="Carlito" pitchFamily="34" charset="-122"/>
                 <a:cs typeface="Carlito" pitchFamily="34" charset="-120"/>
               </a:rPr>
-              <a:t>Meta AI engineers lead a fine-tuning lab on Llama 4 open weights for Israeli-domain use cases (Hebrew, retail, defense). </a:t>
-            </a:r>
-            <a:pPr algn="l" indent="0" marL="0">
-              <a:lnSpc>
-                <a:spcPts val="906"/>
+              <a:t>Production deployment of Qwen-Agent: multi-step commerce workflows, tool-use, RAG over AliExpress APIs. </a:t>
+            </a:r>
+            <a:pPr algn="l" indent="0" marL="0">
+              <a:lnSpc>
+                <a:spcPts val="835"/>
               </a:lnSpc>
               <a:buNone/>
             </a:pPr>
@@ -7441,7 +7862,7 @@
             </a:r>
             <a:pPr algn="l" indent="0" marL="0">
               <a:lnSpc>
-                <a:spcPts val="906"/>
+                <a:spcPts val="835"/>
               </a:lnSpc>
               <a:buNone/>
             </a:pPr>
@@ -7454,7 +7875,7 @@
                 <a:ea typeface="Carlito" pitchFamily="34" charset="-122"/>
                 <a:cs typeface="Carlito" pitchFamily="34" charset="-120"/>
               </a:rPr>
-              <a:t> free fine-tuned Llama 4 instance per startup + H100 compute hours.</a:t>
+              <a:t> Qwen-Agent framework early access + reference implementations for retail ops.</a:t>
             </a:r>
             <a:endParaRPr lang="en-US" sz="800" dirty="0"/>
           </a:p>
@@ -7462,7 +7883,114 @@
       </p:sp>
       <p:sp>
         <p:nvSpPr>
-          <p:cNvPr id="40" name="Text 33"/>
+          <p:cNvPr id="52" name="Shape 45"/>
+          <p:cNvSpPr/>
+          <p:nvPr/>
+        </p:nvSpPr>
+        <p:spPr>
+          <a:xfrm>
+            <a:off x="3317044" y="4049613"/>
+            <a:ext cx="2509800" cy="0"/>
+          </a:xfrm>
+          <a:prstGeom prst="line">
+            <a:avLst/>
+          </a:prstGeom>
+          <a:noFill/>
+          <a:ln w="7144">
+            <a:solidFill>
+              <a:srgbClr val="E5E5E5"/>
+            </a:solidFill>
+            <a:prstDash val="dash"/>
+          </a:ln>
+        </p:spPr>
+      </p:sp>
+      <p:sp>
+        <p:nvSpPr>
+          <p:cNvPr id="53" name="Text 46"/>
+          <p:cNvSpPr/>
+          <p:nvPr/>
+        </p:nvSpPr>
+        <p:spPr>
+          <a:xfrm>
+            <a:off x="3317044" y="4081760"/>
+            <a:ext cx="607300" cy="176784"/>
+          </a:xfrm>
+          <a:prstGeom prst="rect">
+            <a:avLst/>
+          </a:prstGeom>
+          <a:noFill/>
+          <a:ln/>
+        </p:spPr>
+        <p:txBody>
+          <a:bodyPr wrap="none" lIns="0" tIns="7144" rIns="0" bIns="0" rtlCol="0" anchor="t"/>
+          <a:lstStyle/>
+          <a:p>
+            <a:pPr algn="l" indent="0" marL="0">
+              <a:lnSpc>
+                <a:spcPts val="759"/>
+              </a:lnSpc>
+              <a:buNone/>
+            </a:pPr>
+            <a:r>
+              <a:rPr lang="en-US" sz="800" b="1" spc="91" kern="0" dirty="0">
+                <a:solidFill>
+                  <a:srgbClr val="6F42C1"/>
+                </a:solidFill>
+                <a:latin typeface="Carlito" pitchFamily="34" charset="0"/>
+                <a:ea typeface="Carlito" pitchFamily="34" charset="-122"/>
+                <a:cs typeface="Carlito" pitchFamily="34" charset="-120"/>
+              </a:rPr>
+              <a:t>SESSION</a:t>
+            </a:r>
+            <a:endParaRPr lang="en-US" sz="800" dirty="0"/>
+          </a:p>
+        </p:txBody>
+      </p:sp>
+      <p:sp>
+        <p:nvSpPr>
+          <p:cNvPr id="54" name="Text 47"/>
+          <p:cNvSpPr/>
+          <p:nvPr/>
+        </p:nvSpPr>
+        <p:spPr>
+          <a:xfrm>
+            <a:off x="3753259" y="4081760"/>
+            <a:ext cx="2073585" cy="202481"/>
+          </a:xfrm>
+          <a:prstGeom prst="rect">
+            <a:avLst/>
+          </a:prstGeom>
+          <a:noFill/>
+          <a:ln/>
+        </p:spPr>
+        <p:txBody>
+          <a:bodyPr wrap="square" lIns="0" tIns="0" rIns="0" bIns="0" rtlCol="0" anchor="t"/>
+          <a:lstStyle/>
+          <a:p>
+            <a:pPr algn="l" indent="0" marL="0">
+              <a:lnSpc>
+                <a:spcPts val="797"/>
+              </a:lnSpc>
+              <a:buNone/>
+            </a:pPr>
+            <a:r>
+              <a:rPr lang="en-US" sz="800" i="1" dirty="0">
+                <a:solidFill>
+                  <a:srgbClr val="333333"/>
+                </a:solidFill>
+                <a:latin typeface="Carlito" pitchFamily="34" charset="0"/>
+                <a:ea typeface="Carlito" pitchFamily="34" charset="-122"/>
+                <a:cs typeface="Carlito" pitchFamily="34" charset="-120"/>
+              </a:rPr>
+              <a:t>Qwen-Agent at Scale: Orchestrating Multi-Step Commerce Workflows</a:t>
+            </a:r>
+            <a:endParaRPr lang="en-US" sz="800" dirty="0"/>
+          </a:p>
+        </p:txBody>
+      </p:sp>
+      <p:sp>
+        <p:nvSpPr>
+          <p:cNvPr id="55" name="Text 48"/>
           <p:cNvSpPr/>
           <p:nvPr/>
         </p:nvSpPr>
@@ -7499,14 +8027,14 @@
       </p:sp>
       <p:sp>
         <p:nvSpPr>
-          <p:cNvPr id="41" name="Text 34"/>
+          <p:cNvPr id="56" name="Text 49"/>
           <p:cNvSpPr/>
           <p:nvPr/>
         </p:nvSpPr>
         <p:spPr>
           <a:xfrm>
             <a:off x="6026869" y="2855491"/>
-            <a:ext cx="2709937" cy="661690"/>
+            <a:ext cx="2709937" cy="387772"/>
           </a:xfrm>
           <a:prstGeom prst="rect">
             <a:avLst/>
@@ -7529,7 +8057,7 @@
       </p:sp>
       <p:pic>
         <p:nvPicPr>
-          <p:cNvPr id="42" name="Image 5" descr="/tmp/h2p-fit-1788201353173-4h55o6.png">    </p:cNvPr>
+          <p:cNvPr id="57" name="Image 5" descr="/tmp/h2p-fit-1788202053897-j1lu2y.png">    </p:cNvPr>
           <p:cNvPicPr>
             <a:picLocks noChangeAspect="1"/>
           </p:cNvPicPr>
@@ -7544,7 +8072,7 @@
         <p:spPr>
           <a:xfrm>
             <a:off x="6026869" y="2855491"/>
-            <a:ext cx="2709937" cy="661690"/>
+            <a:ext cx="2709937" cy="387772"/>
           </a:xfrm>
           <a:prstGeom prst="rect">
             <a:avLst/>
@@ -7553,13 +8081,13 @@
       </p:pic>
       <p:sp>
         <p:nvSpPr>
-          <p:cNvPr id="43" name="Text 35"/>
-          <p:cNvSpPr/>
-          <p:nvPr/>
-        </p:nvSpPr>
-        <p:spPr>
-          <a:xfrm>
-            <a:off x="6104022" y="3593047"/>
+          <p:cNvPr id="58" name="Text 50"/>
+          <p:cNvSpPr/>
+          <p:nvPr/>
+        </p:nvSpPr>
+        <p:spPr>
+          <a:xfrm>
+            <a:off x="6104022" y="3319129"/>
             <a:ext cx="1094735" cy="184023"/>
           </a:xfrm>
           <a:prstGeom prst="roundRect">
@@ -7592,13 +8120,13 @@
       </p:sp>
       <p:sp>
         <p:nvSpPr>
-          <p:cNvPr id="44" name="Text 36"/>
-          <p:cNvSpPr/>
-          <p:nvPr/>
-        </p:nvSpPr>
-        <p:spPr>
-          <a:xfrm>
-            <a:off x="6305476" y="3645768"/>
+          <p:cNvPr id="59" name="Text 51"/>
+          <p:cNvSpPr/>
+          <p:nvPr/>
+        </p:nvSpPr>
+        <p:spPr>
+          <a:xfrm>
+            <a:off x="6305476" y="3371850"/>
             <a:ext cx="806128" cy="120701"/>
           </a:xfrm>
           <a:prstGeom prst="rect">
@@ -7634,13 +8162,13 @@
       </p:sp>
       <p:sp>
         <p:nvSpPr>
-          <p:cNvPr id="45" name="Text 37"/>
-          <p:cNvSpPr/>
-          <p:nvPr/>
-        </p:nvSpPr>
-        <p:spPr>
-          <a:xfrm>
-            <a:off x="6191176" y="3645768"/>
+          <p:cNvPr id="60" name="Text 52"/>
+          <p:cNvSpPr/>
+          <p:nvPr/>
+        </p:nvSpPr>
+        <p:spPr>
+          <a:xfrm>
+            <a:off x="6191176" y="3371850"/>
             <a:ext cx="91440" cy="91440"/>
           </a:xfrm>
           <a:prstGeom prst="rect">
@@ -7673,28 +8201,30 @@
       </p:sp>
       <p:sp>
         <p:nvSpPr>
-          <p:cNvPr id="46" name="Text 38"/>
-          <p:cNvSpPr/>
-          <p:nvPr/>
-        </p:nvSpPr>
-        <p:spPr>
-          <a:xfrm>
-            <a:off x="6126882" y="3824362"/>
-            <a:ext cx="2509912" cy="545604"/>
-          </a:xfrm>
-          <a:prstGeom prst="rect">
-            <a:avLst/>
-          </a:prstGeom>
-          <a:noFill/>
-          <a:ln/>
-        </p:spPr>
-        <p:txBody>
-          <a:bodyPr wrap="square" lIns="0" tIns="0" rIns="0" bIns="0" rtlCol="0" anchor="t"/>
-          <a:lstStyle/>
-          <a:p>
-            <a:pPr algn="l" indent="0" marL="0">
-              <a:lnSpc>
-                <a:spcPts val="906"/>
+          <p:cNvPr id="61" name="Text 53"/>
+          <p:cNvSpPr/>
+          <p:nvPr/>
+        </p:nvSpPr>
+        <p:spPr>
+          <a:xfrm>
+            <a:off x="6126882" y="3550444"/>
+            <a:ext cx="2509912" cy="468166"/>
+          </a:xfrm>
+          <a:prstGeom prst="rect">
+            <a:avLst/>
+          </a:prstGeom>
+          <a:noFill/>
+          <a:ln/>
+        </p:spPr>
+        <p:txBody>
+          <a:bodyPr wrap="square" lIns="0" tIns="0" rIns="0" bIns="0" rtlCol="0" anchor="t">
+            <a:normAutofit/>
+          </a:bodyPr>
+          <a:lstStyle/>
+          <a:p>
+            <a:pPr algn="l" indent="0" marL="0">
+              <a:lnSpc>
+                <a:spcPts val="835"/>
               </a:lnSpc>
               <a:buNone/>
             </a:pPr>
@@ -7707,11 +8237,11 @@
                 <a:ea typeface="Carlito" pitchFamily="34" charset="-122"/>
                 <a:cs typeface="Carlito" pitchFamily="34" charset="-120"/>
               </a:rPr>
-              <a:t>Qwen + OpenAI + Anthropic + Meta leaders on one stage. AliExpress opens with the 2027 retail-AI roadmap. </a:t>
-            </a:r>
-            <a:pPr algn="l" indent="0" marL="0">
-              <a:lnSpc>
-                <a:spcPts val="906"/>
+              <a:t>Qwen leadership team previews the 2027 roadmap — Qwen-Next architecture, on-device, agentic capabilities. </a:t>
+            </a:r>
+            <a:pPr algn="l" indent="0" marL="0">
+              <a:lnSpc>
+                <a:spcPts val="835"/>
               </a:lnSpc>
               <a:buNone/>
             </a:pPr>
@@ -7728,7 +8258,7 @@
             </a:r>
             <a:pPr algn="l" indent="0" marL="0">
               <a:lnSpc>
-                <a:spcPts val="906"/>
+                <a:spcPts val="835"/>
               </a:lnSpc>
               <a:buNone/>
             </a:pPr>
@@ -7741,7 +8271,7 @@
                 <a:ea typeface="Carlito" pitchFamily="34" charset="-122"/>
                 <a:cs typeface="Carlito" pitchFamily="34" charset="-120"/>
               </a:rPr>
-              <a:t> demo-day pitch slots + published whitepaper co-authored with AliExpress.</a:t>
+              <a:t> Qwen-Next closed-beta seats + co-authored whitepaper with AliExpress.</a:t>
             </a:r>
             <a:endParaRPr lang="en-US" sz="800" dirty="0"/>
           </a:p>
@@ -7749,7 +8279,114 @@
       </p:sp>
       <p:sp>
         <p:nvSpPr>
-          <p:cNvPr id="47" name="Shape 39"/>
+          <p:cNvPr id="62" name="Shape 54"/>
+          <p:cNvSpPr/>
+          <p:nvPr/>
+        </p:nvSpPr>
+        <p:spPr>
+          <a:xfrm>
+            <a:off x="6126882" y="4049613"/>
+            <a:ext cx="2509912" cy="0"/>
+          </a:xfrm>
+          <a:prstGeom prst="line">
+            <a:avLst/>
+          </a:prstGeom>
+          <a:noFill/>
+          <a:ln w="7144">
+            <a:solidFill>
+              <a:srgbClr val="E5E5E5"/>
+            </a:solidFill>
+            <a:prstDash val="dash"/>
+          </a:ln>
+        </p:spPr>
+      </p:sp>
+      <p:sp>
+        <p:nvSpPr>
+          <p:cNvPr id="63" name="Text 55"/>
+          <p:cNvSpPr/>
+          <p:nvPr/>
+        </p:nvSpPr>
+        <p:spPr>
+          <a:xfrm>
+            <a:off x="6126882" y="4081760"/>
+            <a:ext cx="607300" cy="176784"/>
+          </a:xfrm>
+          <a:prstGeom prst="rect">
+            <a:avLst/>
+          </a:prstGeom>
+          <a:noFill/>
+          <a:ln/>
+        </p:spPr>
+        <p:txBody>
+          <a:bodyPr wrap="none" lIns="0" tIns="7144" rIns="0" bIns="0" rtlCol="0" anchor="t"/>
+          <a:lstStyle/>
+          <a:p>
+            <a:pPr algn="l" indent="0" marL="0">
+              <a:lnSpc>
+                <a:spcPts val="759"/>
+              </a:lnSpc>
+              <a:buNone/>
+            </a:pPr>
+            <a:r>
+              <a:rPr lang="en-US" sz="800" b="1" spc="91" kern="0" dirty="0">
+                <a:solidFill>
+                  <a:srgbClr val="6F42C1"/>
+                </a:solidFill>
+                <a:latin typeface="Carlito" pitchFamily="34" charset="0"/>
+                <a:ea typeface="Carlito" pitchFamily="34" charset="-122"/>
+                <a:cs typeface="Carlito" pitchFamily="34" charset="-120"/>
+              </a:rPr>
+              <a:t>SESSION</a:t>
+            </a:r>
+            <a:endParaRPr lang="en-US" sz="800" dirty="0"/>
+          </a:p>
+        </p:txBody>
+      </p:sp>
+      <p:sp>
+        <p:nvSpPr>
+          <p:cNvPr id="64" name="Text 56"/>
+          <p:cNvSpPr/>
+          <p:nvPr/>
+        </p:nvSpPr>
+        <p:spPr>
+          <a:xfrm>
+            <a:off x="6563097" y="4081760"/>
+            <a:ext cx="2073697" cy="202481"/>
+          </a:xfrm>
+          <a:prstGeom prst="rect">
+            <a:avLst/>
+          </a:prstGeom>
+          <a:noFill/>
+          <a:ln/>
+        </p:spPr>
+        <p:txBody>
+          <a:bodyPr wrap="square" lIns="0" tIns="0" rIns="0" bIns="0" rtlCol="0" anchor="t"/>
+          <a:lstStyle/>
+          <a:p>
+            <a:pPr algn="l" indent="0" marL="0">
+              <a:lnSpc>
+                <a:spcPts val="797"/>
+              </a:lnSpc>
+              <a:buNone/>
+            </a:pPr>
+            <a:r>
+              <a:rPr lang="en-US" sz="800" i="1" dirty="0">
+                <a:solidFill>
+                  <a:srgbClr val="333333"/>
+                </a:solidFill>
+                <a:latin typeface="Carlito" pitchFamily="34" charset="0"/>
+                <a:ea typeface="Carlito" pitchFamily="34" charset="-122"/>
+                <a:cs typeface="Carlito" pitchFamily="34" charset="-120"/>
+              </a:rPr>
+              <a:t>Qwen-Next Preview: Inside the Roadmap with the Qwen Leadership Team</a:t>
+            </a:r>
+            <a:endParaRPr lang="en-US" sz="800" dirty="0"/>
+          </a:p>
+        </p:txBody>
+      </p:sp>
+      <p:sp>
+        <p:nvSpPr>
+          <p:cNvPr id="65" name="Shape 57"/>
           <p:cNvSpPr/>
           <p:nvPr/>
         </p:nvSpPr>
@@ -7772,7 +8409,7 @@
       </p:sp>
       <p:sp>
         <p:nvSpPr>
-          <p:cNvPr id="48" name="Text 40"/>
+          <p:cNvPr id="66" name="Text 58"/>
           <p:cNvSpPr/>
           <p:nvPr/>
         </p:nvSpPr>
@@ -7816,7 +8453,7 @@
       </p:sp>
       <p:sp>
         <p:nvSpPr>
-          <p:cNvPr id="49" name="Text 41"/>
+          <p:cNvPr id="67" name="Text 59"/>
           <p:cNvSpPr/>
           <p:nvPr/>
         </p:nvSpPr>
@@ -7850,7 +8487,7 @@
                 <a:ea typeface="Carlito" pitchFamily="34" charset="-122"/>
                 <a:cs typeface="Carlito" pitchFamily="34" charset="-120"/>
               </a:rPr>
-              <a:t>Themed around frontier LLMs — Qwen, GPT-5, Claude, Gemini, Llama, Multi-Model</a:t>
+              <a:t>All themed around the Qwen family — Qwen-Max, Qwen-VL-Max, Qwen-Coder, Qwen3, Qwen-Agent, Qwen-Next</a:t>
             </a:r>
             <a:endParaRPr lang="en-US" sz="800" dirty="0"/>
           </a:p>
@@ -7858,7 +8495,7 @@
       </p:sp>
       <p:sp>
         <p:nvSpPr>
-          <p:cNvPr id="50" name="Shape 42"/>
+          <p:cNvPr id="68" name="Shape 60"/>
           <p:cNvSpPr/>
           <p:nvPr/>
         </p:nvSpPr>
@@ -7881,23 +8518,23 @@
       </p:sp>
       <p:sp>
         <p:nvSpPr>
-          <p:cNvPr id="51" name="Text 43"/>
+          <p:cNvPr id="69" name="Text 61"/>
           <p:cNvSpPr/>
           <p:nvPr/>
         </p:nvSpPr>
         <p:spPr>
           <a:xfrm>
             <a:off x="3321844" y="4541416"/>
-            <a:ext cx="2607469" cy="91440"/>
-          </a:xfrm>
-          <a:prstGeom prst="rect">
-            <a:avLst/>
-          </a:prstGeom>
-          <a:noFill/>
-          <a:ln/>
-        </p:spPr>
-        <p:txBody>
-          <a:bodyPr wrap="none" lIns="0" tIns="0" rIns="0" bIns="0" rtlCol="0" anchor="t">
+            <a:ext cx="2717197" cy="91440"/>
+          </a:xfrm>
+          <a:prstGeom prst="rect">
+            <a:avLst/>
+          </a:prstGeom>
+          <a:noFill/>
+          <a:ln/>
+        </p:spPr>
+        <p:txBody>
+          <a:bodyPr wrap="square" lIns="0" tIns="0" rIns="0" bIns="0" rtlCol="0" anchor="t">
             <a:normAutofit/>
           </a:bodyPr>
           <a:lstStyle/>
@@ -7917,7 +8554,7 @@
                 <a:ea typeface="Liberation Sans Narrow" pitchFamily="34" charset="-122"/>
                 <a:cs typeface="Liberation Sans Narrow" pitchFamily="34" charset="-120"/>
               </a:rPr>
-              <a:t>$32K+ IN COMMUNITY PERKS</a:t>
+              <a:t>6 DEDICATED SESSIONS · 1 PER EVENT</a:t>
             </a:r>
             <a:endParaRPr lang="en-US" sz="800" dirty="0"/>
           </a:p>
@@ -7925,14 +8562,14 @@
       </p:sp>
       <p:sp>
         <p:nvSpPr>
-          <p:cNvPr id="52" name="Text 44"/>
+          <p:cNvPr id="70" name="Text 62"/>
           <p:cNvSpPr/>
           <p:nvPr/>
         </p:nvSpPr>
         <p:spPr>
           <a:xfrm>
             <a:off x="3321844" y="4645000"/>
-            <a:ext cx="2607469" cy="142615"/>
+            <a:ext cx="2607469" cy="204267"/>
           </a:xfrm>
           <a:prstGeom prst="rect">
             <a:avLst/>
@@ -7951,7 +8588,7 @@
               <a:buNone/>
             </a:pPr>
             <a:r>
-              <a:rPr lang="en-US" sz="619" dirty="0">
+              <a:rPr lang="en-US" sz="800" dirty="0">
                 <a:solidFill>
                   <a:srgbClr val="555555"/>
                 </a:solidFill>
@@ -7959,15 +8596,15 @@
                 <a:ea typeface="Carlito" pitchFamily="34" charset="-122"/>
                 <a:cs typeface="Carlito" pitchFamily="34" charset="-120"/>
               </a:rPr>
-              <a:t>Early API access, credits, fine-tuning compute, and platform seats</a:t>
-            </a:r>
-            <a:endParaRPr lang="en-US" sz="619" dirty="0"/>
-          </a:p>
-        </p:txBody>
-      </p:sp>
-      <p:sp>
-        <p:nvSpPr>
-          <p:cNvPr id="53" name="Shape 45"/>
+              <a:t>AliExpress technical speakers deliver the keynote session at every flagship</a:t>
+            </a:r>
+            <a:endParaRPr lang="en-US" sz="800" dirty="0"/>
+          </a:p>
+        </p:txBody>
+      </p:sp>
+      <p:sp>
+        <p:nvSpPr>
+          <p:cNvPr id="71" name="Shape 63"/>
           <p:cNvSpPr/>
           <p:nvPr/>
         </p:nvSpPr>
@@ -7990,7 +8627,7 @@
       </p:sp>
       <p:sp>
         <p:nvSpPr>
-          <p:cNvPr id="54" name="Text 46"/>
+          <p:cNvPr id="72" name="Text 64"/>
           <p:cNvSpPr/>
           <p:nvPr/>
         </p:nvSpPr>
@@ -8034,7 +8671,7 @@
       </p:sp>
       <p:sp>
         <p:nvSpPr>
-          <p:cNvPr id="55" name="Text 47"/>
+          <p:cNvPr id="73" name="Text 65"/>
           <p:cNvSpPr/>
           <p:nvPr/>
         </p:nvSpPr>
@@ -8076,7 +8713,7 @@
       </p:sp>
       <p:sp>
         <p:nvSpPr>
-          <p:cNvPr id="56" name="Text 48"/>
+          <p:cNvPr id="74" name="Text 66"/>
           <p:cNvSpPr/>
           <p:nvPr/>
         </p:nvSpPr>
@@ -8110,7 +8747,7 @@
                 <a:ea typeface="Carlito" pitchFamily="34" charset="-122"/>
                 <a:cs typeface="Carlito" pitchFamily="34" charset="-120"/>
               </a:rPr>
-              <a:t>12-MONTH ANNUAL PARTNERSHIP · LLM-THEMED CALENDAR</a:t>
+              <a:t>12-MONTH ANNUAL PARTNERSHIP · QWEN-EXCLUSIVE CALENDAR</a:t>
             </a:r>
             <a:endParaRPr lang="en-US" sz="800" dirty="0"/>
           </a:p>
@@ -8118,7 +8755,7 @@
       </p:sp>
       <p:sp>
         <p:nvSpPr>
-          <p:cNvPr id="57" name="Text 49"/>
+          <p:cNvPr id="75" name="Text 67"/>
           <p:cNvSpPr/>
           <p:nvPr/>
         </p:nvSpPr>
@@ -8160,7 +8797,7 @@
       </p:sp>
       <p:sp>
         <p:nvSpPr>
-          <p:cNvPr id="58" name="Text 50"/>
+          <p:cNvPr id="76" name="Text 68"/>
           <p:cNvSpPr/>
           <p:nvPr/>
         </p:nvSpPr>
@@ -8192,7 +8829,7 @@
       </p:sp>
       <p:sp>
         <p:nvSpPr>
-          <p:cNvPr id="59" name="Text 51"/>
+          <p:cNvPr id="77" name="Text 69"/>
           <p:cNvSpPr/>
           <p:nvPr/>
         </p:nvSpPr>
@@ -8232,48 +8869,40 @@
           </a:p>
         </p:txBody>
       </p:sp>
-      <p:sp>
-        <p:nvSpPr>
-          <p:cNvPr id="60" name="Text 52"/>
-          <p:cNvSpPr/>
-          <p:nvPr/>
-        </p:nvSpPr>
-        <p:spPr>
-          <a:xfrm>
-            <a:off x="2634459" y="1309083"/>
-            <a:ext cx="419517" cy="196025"/>
-          </a:xfrm>
-          <a:prstGeom prst="roundRect">
-            <a:avLst>
-              <a:gd name="adj" fmla="val 14577"/>
-            </a:avLst>
-          </a:prstGeom>
-          <a:solidFill>
-            <a:srgbClr val="6F42C1"/>
-          </a:solidFill>
-          <a:ln/>
-        </p:spPr>
-        <p:txBody>
-          <a:bodyPr wrap="square" rtlCol="0" anchor="ctr"/>
-          <a:lstStyle/>
-          <a:p>
-            <a:pPr indent="0" marL="0">
-              <a:buNone/>
-            </a:pPr>
-            <a:endParaRPr lang="en-US" dirty="0"/>
-          </a:p>
-        </p:txBody>
-      </p:sp>
-      <p:sp>
-        <p:nvSpPr>
-          <p:cNvPr id="61" name="Text 53"/>
-          <p:cNvSpPr/>
-          <p:nvPr/>
-        </p:nvSpPr>
-        <p:spPr>
-          <a:xfrm>
-            <a:off x="2649996" y="1319585"/>
-            <a:ext cx="388441" cy="175022"/>
+      <p:pic>
+        <p:nvPicPr>
+          <p:cNvPr id="78" name="Image 6" descr="preencoded.png">    </p:cNvPr>
+          <p:cNvPicPr>
+            <a:picLocks noChangeAspect="1"/>
+          </p:cNvPicPr>
+          <p:nvPr/>
+        </p:nvPicPr>
+        <p:blipFill>
+          <a:blip r:embed="rId7"/>
+          <a:stretch>
+            <a:fillRect/>
+          </a:stretch>
+        </p:blipFill>
+        <p:spPr>
+          <a:xfrm>
+            <a:off x="2438586" y="1319585"/>
+            <a:ext cx="599852" cy="175022"/>
+          </a:xfrm>
+          <a:prstGeom prst="rect">
+            <a:avLst/>
+          </a:prstGeom>
+        </p:spPr>
+      </p:pic>
+      <p:sp>
+        <p:nvSpPr>
+          <p:cNvPr id="79" name="Text 70"/>
+          <p:cNvSpPr/>
+          <p:nvPr/>
+        </p:nvSpPr>
+        <p:spPr>
+          <a:xfrm>
+            <a:off x="2438586" y="1319585"/>
+            <a:ext cx="599852" cy="175022"/>
           </a:xfrm>
           <a:prstGeom prst="rect">
             <a:avLst/>
@@ -8300,7 +8929,7 @@
                 <a:ea typeface="Carlito" pitchFamily="34" charset="-122"/>
                 <a:cs typeface="Carlito" pitchFamily="34" charset="-120"/>
               </a:rPr>
-              <a:t>Qwen</a:t>
+              <a:t>Qwen-Max</a:t>
             </a:r>
             <a:endParaRPr lang="en-US" sz="800" dirty="0"/>
           </a:p>
@@ -8308,14 +8937,14 @@
       </p:sp>
       <p:sp>
         <p:nvSpPr>
-          <p:cNvPr id="62" name="Text 54"/>
-          <p:cNvSpPr/>
-          <p:nvPr/>
-        </p:nvSpPr>
-        <p:spPr>
-          <a:xfrm>
-            <a:off x="500063" y="1451967"/>
-            <a:ext cx="2524088" cy="277749"/>
+          <p:cNvPr id="80" name="Text 71"/>
+          <p:cNvSpPr/>
+          <p:nvPr/>
+        </p:nvSpPr>
+        <p:spPr>
+          <a:xfrm>
+            <a:off x="500063" y="1310208"/>
+            <a:ext cx="2524088" cy="263298"/>
           </a:xfrm>
           <a:prstGeom prst="rect">
             <a:avLst/>
@@ -8336,12 +8965,12 @@
           <a:p>
             <a:pPr algn="l" indent="0" marL="0">
               <a:lnSpc>
-                <a:spcPts val="1013"/>
-              </a:lnSpc>
-              <a:buNone/>
-            </a:pPr>
-            <a:r>
-              <a:rPr lang="en-US" sz="844" b="1" spc="-8" kern="0" dirty="0">
+                <a:spcPts val="945"/>
+              </a:lnSpc>
+              <a:buNone/>
+            </a:pPr>
+            <a:r>
+              <a:rPr lang="en-US" sz="800" b="1" spc="-8" kern="0" dirty="0">
                 <a:solidFill>
                   <a:srgbClr val="FFFFFF"/>
                 </a:solidFill>
@@ -8349,15 +8978,15 @@
                 <a:ea typeface="Carlito" pitchFamily="34" charset="-122"/>
                 <a:cs typeface="Carlito" pitchFamily="34" charset="-120"/>
               </a:rPr>
-              <a:t>Qwen Unveiled — Agentic Commerce at Scale</a:t>
-            </a:r>
-            <a:endParaRPr lang="en-US" sz="844" dirty="0"/>
-          </a:p>
-        </p:txBody>
-      </p:sp>
-      <p:sp>
-        <p:nvSpPr>
-          <p:cNvPr id="63" name="Text 55"/>
+              <a:t>Qwen-Max Unveiled — Agentic Commerce at Scale</a:t>
+            </a:r>
+            <a:endParaRPr lang="en-US" sz="800" dirty="0"/>
+          </a:p>
+        </p:txBody>
+      </p:sp>
+      <p:sp>
+        <p:nvSpPr>
+          <p:cNvPr id="81" name="Text 72"/>
           <p:cNvSpPr/>
           <p:nvPr/>
         </p:nvSpPr>
@@ -8391,7 +9020,7 @@
       </p:sp>
       <p:sp>
         <p:nvSpPr>
-          <p:cNvPr id="64" name="Text 56"/>
+          <p:cNvPr id="82" name="Text 73"/>
           <p:cNvSpPr/>
           <p:nvPr/>
         </p:nvSpPr>
@@ -8431,48 +9060,40 @@
           </a:p>
         </p:txBody>
       </p:sp>
-      <p:sp>
-        <p:nvSpPr>
-          <p:cNvPr id="65" name="Text 57"/>
-          <p:cNvSpPr/>
-          <p:nvPr/>
-        </p:nvSpPr>
-        <p:spPr>
-          <a:xfrm>
-            <a:off x="5449351" y="1301940"/>
-            <a:ext cx="421687" cy="196025"/>
-          </a:xfrm>
-          <a:prstGeom prst="roundRect">
-            <a:avLst>
-              <a:gd name="adj" fmla="val 14577"/>
-            </a:avLst>
-          </a:prstGeom>
-          <a:solidFill>
-            <a:srgbClr val="10A37F"/>
-          </a:solidFill>
-          <a:ln/>
-        </p:spPr>
-        <p:txBody>
-          <a:bodyPr wrap="square" rtlCol="0" anchor="ctr"/>
-          <a:lstStyle/>
-          <a:p>
-            <a:pPr indent="0" marL="0">
-              <a:buNone/>
-            </a:pPr>
-            <a:endParaRPr lang="en-US" dirty="0"/>
-          </a:p>
-        </p:txBody>
-      </p:sp>
-      <p:sp>
-        <p:nvSpPr>
-          <p:cNvPr id="66" name="Text 58"/>
-          <p:cNvSpPr/>
-          <p:nvPr/>
-        </p:nvSpPr>
-        <p:spPr>
-          <a:xfrm>
-            <a:off x="5464969" y="1312441"/>
-            <a:ext cx="390451" cy="175022"/>
+      <p:pic>
+        <p:nvPicPr>
+          <p:cNvPr id="83" name="Image 7" descr="preencoded.png">    </p:cNvPr>
+          <p:cNvPicPr>
+            <a:picLocks noChangeAspect="1"/>
+          </p:cNvPicPr>
+          <p:nvPr/>
+        </p:nvPicPr>
+        <p:blipFill>
+          <a:blip r:embed="rId8"/>
+          <a:stretch>
+            <a:fillRect/>
+          </a:stretch>
+        </p:blipFill>
+        <p:spPr>
+          <a:xfrm>
+            <a:off x="5120171" y="1312441"/>
+            <a:ext cx="735248" cy="175022"/>
+          </a:xfrm>
+          <a:prstGeom prst="rect">
+            <a:avLst/>
+          </a:prstGeom>
+        </p:spPr>
+      </p:pic>
+      <p:sp>
+        <p:nvSpPr>
+          <p:cNvPr id="84" name="Text 74"/>
+          <p:cNvSpPr/>
+          <p:nvPr/>
+        </p:nvSpPr>
+        <p:spPr>
+          <a:xfrm>
+            <a:off x="5111550" y="1312441"/>
+            <a:ext cx="752490" cy="175022"/>
           </a:xfrm>
           <a:prstGeom prst="rect">
             <a:avLst/>
@@ -8495,11 +9116,11 @@
                 <a:solidFill>
                   <a:srgbClr val="FFFFFF"/>
                 </a:solidFill>
-                <a:latin typeface="Liberation Sans Narrow" pitchFamily="34" charset="0"/>
-                <a:ea typeface="Liberation Sans Narrow" pitchFamily="34" charset="-122"/>
-                <a:cs typeface="Liberation Sans Narrow" pitchFamily="34" charset="-120"/>
-              </a:rPr>
-              <a:t>GPT-5</a:t>
+                <a:latin typeface="Carlito" pitchFamily="34" charset="0"/>
+                <a:ea typeface="Carlito" pitchFamily="34" charset="-122"/>
+                <a:cs typeface="Carlito" pitchFamily="34" charset="-120"/>
+              </a:rPr>
+              <a:t>Qwen-VL-Max</a:t>
             </a:r>
             <a:endParaRPr lang="en-US" sz="800" dirty="0"/>
           </a:p>
@@ -8507,14 +9128,14 @@
       </p:sp>
       <p:sp>
         <p:nvSpPr>
-          <p:cNvPr id="67" name="Text 59"/>
-          <p:cNvSpPr/>
-          <p:nvPr/>
-        </p:nvSpPr>
-        <p:spPr>
-          <a:xfrm>
-            <a:off x="3302757" y="1702668"/>
-            <a:ext cx="2733828" cy="138875"/>
+          <p:cNvPr id="85" name="Text 75"/>
+          <p:cNvSpPr/>
+          <p:nvPr/>
+        </p:nvSpPr>
+        <p:spPr>
+          <a:xfrm>
+            <a:off x="3302757" y="1317352"/>
+            <a:ext cx="2538375" cy="263298"/>
           </a:xfrm>
           <a:prstGeom prst="rect">
             <a:avLst/>
@@ -8535,28 +9156,28 @@
           <a:p>
             <a:pPr algn="l" indent="0" marL="0">
               <a:lnSpc>
-                <a:spcPts val="1013"/>
-              </a:lnSpc>
-              <a:buNone/>
-            </a:pPr>
-            <a:r>
-              <a:rPr lang="en-US" sz="844" b="1" spc="-8" kern="0" dirty="0">
+                <a:spcPts val="945"/>
+              </a:lnSpc>
+              <a:buNone/>
+            </a:pPr>
+            <a:r>
+              <a:rPr lang="en-US" sz="800" b="1" spc="-8" kern="0" dirty="0">
                 <a:solidFill>
                   <a:srgbClr val="FFFFFF"/>
                 </a:solidFill>
-                <a:latin typeface="Liberation Sans Narrow" pitchFamily="34" charset="0"/>
-                <a:ea typeface="Liberation Sans Narrow" pitchFamily="34" charset="-122"/>
-                <a:cs typeface="Liberation Sans Narrow" pitchFamily="34" charset="-120"/>
-              </a:rPr>
-              <a:t>GPT-5 Frontier — Reasoning &amp; Agents</a:t>
-            </a:r>
-            <a:endParaRPr lang="en-US" sz="844" dirty="0"/>
-          </a:p>
-        </p:txBody>
-      </p:sp>
-      <p:sp>
-        <p:nvSpPr>
-          <p:cNvPr id="68" name="Text 60"/>
+                <a:latin typeface="Carlito" pitchFamily="34" charset="0"/>
+                <a:ea typeface="Carlito" pitchFamily="34" charset="-122"/>
+                <a:cs typeface="Carlito" pitchFamily="34" charset="-120"/>
+              </a:rPr>
+              <a:t>Visual Commerce — From Search to Multimodal Discovery</a:t>
+            </a:r>
+            <a:endParaRPr lang="en-US" sz="800" dirty="0"/>
+          </a:p>
+        </p:txBody>
+      </p:sp>
+      <p:sp>
+        <p:nvSpPr>
+          <p:cNvPr id="86" name="Text 76"/>
           <p:cNvSpPr/>
           <p:nvPr/>
         </p:nvSpPr>
@@ -8590,7 +9211,7 @@
       </p:sp>
       <p:sp>
         <p:nvSpPr>
-          <p:cNvPr id="69" name="Text 61"/>
+          <p:cNvPr id="87" name="Text 77"/>
           <p:cNvSpPr/>
           <p:nvPr/>
         </p:nvSpPr>
@@ -8630,48 +9251,40 @@
           </a:p>
         </p:txBody>
       </p:sp>
-      <p:sp>
-        <p:nvSpPr>
-          <p:cNvPr id="70" name="Text 62"/>
-          <p:cNvSpPr/>
-          <p:nvPr/>
-        </p:nvSpPr>
-        <p:spPr>
-          <a:xfrm>
-            <a:off x="8206365" y="1301940"/>
-            <a:ext cx="476658" cy="196025"/>
-          </a:xfrm>
-          <a:prstGeom prst="roundRect">
-            <a:avLst>
-              <a:gd name="adj" fmla="val 14577"/>
-            </a:avLst>
-          </a:prstGeom>
-          <a:solidFill>
-            <a:srgbClr val="D97757"/>
-          </a:solidFill>
-          <a:ln/>
-        </p:spPr>
-        <p:txBody>
-          <a:bodyPr wrap="square" rtlCol="0" anchor="ctr"/>
-          <a:lstStyle/>
-          <a:p>
-            <a:pPr indent="0" marL="0">
-              <a:buNone/>
-            </a:pPr>
-            <a:endParaRPr lang="en-US" dirty="0"/>
-          </a:p>
-        </p:txBody>
-      </p:sp>
-      <p:sp>
-        <p:nvSpPr>
-          <p:cNvPr id="71" name="Text 63"/>
-          <p:cNvSpPr/>
-          <p:nvPr/>
-        </p:nvSpPr>
-        <p:spPr>
-          <a:xfrm>
-            <a:off x="8224019" y="1312441"/>
-            <a:ext cx="441350" cy="175022"/>
+      <p:pic>
+        <p:nvPicPr>
+          <p:cNvPr id="88" name="Image 8" descr="preencoded.png">    </p:cNvPr>
+          <p:cNvPicPr>
+            <a:picLocks noChangeAspect="1"/>
+          </p:cNvPicPr>
+          <p:nvPr/>
+        </p:nvPicPr>
+        <p:blipFill>
+          <a:blip r:embed="rId9"/>
+          <a:stretch>
+            <a:fillRect/>
+          </a:stretch>
+        </p:blipFill>
+        <p:spPr>
+          <a:xfrm>
+            <a:off x="7989057" y="1312441"/>
+            <a:ext cx="676312" cy="175022"/>
+          </a:xfrm>
+          <a:prstGeom prst="rect">
+            <a:avLst/>
+          </a:prstGeom>
+        </p:spPr>
+      </p:pic>
+      <p:sp>
+        <p:nvSpPr>
+          <p:cNvPr id="89" name="Text 78"/>
+          <p:cNvSpPr/>
+          <p:nvPr/>
+        </p:nvSpPr>
+        <p:spPr>
+          <a:xfrm>
+            <a:off x="7989057" y="1312441"/>
+            <a:ext cx="676312" cy="175022"/>
           </a:xfrm>
           <a:prstGeom prst="rect">
             <a:avLst/>
@@ -8698,7 +9311,7 @@
                 <a:ea typeface="Carlito" pitchFamily="34" charset="-122"/>
                 <a:cs typeface="Carlito" pitchFamily="34" charset="-120"/>
               </a:rPr>
-              <a:t>Claude</a:t>
+              <a:t>Qwen-Coder</a:t>
             </a:r>
             <a:endParaRPr lang="en-US" sz="800" dirty="0"/>
           </a:p>
@@ -8706,14 +9319,14 @@
       </p:sp>
       <p:sp>
         <p:nvSpPr>
-          <p:cNvPr id="72" name="Text 64"/>
-          <p:cNvSpPr/>
-          <p:nvPr/>
-        </p:nvSpPr>
-        <p:spPr>
-          <a:xfrm>
-            <a:off x="6112594" y="1574081"/>
-            <a:ext cx="2538487" cy="277749"/>
+          <p:cNvPr id="90" name="Text 79"/>
+          <p:cNvSpPr/>
+          <p:nvPr/>
+        </p:nvSpPr>
+        <p:spPr>
+          <a:xfrm>
+            <a:off x="6112594" y="1317352"/>
+            <a:ext cx="2538487" cy="263298"/>
           </a:xfrm>
           <a:prstGeom prst="rect">
             <a:avLst/>
@@ -8734,12 +9347,12 @@
           <a:p>
             <a:pPr algn="l" indent="0" marL="0">
               <a:lnSpc>
-                <a:spcPts val="1013"/>
-              </a:lnSpc>
-              <a:buNone/>
-            </a:pPr>
-            <a:r>
-              <a:rPr lang="en-US" sz="844" b="1" spc="-8" kern="0" dirty="0">
+                <a:spcPts val="945"/>
+              </a:lnSpc>
+              <a:buNone/>
+            </a:pPr>
+            <a:r>
+              <a:rPr lang="en-US" sz="800" b="1" spc="-8" kern="0" dirty="0">
                 <a:solidFill>
                   <a:srgbClr val="FFFFFF"/>
                 </a:solidFill>
@@ -8747,15 +9360,15 @@
                 <a:ea typeface="Carlito" pitchFamily="34" charset="-122"/>
                 <a:cs typeface="Carlito" pitchFamily="34" charset="-120"/>
               </a:rPr>
-              <a:t>Claude Code Live — 200K Context Workshop</a:t>
-            </a:r>
-            <a:endParaRPr lang="en-US" sz="844" dirty="0"/>
-          </a:p>
-        </p:txBody>
-      </p:sp>
-      <p:sp>
-        <p:nvSpPr>
-          <p:cNvPr id="73" name="Text 65"/>
+              <a:t>Qwen-Coder Live — Building Commerce-Aware Agents</a:t>
+            </a:r>
+            <a:endParaRPr lang="en-US" sz="800" dirty="0"/>
+          </a:p>
+        </p:txBody>
+      </p:sp>
+      <p:sp>
+        <p:nvSpPr>
+          <p:cNvPr id="91" name="Text 80"/>
           <p:cNvSpPr/>
           <p:nvPr/>
         </p:nvSpPr>
@@ -8789,7 +9402,7 @@
       </p:sp>
       <p:sp>
         <p:nvSpPr>
-          <p:cNvPr id="74" name="Text 66"/>
+          <p:cNvPr id="92" name="Text 81"/>
           <p:cNvSpPr/>
           <p:nvPr/>
         </p:nvSpPr>
@@ -8829,48 +9442,40 @@
           </a:p>
         </p:txBody>
       </p:sp>
-      <p:sp>
-        <p:nvSpPr>
-          <p:cNvPr id="75" name="Text 67"/>
-          <p:cNvSpPr/>
-          <p:nvPr/>
-        </p:nvSpPr>
-        <p:spPr>
-          <a:xfrm>
-            <a:off x="2579961" y="2916427"/>
-            <a:ext cx="483529" cy="196025"/>
-          </a:xfrm>
-          <a:prstGeom prst="roundRect">
-            <a:avLst>
-              <a:gd name="adj" fmla="val 14577"/>
-            </a:avLst>
-          </a:prstGeom>
-          <a:solidFill>
-            <a:srgbClr val="4285F4"/>
-          </a:solidFill>
-          <a:ln/>
-        </p:spPr>
-        <p:txBody>
-          <a:bodyPr wrap="square" rtlCol="0" anchor="ctr"/>
-          <a:lstStyle/>
-          <a:p>
-            <a:pPr indent="0" marL="0">
-              <a:buNone/>
-            </a:pPr>
-            <a:endParaRPr lang="en-US" dirty="0"/>
-          </a:p>
-        </p:txBody>
-      </p:sp>
-      <p:sp>
-        <p:nvSpPr>
-          <p:cNvPr id="76" name="Text 68"/>
-          <p:cNvSpPr/>
-          <p:nvPr/>
-        </p:nvSpPr>
-        <p:spPr>
-          <a:xfrm>
-            <a:off x="2597869" y="2926928"/>
-            <a:ext cx="447712" cy="175022"/>
+      <p:pic>
+        <p:nvPicPr>
+          <p:cNvPr id="93" name="Image 9" descr="preencoded.png">    </p:cNvPr>
+          <p:cNvPicPr>
+            <a:picLocks noChangeAspect="1"/>
+          </p:cNvPicPr>
+          <p:nvPr/>
+        </p:nvPicPr>
+        <p:blipFill>
+          <a:blip r:embed="rId10"/>
+          <a:stretch>
+            <a:fillRect/>
+          </a:stretch>
+        </p:blipFill>
+        <p:spPr>
+          <a:xfrm>
+            <a:off x="2347503" y="2926928"/>
+            <a:ext cx="698078" cy="175022"/>
+          </a:xfrm>
+          <a:prstGeom prst="rect">
+            <a:avLst/>
+          </a:prstGeom>
+        </p:spPr>
+      </p:pic>
+      <p:sp>
+        <p:nvSpPr>
+          <p:cNvPr id="94" name="Text 82"/>
+          <p:cNvSpPr/>
+          <p:nvPr/>
+        </p:nvSpPr>
+        <p:spPr>
+          <a:xfrm>
+            <a:off x="2347503" y="2926928"/>
+            <a:ext cx="698078" cy="175022"/>
           </a:xfrm>
           <a:prstGeom prst="rect">
             <a:avLst/>
@@ -8893,11 +9498,11 @@
                 <a:solidFill>
                   <a:srgbClr val="FFFFFF"/>
                 </a:solidFill>
-                <a:latin typeface="Carlito" pitchFamily="34" charset="0"/>
-                <a:ea typeface="Carlito" pitchFamily="34" charset="-122"/>
-                <a:cs typeface="Carlito" pitchFamily="34" charset="-120"/>
-              </a:rPr>
-              <a:t>Gemini</a:t>
+                <a:latin typeface="Liberation Sans Narrow" pitchFamily="34" charset="0"/>
+                <a:ea typeface="Liberation Sans Narrow" pitchFamily="34" charset="-122"/>
+                <a:cs typeface="Liberation Sans Narrow" pitchFamily="34" charset="-120"/>
+              </a:rPr>
+              <a:t>Qwen3 Open</a:t>
             </a:r>
             <a:endParaRPr lang="en-US" sz="800" dirty="0"/>
           </a:p>
@@ -8905,14 +9510,14 @@
       </p:sp>
       <p:sp>
         <p:nvSpPr>
-          <p:cNvPr id="77" name="Text 69"/>
-          <p:cNvSpPr/>
-          <p:nvPr/>
-        </p:nvSpPr>
-        <p:spPr>
-          <a:xfrm>
-            <a:off x="492919" y="3317156"/>
-            <a:ext cx="2733828" cy="138875"/>
+          <p:cNvPr id="95" name="Text 83"/>
+          <p:cNvSpPr/>
+          <p:nvPr/>
+        </p:nvSpPr>
+        <p:spPr>
+          <a:xfrm>
+            <a:off x="492919" y="2931840"/>
+            <a:ext cx="2538375" cy="263298"/>
           </a:xfrm>
           <a:prstGeom prst="rect">
             <a:avLst/>
@@ -8933,12 +9538,12 @@
           <a:p>
             <a:pPr algn="l" indent="0" marL="0">
               <a:lnSpc>
-                <a:spcPts val="1013"/>
-              </a:lnSpc>
-              <a:buNone/>
-            </a:pPr>
-            <a:r>
-              <a:rPr lang="en-US" sz="844" b="1" spc="-8" kern="0" dirty="0">
+                <a:spcPts val="945"/>
+              </a:lnSpc>
+              <a:buNone/>
+            </a:pPr>
+            <a:r>
+              <a:rPr lang="en-US" sz="800" b="1" spc="-8" kern="0" dirty="0">
                 <a:solidFill>
                   <a:srgbClr val="FFFFFF"/>
                 </a:solidFill>
@@ -8946,15 +9551,15 @@
                 <a:ea typeface="Carlito" pitchFamily="34" charset="-122"/>
                 <a:cs typeface="Carlito" pitchFamily="34" charset="-120"/>
               </a:rPr>
-              <a:t>Gemini Multimodal — Vision + Vertex AI</a:t>
-            </a:r>
-            <a:endParaRPr lang="en-US" sz="844" dirty="0"/>
-          </a:p>
-        </p:txBody>
-      </p:sp>
-      <p:sp>
-        <p:nvSpPr>
-          <p:cNvPr id="78" name="Text 70"/>
+              <a:t>Qwen3 Open Lab — Fine-Tune for Israeli Retail &amp; Hebrew</a:t>
+            </a:r>
+            <a:endParaRPr lang="en-US" sz="800" dirty="0"/>
+          </a:p>
+        </p:txBody>
+      </p:sp>
+      <p:sp>
+        <p:nvSpPr>
+          <p:cNvPr id="96" name="Text 84"/>
           <p:cNvSpPr/>
           <p:nvPr/>
         </p:nvSpPr>
@@ -8988,7 +9593,7 @@
       </p:sp>
       <p:sp>
         <p:nvSpPr>
-          <p:cNvPr id="79" name="Text 71"/>
+          <p:cNvPr id="97" name="Text 85"/>
           <p:cNvSpPr/>
           <p:nvPr/>
         </p:nvSpPr>
@@ -9028,48 +9633,40 @@
           </a:p>
         </p:txBody>
       </p:sp>
-      <p:sp>
-        <p:nvSpPr>
-          <p:cNvPr id="80" name="Text 72"/>
-          <p:cNvSpPr/>
-          <p:nvPr/>
-        </p:nvSpPr>
-        <p:spPr>
-          <a:xfrm>
-            <a:off x="5351606" y="2916427"/>
-            <a:ext cx="523190" cy="196025"/>
-          </a:xfrm>
-          <a:prstGeom prst="roundRect">
-            <a:avLst>
-              <a:gd name="adj" fmla="val 14577"/>
-            </a:avLst>
-          </a:prstGeom>
-          <a:solidFill>
-            <a:srgbClr val="0467DF"/>
-          </a:solidFill>
-          <a:ln/>
-        </p:spPr>
-        <p:txBody>
-          <a:bodyPr wrap="square" rtlCol="0" anchor="ctr"/>
-          <a:lstStyle/>
-          <a:p>
-            <a:pPr indent="0" marL="0">
-              <a:buNone/>
-            </a:pPr>
-            <a:endParaRPr lang="en-US" dirty="0"/>
-          </a:p>
-        </p:txBody>
-      </p:sp>
-      <p:sp>
-        <p:nvSpPr>
-          <p:cNvPr id="81" name="Text 73"/>
-          <p:cNvSpPr/>
-          <p:nvPr/>
-        </p:nvSpPr>
-        <p:spPr>
-          <a:xfrm>
-            <a:off x="5370984" y="2926928"/>
-            <a:ext cx="484436" cy="175022"/>
+      <p:pic>
+        <p:nvPicPr>
+          <p:cNvPr id="98" name="Image 10" descr="preencoded.png">    </p:cNvPr>
+          <p:cNvPicPr>
+            <a:picLocks noChangeAspect="1"/>
+          </p:cNvPicPr>
+          <p:nvPr/>
+        </p:nvPicPr>
+        <p:blipFill>
+          <a:blip r:embed="rId11"/>
+          <a:stretch>
+            <a:fillRect/>
+          </a:stretch>
+        </p:blipFill>
+        <p:spPr>
+          <a:xfrm>
+            <a:off x="5175200" y="2926928"/>
+            <a:ext cx="680219" cy="175022"/>
+          </a:xfrm>
+          <a:prstGeom prst="rect">
+            <a:avLst/>
+          </a:prstGeom>
+        </p:spPr>
+      </p:pic>
+      <p:sp>
+        <p:nvSpPr>
+          <p:cNvPr id="99" name="Text 86"/>
+          <p:cNvSpPr/>
+          <p:nvPr/>
+        </p:nvSpPr>
+        <p:spPr>
+          <a:xfrm>
+            <a:off x="5175200" y="2926928"/>
+            <a:ext cx="680219" cy="175022"/>
           </a:xfrm>
           <a:prstGeom prst="rect">
             <a:avLst/>
@@ -9092,11 +9689,11 @@
                 <a:solidFill>
                   <a:srgbClr val="FFFFFF"/>
                 </a:solidFill>
-                <a:latin typeface="Liberation Sans Narrow" pitchFamily="34" charset="0"/>
-                <a:ea typeface="Liberation Sans Narrow" pitchFamily="34" charset="-122"/>
-                <a:cs typeface="Liberation Sans Narrow" pitchFamily="34" charset="-120"/>
-              </a:rPr>
-              <a:t>Llama 4</a:t>
+                <a:latin typeface="Carlito" pitchFamily="34" charset="0"/>
+                <a:ea typeface="Carlito" pitchFamily="34" charset="-122"/>
+                <a:cs typeface="Carlito" pitchFamily="34" charset="-120"/>
+              </a:rPr>
+              <a:t>Qwen-Agent</a:t>
             </a:r>
             <a:endParaRPr lang="en-US" sz="800" dirty="0"/>
           </a:p>
@@ -9104,14 +9701,14 @@
       </p:sp>
       <p:sp>
         <p:nvSpPr>
-          <p:cNvPr id="82" name="Text 74"/>
-          <p:cNvSpPr/>
-          <p:nvPr/>
-        </p:nvSpPr>
-        <p:spPr>
-          <a:xfrm>
-            <a:off x="3302757" y="3317156"/>
-            <a:ext cx="2733828" cy="138875"/>
+          <p:cNvPr id="100" name="Text 87"/>
+          <p:cNvSpPr/>
+          <p:nvPr/>
+        </p:nvSpPr>
+        <p:spPr>
+          <a:xfrm>
+            <a:off x="3302757" y="3051832"/>
+            <a:ext cx="2733828" cy="131649"/>
           </a:xfrm>
           <a:prstGeom prst="rect">
             <a:avLst/>
@@ -9132,12 +9729,12 @@
           <a:p>
             <a:pPr algn="l" indent="0" marL="0">
               <a:lnSpc>
-                <a:spcPts val="1013"/>
-              </a:lnSpc>
-              <a:buNone/>
-            </a:pPr>
-            <a:r>
-              <a:rPr lang="en-US" sz="844" b="1" spc="-8" kern="0" dirty="0">
+                <a:spcPts val="945"/>
+              </a:lnSpc>
+              <a:buNone/>
+            </a:pPr>
+            <a:r>
+              <a:rPr lang="en-US" sz="800" b="1" spc="-8" kern="0" dirty="0">
                 <a:solidFill>
                   <a:srgbClr val="FFFFFF"/>
                 </a:solidFill>
@@ -9145,15 +9742,15 @@
                 <a:ea typeface="Carlito" pitchFamily="34" charset="-122"/>
                 <a:cs typeface="Carlito" pitchFamily="34" charset="-120"/>
               </a:rPr>
-              <a:t>Llama Open Lab — Fine-Tune Your Own</a:t>
-            </a:r>
-            <a:endParaRPr lang="en-US" sz="844" dirty="0"/>
-          </a:p>
-        </p:txBody>
-      </p:sp>
-      <p:sp>
-        <p:nvSpPr>
-          <p:cNvPr id="83" name="Text 75"/>
+              <a:t>Agentic Ops — Qwen-Agent in Production</a:t>
+            </a:r>
+            <a:endParaRPr lang="en-US" sz="800" dirty="0"/>
+          </a:p>
+        </p:txBody>
+      </p:sp>
+      <p:sp>
+        <p:nvSpPr>
+          <p:cNvPr id="101" name="Text 88"/>
           <p:cNvSpPr/>
           <p:nvPr/>
         </p:nvSpPr>
@@ -9187,7 +9784,7 @@
       </p:sp>
       <p:sp>
         <p:nvSpPr>
-          <p:cNvPr id="84" name="Text 76"/>
+          <p:cNvPr id="102" name="Text 89"/>
           <p:cNvSpPr/>
           <p:nvPr/>
         </p:nvSpPr>
@@ -9229,22 +9826,22 @@
       </p:sp>
       <p:pic>
         <p:nvPicPr>
-          <p:cNvPr id="85" name="Image 6" descr="preencoded.png">    </p:cNvPr>
+          <p:cNvPr id="103" name="Image 11" descr="preencoded.png">    </p:cNvPr>
           <p:cNvPicPr>
             <a:picLocks noChangeAspect="1"/>
           </p:cNvPicPr>
           <p:nvPr/>
         </p:nvPicPr>
         <p:blipFill>
-          <a:blip r:embed="rId7"/>
+          <a:blip r:embed="rId12"/>
           <a:stretch>
             <a:fillRect/>
           </a:stretch>
         </p:blipFill>
         <p:spPr>
           <a:xfrm>
-            <a:off x="8004237" y="2926928"/>
-            <a:ext cx="661132" cy="175022"/>
+            <a:off x="8040960" y="2926928"/>
+            <a:ext cx="624408" cy="175022"/>
           </a:xfrm>
           <a:prstGeom prst="rect">
             <a:avLst/>
@@ -9253,14 +9850,14 @@
       </p:pic>
       <p:sp>
         <p:nvSpPr>
-          <p:cNvPr id="86" name="Text 77"/>
-          <p:cNvSpPr/>
-          <p:nvPr/>
-        </p:nvSpPr>
-        <p:spPr>
-          <a:xfrm>
-            <a:off x="7966350" y="2926928"/>
-            <a:ext cx="736905" cy="175022"/>
+          <p:cNvPr id="104" name="Text 90"/>
+          <p:cNvSpPr/>
+          <p:nvPr/>
+        </p:nvSpPr>
+        <p:spPr>
+          <a:xfrm>
+            <a:off x="8040960" y="2926928"/>
+            <a:ext cx="624408" cy="175022"/>
           </a:xfrm>
           <a:prstGeom prst="rect">
             <a:avLst/>
@@ -9287,7 +9884,7 @@
                 <a:ea typeface="Carlito" pitchFamily="34" charset="-122"/>
                 <a:cs typeface="Carlito" pitchFamily="34" charset="-120"/>
               </a:rPr>
-              <a:t>Multi-Model</a:t>
+              <a:t>Qwen-Next</a:t>
             </a:r>
             <a:endParaRPr lang="en-US" sz="800" dirty="0"/>
           </a:p>
@@ -9295,14 +9892,14 @@
       </p:sp>
       <p:sp>
         <p:nvSpPr>
-          <p:cNvPr id="87" name="Text 78"/>
-          <p:cNvSpPr/>
-          <p:nvPr/>
-        </p:nvSpPr>
-        <p:spPr>
-          <a:xfrm>
-            <a:off x="6112594" y="3317156"/>
-            <a:ext cx="2733940" cy="138875"/>
+          <p:cNvPr id="105" name="Text 91"/>
+          <p:cNvSpPr/>
+          <p:nvPr/>
+        </p:nvSpPr>
+        <p:spPr>
+          <a:xfrm>
+            <a:off x="6112594" y="3051832"/>
+            <a:ext cx="2733940" cy="131649"/>
           </a:xfrm>
           <a:prstGeom prst="rect">
             <a:avLst/>
@@ -9323,12 +9920,12 @@
           <a:p>
             <a:pPr algn="l" indent="0" marL="0">
               <a:lnSpc>
-                <a:spcPts val="1013"/>
-              </a:lnSpc>
-              <a:buNone/>
-            </a:pPr>
-            <a:r>
-              <a:rPr lang="en-US" sz="844" b="1" spc="-8" kern="0" dirty="0">
+                <a:spcPts val="945"/>
+              </a:lnSpc>
+              <a:buNone/>
+            </a:pPr>
+            <a:r>
+              <a:rPr lang="en-US" sz="800" b="1" spc="-8" kern="0" dirty="0">
                 <a:solidFill>
                   <a:srgbClr val="FFFFFF"/>
                 </a:solidFill>
@@ -9336,9 +9933,9 @@
                 <a:ea typeface="Liberation Sans Narrow" pitchFamily="34" charset="-122"/>
                 <a:cs typeface="Liberation Sans Narrow" pitchFamily="34" charset="-120"/>
               </a:rPr>
-              <a:t>Year-Cap Summit — The 2027 Roadmap</a:t>
-            </a:r>
-            <a:endParaRPr lang="en-US" sz="844" dirty="0"/>
+              <a:t>Year-Cap — The 2027 Qwen Roadmap</a:t>
+            </a:r>
+            <a:endParaRPr lang="en-US" sz="800" dirty="0"/>
           </a:p>
         </p:txBody>
       </p:sp>

</xml_diff>